<commit_message>
docs(defense): shorten slide text to fragments, restore notes to a real script
Bullets and card text cut to phrases — nobody reads full sentences off
a slide. The explanation that used to live there moved to the speaker
notes instead, rewritten as 3-5 sentences of formal academic prose per
slide: enough context to orient a listener, short of a transcript.
Notes had been cut to single cue-sentences in the prior revision and
lost necessary context; this rebalances both directions at once.
</commit_message>
<xml_diff>
--- a/thesis 1/defense/SynapseOS_Proposal_Defense.pptx
+++ b/thesis 1/defense/SynapseOS_Proposal_Defense.pptx
@@ -1124,7 +1124,7 @@
           <a:p>
             <a:r>
               <a:rPr lang="en-US" dirty="0"/>
-              <a:t>This is a proposal defense for SynapseOS, Chapters 1 through 3 — the research plan, not final results, since the user study hasn't run yet.</a:t>
+              <a:t>Good [morning/afternoon], panel. We present the Thesis 1 proposal for SynapseOS, a conversational interface layer for personal computing, developed to let a person operate a Linux desktop in ordinary language rather than through memorized commands or a fixed menu of GUI actions. This defense addresses the research plan and methodology set out in Chapters 1 through 3; the comparative user study itself has not yet been conducted, so our results today are necessarily preliminary, not final. We will walk through the research gap motivating this work, our two independent research contributions, how each will be evaluated, our current progress against the proposed timeline, and, finally, one open question we want to raise ourselves before the panel does.</a:t>
             </a:r>
             <a:endParaRPr lang="en-US" dirty="0"/>
           </a:p>
@@ -1212,7 +1212,7 @@
           <a:p>
             <a:r>
               <a:rPr lang="en-US" dirty="0"/>
-              <a:t>The pattern list silently loses data 41% of the time; the fail-closed list and our algorithm are both exactly zero.</a:t>
+              <a:t>Out of the 405 commands in our held-out corpus that touch something outside the filesystem or lose data outright, the existing pattern list allows silent data loss in 41.2 percent of cases — a figure that, in a real deployment, represents irreversible harm the user was never even asked to accept. Both the fail-closed list and our algorithm reduce that figure to exactly zero. This equivalence is itself an important, somewhat counterintuitive finding: on the silent-loss metric alone, the two safe approaches are statistically indistinguishable, which tells us directly that the verdict a system reaches is not, by itself, the contribution worth claiming.</a:t>
             </a:r>
             <a:endParaRPr lang="en-US" dirty="0"/>
           </a:p>
@@ -1300,7 +1300,7 @@
           <a:p>
             <a:r>
               <a:rPr lang="en-US" dirty="0"/>
-              <a:t>Our algorithm restores 89.5% of executable losses; the fail-closed list restores none, by construction — it only ever asks, never captures.</a:t>
+              <a:t>Silent-loss safety is necessary but not sufficient — a system that simply refuses everything it does not recognize is equally safe by that measure, yet protects nothing. This second chart is where the approaches actually separate: of the 325 commands in our corpus that do lose something recoverable, the fail-closed list restores none of them, by construction, since it never attempts capture at all. Our algorithm, by contrast, restores 89.5 percent of those losses, with every restoration independently verified by executing the command in a sandbox and comparing the resulting filesystem tree. We want to be transparent that this result comes from a single held-out round with a single annotator; a second annotator and a larger corpus remain open work, tracked explicitly in our documentation rather than left implicit.</a:t>
             </a:r>
             <a:endParaRPr lang="en-US" dirty="0"/>
           </a:p>
@@ -1388,7 +1388,7 @@
           <a:p>
             <a:r>
               <a:rPr lang="en-US" dirty="0"/>
-              <a:t>Within-subjects against each participant's own OS — the gap between fluent-in-neither and fluent-in-both participants is the primary outcome.</a:t>
+              <a:t>The comparative study follows a within-subjects design, meaning every participant serves as their own control, evaluated against whichever operating system they already use daily — Windows, macOS, or Linux. We deliberately recruit two distinct populations: individuals fluent in neither the command line nor the graphical desktop, and individuals fluent in both. The gap between these two populations, rather than the raw performance of either group in isolation, is our primary outcome of interest, because it is the most direct test of our central hypothesis. Task performance is measured using the OSWorld benchmark together with a custom cross-platform task suite we developed, while subjective experience is captured through the System Usability Scale, the NASA Task Load Index, and a semi-structured post-study interview.</a:t>
             </a:r>
             <a:endParaRPr lang="en-US" dirty="0"/>
           </a:p>
@@ -1476,7 +1476,7 @@
           <a:p>
             <a:r>
               <a:rPr lang="en-US" dirty="0"/>
-              <a:t>Our adviser's own written feedback said, verbatim, to manage scope carefully — this is our answer, in writing, not just a verbal reassurance.</a:t>
+              <a:t>Our adviser's own written feedback on an earlier draft instructed us, in those exact words, to manage our scope carefully — a fair concern, given that this proposal combines algorithm development, corpus construction, interface engineering, and a controlled user study within a single undergraduate thesis. Our response is a written, explicit priority ordering rather than a vague reassurance: the recoverability algorithm and the GUI-mode session launch, which together constitute the distribution we intend to ship, are treated as the mandatory deliverable. Model fine-tuning details and the full forty-participant comparative study remain real, planned work, but they are explicitly the first components we would scale back if our timeline comes under pressure. This ordering reflects priority, not ambition — we are not abandoning either track, only stating plainly which one yields first.</a:t>
             </a:r>
             <a:endParaRPr lang="en-US" dirty="0"/>
           </a:p>
@@ -1564,7 +1564,7 @@
           <a:p>
             <a:r>
               <a:rPr lang="en-US" dirty="0"/>
-              <a:t>Ethics is the real bottleneck — instruments are drafted, but the application itself hasn't been submitted yet, so it's being prioritized now.</a:t>
+              <a:t>As of today, the algorithm track is essentially complete, with round seven standing as our reported, frozen result. The build track — the runtime and the GUI-mode session launch — remains actively in progress. The genuine bottleneck is ethics: our study instruments are fully drafted, but the institutional review board application itself has not yet been submitted. Because IRB turnaround is the least controllable variable in our entire timeline, we are prioritizing its submission now, in parallel with remaining build work, rather than sequencing it afterward.</a:t>
             </a:r>
             <a:endParaRPr lang="en-US" dirty="0"/>
           </a:p>
@@ -1652,7 +1652,7 @@
           <a:p>
             <a:r>
               <a:rPr lang="en-US" dirty="0"/>
-              <a:t>We're naming this ourselves rather than having it asked cold — we have a concrete plan to turn the prose answer into a measured number.</a:t>
+              <a:t>We would rather raise this question ourselves than have it put to us cold, because our adviser has in fact already asked it, in an earlier review, and it deserves a direct answer rather than an evasive one. At present, our answer is a prose argument rather than a measured number: we contend that the per-command rule table underlying the algorithm is itself simply a list, comparable in kind to the baseline we compare against, and that what we actually claim credit for is what the algorithm builds on top of that table — composition through wrappers, and resolution of run-time targets. We have not yet isolated the rule table's own contribution as an explicit ablation, and we say so plainly rather than let the panel discover the gap on their own. Our concrete plan to close it: add a flag to the analyzer that routes all wrapper and composition handling to an opaque fallback instead of resolving through it, run that configuration as a fourth comparison column against the same held-out corpus, and report whatever delta results — a scoped, well-defined next step, not an open-ended promise.</a:t>
             </a:r>
             <a:endParaRPr lang="en-US" dirty="0"/>
           </a:p>
@@ -1740,7 +1740,7 @@
           <a:p>
             <a:r>
               <a:rPr lang="en-US" dirty="0"/>
-              <a:t>Either contribution stands on its own if the other slips — that independence was a deliberate scope decision, not an accident.</a:t>
+              <a:t>Should both evaluations proceed as designed, SynapseOS will have produced two genuinely independent contributions. The first is a recoverability algorithm, measurably safer and more useful than the pattern-matching approach it extends, evaluated entirely without human participants. The second, pending institutional approval, is the first controlled empirical evidence addressing whether a conversational interface actually narrows the gap between users fluent in the command line and users fluent in neither existing interface. Critically, each contribution stands on its own merit even if the other is delayed or scaled back — that mutual independence was a deliberate decision made early in this project's design, not a fortunate accident discovered later.</a:t>
             </a:r>
             <a:endParaRPr lang="en-US" dirty="0"/>
           </a:p>
@@ -1828,7 +1828,7 @@
           <a:p>
             <a:r>
               <a:rPr lang="en-US" dirty="0"/>
-              <a:t>Open floor for questions.</a:t>
+              <a:t>We welcome the panel's questions, and thank you for your time and consideration.</a:t>
             </a:r>
             <a:endParaRPr lang="en-US" dirty="0"/>
           </a:p>
@@ -1916,7 +1916,7 @@
           <a:p>
             <a:r>
               <a:rPr lang="en-US" dirty="0"/>
-              <a:t>Nobody has built and evaluated a conversational layer over the full Linux desktop session — that's the gap we're targeting.</a:t>
+              <a:t>The command line can, in principle, express nearly any operation a computer supports, but only for someone fluent enough to write the syntax. The graphical desktop removed that syntactic barrier, but replaced it with a different one: a user can only do what the interface's designers anticipated and built a control for. Large language models have reopened a research thread that is, in fact, decades old — the Berkeley UNIX Consultant demonstrated a working natural-language interface to Unix as early as 1988 — but with substantially greater capability than was available then. What remains missing, despite this renewed interest, is an implemented and empirically evaluated system that places a conversational layer over the entire Linux desktop session, rather than over the shell alone or a single application; that is precisely the gap this study addresses.</a:t>
             </a:r>
             <a:endParaRPr lang="en-US" dirty="0"/>
           </a:p>
@@ -2004,7 +2004,7 @@
           <a:p>
             <a:r>
               <a:rPr lang="en-US" dirty="0"/>
-              <a:t>Direct from Chapter 1 — the frame for everything that follows.</a:t>
+              <a:t>This statement captures the thesis's central premise: a computer's functional capability does not change between the command line and the graphical desktop, but a person's ability to reach that capability does, depending entirely on which interface they happen to be fluent in. SynapseOS proposes a third interface — natural language — specifically because it is the one mode of expression most people already possess, regardless of technical background. Chapters 1 through 3 of this proposal exist to argue that such an interface can be built, and, more importantly, that its value can be measured rather than merely asserted.</a:t>
             </a:r>
             <a:endParaRPr lang="en-US" dirty="0"/>
           </a:p>
@@ -2092,7 +2092,7 @@
           <a:p>
             <a:r>
               <a:rPr lang="en-US" dirty="0"/>
-              <a:t>RQ1 moved to the front after an earlier adviser review asked whether any contribution would survive without the interface — objectives mirror these four one-to-one.</a:t>
+              <a:t>These four research questions were deliberately reordered following an earlier review, in which our adviser posed a pointed test: if the conversational interface were removed entirely, would any research contribution survive? For the manuscript as it then stood, the honest answer was no. In response, we restructured the proposal so that the recoverability algorithm now leads as RQ1, standing as an independent, corpus-evaluated contribution that requires no human participants at all. Research Questions 2 through 4 remain the interface questions, and these are what the 40-participant comparative study is designed to answer. Our four research objectives mirror these questions one-to-one, so satisfying each objective directly answers its corresponding question.</a:t>
             </a:r>
             <a:endParaRPr lang="en-US" dirty="0"/>
           </a:p>
@@ -2180,7 +2180,7 @@
           <a:p>
             <a:r>
               <a:rPr lang="en-US" dirty="0"/>
-              <a:t>SynapseOS instantiates this pipeline directly, and the recoverability algorithm lives at the Action layer.</a:t>
+              <a:t>This four-layer pipeline — Input, Reasoning, Action, and Operating-System Integration — is the organizing framework developed in Chapter 2's review of the literature. It proved diagnostic in practice: nearly every surveyed system's principal limitation could be located at exactly one of these four layers, which is what makes the framework useful rather than merely descriptive. SynapseOS instantiates the pipeline directly — natural language enters at Input, a locally-hosted small language model reasons over it, the resulting shell commands execute at the Action layer, and the system spans the full graphical session rather than a single application at the Operating-System Integration layer. The recoverability algorithm that answers RQ1 lives specifically within the Action layer: it is the mechanism that decides, before anything executes, whether a command is safe to run outright or must first be confirmed.</a:t>
             </a:r>
             <a:endParaRPr lang="en-US" dirty="0"/>
           </a:p>
@@ -2268,7 +2268,7 @@
           <a:p>
             <a:r>
               <a:rPr lang="en-US" dirty="0"/>
-              <a:t>Placeholder for a real recorded exchange — this already runs today, on real hardware.</a:t>
+              <a:t>This slide is a placeholder for a recorded, verified terminal session, which we will substitute once captured. What it will show, concretely, is a plain-English request typed by a user, the shell command SynapseOS generates in response, the confirmation gate intervening before anything irreversible occurs, and the resulting output. We include this here deliberately, ahead of the algorithm's technical details, to make one point plain before anything else: this system already runs, today, on real hardware, and is not merely a design on paper.</a:t>
             </a:r>
             <a:endParaRPr lang="en-US" dirty="0"/>
           </a:p>
@@ -2356,7 +2356,7 @@
           <a:p>
             <a:r>
               <a:rPr lang="en-US" dirty="0"/>
-              <a:t>A pattern list judges a command by its name, not its effect — the naive safe fix is safe but useless.</a:t>
+              <a:t>Allowing a language model to act on a real filesystem introduces a risk the interface layer alone cannot resolve: a generated command may destroy data before its author has any opportunity to review it. The conventional safeguard — matching a command against an enumerated list of known-dangerous patterns — judges the command by its surface form, its name, rather than by what it will actually do, so a disguised or simply unfamiliar variant of a dangerous operation passes through undetected. The naive alternative, refusing every command the list does not recognize, is safe in the narrow sense but practically useless: it protects nothing and interrupts the user constantly. What this study proposes instead is a third approach — an algorithm that understands a command's effects well enough, before execution, to know specifically what it will change.</a:t>
             </a:r>
             <a:endParaRPr lang="en-US" dirty="0"/>
           </a:p>
@@ -2444,7 +2444,7 @@
           <a:p>
             <a:r>
               <a:rPr lang="en-US" dirty="0"/>
-              <a:t>Two abilities only, deliberately narrow — anything the analysis doesn't model is unknown and fails closed.</a:t>
+              <a:t>The algorithm's claim is deliberately narrow, and that narrowness is itself a design decision rather than a limitation we are apologizing for. It claims exactly two abilities: composition through wrappers, meaning it sees through constructs such as find -exec, xargs, shell loops, command and process substitution, pipelines, and sudo, treating earlier segments of a line as visible context for later ones; and resolution of run-time targets, meaning that where a target is computed only at execution time, a read-only dry run establishes the concrete targets in advance, so a capture plan can be built before anything actually runs. Commands with explicit, statically-named targets remain the responsibility of the existing pattern list, which already handled them adequately in our pilot work. Anything the analysis does not model is simply treated as unknown, and unknown fails closed by design — the system asks for confirmation and captures nothing, rather than guessing. We want to be explicit that we are not claiming to have solved recoverability in general; we are claiming these two specific abilities, and measuring them against baselines.</a:t>
             </a:r>
             <a:endParaRPr lang="en-US" dirty="0"/>
           </a:p>
@@ -2532,7 +2532,7 @@
           <a:p>
             <a:r>
               <a:rPr lang="en-US" dirty="0"/>
-              <a:t>Two independent contributions, reported separately because they're established separately — no participants for RQ1, 40 for RQ2 through 4.</a:t>
+              <a:t>We report the algorithm study and the user study as two genuinely independent contributions, because they are established through entirely separate evidence. The algorithm study requires no human participants at all: it is evaluated against a held-out corpus of generated commands, with ground truth established by sandboxed execution rather than human judgment, compared across the existing pattern list, that same list made to fail closed, and our algorithm. The user study, by contrast, follows a classical within-subjects design, comparing each of 40 participants against the operating system they already use daily, with task performance measured through OSWorld and a custom cross-platform suite, and subjective experience measured through the System Usability Scale and the NASA Task Load Index. That second study is the one still awaiting institutional ethics approval before it can proceed.</a:t>
             </a:r>
             <a:endParaRPr lang="en-US" dirty="0"/>
           </a:p>
@@ -4008,7 +4008,7 @@
                 <a:ea typeface="Calibri" pitchFamily="34" charset="-122"/>
                 <a:cs typeface="Calibri" pitchFamily="34" charset="-120"/>
               </a:rPr>
-              <a:t>Within-subjects: each of 40 participants against their own primary OS (Windows, macOS, or Linux)</a:t>
+              <a:t>Within-subjects: 40 participants vs. their own primary OS</a:t>
             </a:r>
             <a:endParaRPr lang="en-US" sz="1900" dirty="0"/>
           </a:p>
@@ -4029,7 +4029,7 @@
                 <a:ea typeface="Calibri" pitchFamily="34" charset="-122"/>
                 <a:cs typeface="Calibri" pitchFamily="34" charset="-120"/>
               </a:rPr>
-              <a:t>Two populations: fluent in neither interface, and fluent in both — the gap between them is the primary outcome</a:t>
+              <a:t>Two populations: fluent in neither interface, fluent in both</a:t>
             </a:r>
             <a:endParaRPr lang="en-US" sz="1900" dirty="0"/>
           </a:p>
@@ -4050,7 +4050,7 @@
                 <a:ea typeface="Calibri" pitchFamily="34" charset="-122"/>
                 <a:cs typeface="Calibri" pitchFamily="34" charset="-120"/>
               </a:rPr>
-              <a:t>Tasks: OSWorld benchmark + a custom cross-platform suite (file search, system monitoring, package management, text/data processing)</a:t>
+              <a:t>Tasks: OSWorld benchmark + custom cross-platform suite</a:t>
             </a:r>
             <a:endParaRPr lang="en-US" sz="1900" dirty="0"/>
           </a:p>
@@ -4071,7 +4071,7 @@
                 <a:ea typeface="Calibri" pitchFamily="34" charset="-122"/>
                 <a:cs typeface="Calibri" pitchFamily="34" charset="-120"/>
               </a:rPr>
-              <a:t>Measures: completion time, error rate, SUS, NASA-TLX, plus a semi-structured interview</a:t>
+              <a:t>Measures: completion time, error rate, SUS, NASA-TLX, interview</a:t>
             </a:r>
             <a:endParaRPr lang="en-US" sz="1900" dirty="0"/>
           </a:p>
@@ -4243,7 +4243,7 @@
               <a:buNone/>
             </a:pPr>
             <a:r>
-              <a:rPr lang="en-US" sz="1800" b="1" dirty="0">
+              <a:rPr lang="en-US" sz="1900" b="1" dirty="0">
                 <a:solidFill>
                   <a:schemeClr val="accent2"/>
                 </a:solidFill>
@@ -4254,14 +4254,14 @@
               <a:t>Responding directly to “manage scope carefully”:
 </a:t>
             </a:r>
-            <a:endParaRPr lang="en-US" sz="1800" dirty="0"/>
+            <a:endParaRPr lang="en-US" sz="1900" dirty="0"/>
           </a:p>
           <a:p>
             <a:pPr indent="0" marL="0">
               <a:buNone/>
             </a:pPr>
             <a:r>
-              <a:rPr lang="en-US" sz="1700" dirty="0">
+              <a:rPr lang="en-US" sz="1800" dirty="0">
                 <a:solidFill>
                   <a:schemeClr val="bg1"/>
                 </a:solidFill>
@@ -4269,9 +4269,9 @@
                 <a:ea typeface="Calibri" pitchFamily="34" charset="-122"/>
                 <a:cs typeface="Calibri" pitchFamily="34" charset="-120"/>
               </a:rPr>
-              <a:t>the algorithm and the GUI-mode session launch are the mandatory deliverable. Model fine-tuning and the full comparative study are real and still planned, but the first things to shrink if time runs out.</a:t>
-            </a:r>
-            <a:endParaRPr lang="en-US" sz="1800" dirty="0"/>
+              <a:t>Algorithm + GUI-mode launch — mandatory. Model fine-tuning + full comparative study — real, but first to shrink.</a:t>
+            </a:r>
+            <a:endParaRPr lang="en-US" sz="1900" dirty="0"/>
           </a:p>
         </p:txBody>
       </p:sp>
@@ -4300,7 +4300,7 @@
               <a:buNone/>
             </a:pPr>
             <a:r>
-              <a:rPr lang="en-US" sz="1600" i="1" dirty="0">
+              <a:rPr lang="en-US" sz="1800" i="1" dirty="0">
                 <a:solidFill>
                   <a:schemeClr val="bg2"/>
                 </a:solidFill>
@@ -4308,9 +4308,9 @@
                 <a:ea typeface="Calibri" pitchFamily="34" charset="-122"/>
                 <a:cs typeface="Calibri" pitchFamily="34" charset="-120"/>
               </a:rPr>
-              <a:t>That reorder of priority — not of ambition — is our written answer to the adviser's own scope concern from an earlier review.</a:t>
-            </a:r>
-            <a:endParaRPr lang="en-US" sz="1600" dirty="0"/>
+              <a:t>A reorder of priority, not of ambition.</a:t>
+            </a:r>
+            <a:endParaRPr lang="en-US" sz="1800" dirty="0"/>
           </a:p>
         </p:txBody>
       </p:sp>
@@ -5062,7 +5062,7 @@
                   <a:schemeClr val="bg1"/>
                 </a:solidFill>
               </a:rPr>
-              <a:t>This is a question our adviser already asked, in an earlier review</a:t>
+              <a:t>Already asked once, by our adviser</a:t>
             </a:r>
             <a:endParaRPr lang="en-US" sz="1700" dirty="0"/>
           </a:p>
@@ -5080,7 +5080,7 @@
                   <a:schemeClr val="bg1"/>
                 </a:solidFill>
               </a:rPr>
-              <a:t>Current answer: a prose argument — the rule table is itself a list; composition and target resolution are what's built on top of it</a:t>
+              <a:t>Current answer: a prose argument — the rule table is itself a list</a:t>
             </a:r>
             <a:endParaRPr lang="en-US" sz="1700" dirty="0"/>
           </a:p>
@@ -5098,7 +5098,7 @@
                   <a:schemeClr val="bg1"/>
                 </a:solidFill>
               </a:rPr>
-              <a:t>Not yet a number — no ablation has isolated the rule table's own contribution</a:t>
+              <a:t>Not yet a number — no ablation performed</a:t>
             </a:r>
             <a:endParaRPr lang="en-US" sz="1700" dirty="0"/>
           </a:p>
@@ -5116,7 +5116,7 @@
                   <a:schemeClr val="bg1"/>
                 </a:solidFill>
               </a:rPr>
-              <a:t>Plan to close it: an analyzer flag that routes composition/wrapper handling to “opaque”, run as a fourth comparison column against the same corpus</a:t>
+              <a:t>Plan: analyzer flag → opaque fallback → fourth corpus column</a:t>
             </a:r>
             <a:endParaRPr lang="en-US" sz="1700" dirty="0"/>
           </a:p>
@@ -5352,7 +5352,7 @@
               <a:buNone/>
             </a:pPr>
             <a:r>
-              <a:rPr lang="en-US" sz="1600" dirty="0">
+              <a:rPr lang="en-US" sz="1700" dirty="0">
                 <a:solidFill>
                   <a:schemeClr val="bg1"/>
                 </a:solidFill>
@@ -5360,9 +5360,9 @@
                 <a:ea typeface="Calibri" pitchFamily="34" charset="-122"/>
                 <a:cs typeface="Calibri" pitchFamily="34" charset="-120"/>
               </a:rPr>
-              <a:t>A composition- and resolution-aware recoverability algorithm, evaluated against two baselines on a held-out corpus</a:t>
-            </a:r>
-            <a:endParaRPr lang="en-US" sz="1600" dirty="0"/>
+              <a:t>Composition- and resolution-aware algorithm, evaluated against two baselines</a:t>
+            </a:r>
+            <a:endParaRPr lang="en-US" sz="1700" dirty="0"/>
           </a:p>
         </p:txBody>
       </p:sp>
@@ -5452,7 +5452,7 @@
               <a:buNone/>
             </a:pPr>
             <a:r>
-              <a:rPr lang="en-US" sz="1600" dirty="0">
+              <a:rPr lang="en-US" sz="1700" dirty="0">
                 <a:solidFill>
                   <a:schemeClr val="bg1"/>
                 </a:solidFill>
@@ -5460,9 +5460,9 @@
                 <a:ea typeface="Calibri" pitchFamily="34" charset="-122"/>
                 <a:cs typeface="Calibri" pitchFamily="34" charset="-120"/>
               </a:rPr>
-              <a:t>A conversational interface layer with a reversibility-based confirmation gate and undo, over an unchanged Linux desktop</a:t>
-            </a:r>
-            <a:endParaRPr lang="en-US" sz="1600" dirty="0"/>
+              <a:t>Interface layer with a reversibility-based confirmation gate and undo, over an unchanged desktop</a:t>
+            </a:r>
+            <a:endParaRPr lang="en-US" sz="1700" dirty="0"/>
           </a:p>
         </p:txBody>
       </p:sp>
@@ -5552,7 +5552,7 @@
               <a:buNone/>
             </a:pPr>
             <a:r>
-              <a:rPr lang="en-US" sz="1600" dirty="0">
+              <a:rPr lang="en-US" sz="1700" dirty="0">
                 <a:solidFill>
                   <a:schemeClr val="bg1"/>
                 </a:solidFill>
@@ -5560,9 +5560,9 @@
                 <a:ea typeface="Calibri" pitchFamily="34" charset="-122"/>
                 <a:cs typeface="Calibri" pitchFamily="34" charset="-120"/>
               </a:rPr>
-              <a:t>The first controlled evidence for whether conversation narrows the fluency gap between CLI and GUI users</a:t>
-            </a:r>
-            <a:endParaRPr lang="en-US" sz="1600" dirty="0"/>
+              <a:t>First controlled evidence on narrowing the CLI/GUI fluency gap</a:t>
+            </a:r>
+            <a:endParaRPr lang="en-US" sz="1700" dirty="0"/>
           </a:p>
         </p:txBody>
       </p:sp>
@@ -5856,7 +5856,7 @@
                 <a:ea typeface="Calibri" pitchFamily="34" charset="-122"/>
                 <a:cs typeface="Calibri" pitchFamily="34" charset="-120"/>
               </a:rPr>
-              <a:t>Nearly any operation a computer supports can be expressed on the command line — but only by someone who can write it</a:t>
+              <a:t>Command line — full capability, syntax barrier</a:t>
             </a:r>
             <a:endParaRPr lang="en-US" sz="1900" dirty="0"/>
           </a:p>
@@ -5877,7 +5877,7 @@
                 <a:ea typeface="Calibri" pitchFamily="34" charset="-122"/>
                 <a:cs typeface="Calibri" pitchFamily="34" charset="-120"/>
               </a:rPr>
-              <a:t>Everyone else is limited to what a graphical desktop's designers anticipated</a:t>
+              <a:t>Graphical desktop — limited to what designers anticipated</a:t>
             </a:r>
             <a:endParaRPr lang="en-US" sz="1900" dirty="0"/>
           </a:p>
@@ -5898,7 +5898,7 @@
                 <a:ea typeface="Calibri" pitchFamily="34" charset="-122"/>
                 <a:cs typeface="Calibri" pitchFamily="34" charset="-120"/>
               </a:rPr>
-              <a:t>LLMs have reopened a decades-old research thread (Berkeley UNIX Consultant, 1988) with far greater capability</a:t>
+              <a:t>LLMs reopen the thread (Berkeley UNIX Consultant, 1988) with far greater capability</a:t>
             </a:r>
             <a:endParaRPr lang="en-US" sz="1900" dirty="0"/>
           </a:p>
@@ -5919,7 +5919,7 @@
                 <a:ea typeface="Calibri" pitchFamily="34" charset="-122"/>
                 <a:cs typeface="Calibri" pitchFamily="34" charset="-120"/>
               </a:rPr>
-              <a:t>But no implemented, evaluated system places a conversational layer over the whole Linux desktop session — existing work covers only the shell, or only individual applications</a:t>
+              <a:t>Missing: an implemented, evaluated system for the whole Linux desktop session</a:t>
             </a:r>
             <a:endParaRPr lang="en-US" sz="1900" dirty="0"/>
           </a:p>
@@ -6047,12 +6047,12 @@
         </p:nvSpPr>
         <p:spPr>
           <a:xfrm>
-            <a:off x="914400" y="2011680"/>
-            <a:ext cx="10332720" cy="2560320"/>
+            <a:off x="1188720" y="2377440"/>
+            <a:ext cx="9784080" cy="1828800"/>
           </a:xfrm>
           <a:prstGeom prst="roundRect">
             <a:avLst>
-              <a:gd name="adj" fmla="val 3571"/>
+              <a:gd name="adj" fmla="val 5000"/>
             </a:avLst>
           </a:prstGeom>
           <a:solidFill>
@@ -6074,8 +6074,8 @@
         </p:nvSpPr>
         <p:spPr>
           <a:xfrm>
-            <a:off x="1280160" y="2286000"/>
-            <a:ext cx="9601200" cy="2011680"/>
+            <a:off x="1554480" y="2377440"/>
+            <a:ext cx="9052560" cy="1828800"/>
           </a:xfrm>
           <a:prstGeom prst="rect">
             <a:avLst/>
@@ -6091,7 +6091,7 @@
               <a:buNone/>
             </a:pPr>
             <a:r>
-              <a:rPr lang="en-US" sz="1900" i="1" dirty="0">
+              <a:rPr lang="en-US" sz="2400" i="1" dirty="0">
                 <a:solidFill>
                   <a:schemeClr val="bg1"/>
                 </a:solidFill>
@@ -6099,9 +6099,9 @@
                 <a:ea typeface="Calibri" pitchFamily="34" charset="-122"/>
                 <a:cs typeface="Calibri" pitchFamily="34" charset="-120"/>
               </a:rPr>
-              <a:t>The capability of a personal computer is unevenly reachable. This study addresses the absence of a conversational interface layer — one that accepts intent in ordinary language and carries it out through the standard system toolchain — that has been empirically evaluated against the conventional graphical workflow, specifically for whether it changes what people of differing technical fluency can accomplish.</a:t>
-            </a:r>
-            <a:endParaRPr lang="en-US" sz="1900" dirty="0"/>
+              <a:t>Computer capability is unevenly reachable — gated by which interface a person is fluent in.</a:t>
+            </a:r>
+            <a:endParaRPr lang="en-US" sz="2400" dirty="0"/>
           </a:p>
         </p:txBody>
       </p:sp>
@@ -6280,7 +6280,7 @@
               <a:buChar char="▸"/>
             </a:pPr>
             <a:r>
-              <a:rPr lang="en-US" sz="1800" dirty="0">
+              <a:rPr lang="en-US" sz="1900" dirty="0">
                 <a:solidFill>
                   <a:schemeClr val="bg1"/>
                 </a:solidFill>
@@ -6288,7 +6288,7 @@
                 <a:ea typeface="Calibri" pitchFamily="34" charset="-122"/>
                 <a:cs typeface="Calibri" pitchFamily="34" charset="-120"/>
               </a:rPr>
-              <a:t>RQ1 — Can we find what a generated command will do before it runs, and capture enough to undo it — losing less data and asking less often than a pattern list?</a:t>
+              <a:t>RQ1 — Predict a command's effects before it runs; capture enough to undo it; beat a pattern list</a:t>
             </a:r>
             <a:endParaRPr lang="en-US" sz="1900" dirty="0"/>
           </a:p>
@@ -6301,7 +6301,7 @@
               <a:buChar char="▸"/>
             </a:pPr>
             <a:r>
-              <a:rPr lang="en-US" sz="1800" dirty="0">
+              <a:rPr lang="en-US" sz="1900" dirty="0">
                 <a:solidFill>
                   <a:schemeClr val="bg1"/>
                 </a:solidFill>
@@ -6309,7 +6309,7 @@
                 <a:ea typeface="Calibri" pitchFamily="34" charset="-122"/>
                 <a:cs typeface="Calibri" pitchFamily="34" charset="-120"/>
               </a:rPr>
-              <a:t>RQ2 — How do we let someone direct a whole Linux desktop in ordinary language?</a:t>
+              <a:t>RQ2 — Direct a full Linux desktop in ordinary language</a:t>
             </a:r>
             <a:endParaRPr lang="en-US" sz="1900" dirty="0"/>
           </a:p>
@@ -6322,7 +6322,7 @@
               <a:buChar char="▸"/>
             </a:pPr>
             <a:r>
-              <a:rPr lang="en-US" sz="1800" dirty="0">
+              <a:rPr lang="en-US" sz="1900" dirty="0">
                 <a:solidFill>
                   <a:schemeClr val="bg1"/>
                 </a:solidFill>
@@ -6330,7 +6330,7 @@
                 <a:ea typeface="Calibri" pitchFamily="34" charset="-122"/>
                 <a:cs typeface="Calibri" pitchFamily="34" charset="-120"/>
               </a:rPr>
-              <a:t>RQ3 — What confirmation and recovery design lets a user undo a mistake, including one they approved themselves?</a:t>
+              <a:t>RQ3 — Confirm and recover from mistakes, including ones the user approved</a:t>
             </a:r>
             <a:endParaRPr lang="en-US" sz="1900" dirty="0"/>
           </a:p>
@@ -6343,7 +6343,7 @@
               <a:buChar char="▸"/>
             </a:pPr>
             <a:r>
-              <a:rPr lang="en-US" sz="1800" dirty="0">
+              <a:rPr lang="en-US" sz="1900" dirty="0">
                 <a:solidFill>
                   <a:schemeClr val="bg1"/>
                 </a:solidFill>
@@ -6351,7 +6351,7 @@
                 <a:ea typeface="Calibri" pitchFamily="34" charset="-122"/>
                 <a:cs typeface="Calibri" pitchFamily="34" charset="-120"/>
               </a:rPr>
-              <a:t>RQ4 — Does this narrow the gap for people fluent in neither the command line nor the GUI?</a:t>
+              <a:t>RQ4 — Narrow the fluency gap between CLI and GUI non-experts</a:t>
             </a:r>
             <a:endParaRPr lang="en-US" sz="1900" dirty="0"/>
           </a:p>
@@ -6426,7 +6426,7 @@
                 <a:ea typeface="Calibri" pitchFamily="34" charset="-122"/>
                 <a:cs typeface="Calibri" pitchFamily="34" charset="-120"/>
               </a:rPr>
-              <a:t>— the algorithm and the interface are two independent contributions, not one subordinate to the other.</a:t>
+              <a:t>— two independent contributions, not one subordinate to the other.</a:t>
             </a:r>
             <a:endParaRPr lang="en-US" sz="1500" dirty="0"/>
           </a:p>
@@ -6571,7 +6571,7 @@
               <a:buNone/>
             </a:pPr>
             <a:r>
-              <a:rPr lang="en-US" sz="1700" dirty="0">
+              <a:rPr lang="en-US" sz="1800" dirty="0">
                 <a:solidFill>
                   <a:schemeClr val="bg2"/>
                 </a:solidFill>
@@ -6579,9 +6579,9 @@
                 <a:ea typeface="Calibri" pitchFamily="34" charset="-122"/>
                 <a:cs typeface="Calibri" pitchFamily="34" charset="-120"/>
               </a:rPr>
-              <a:t>A four-layer pipeline, common to every language-mediated computing interface surveyed in Chapter 2:</a:t>
-            </a:r>
-            <a:endParaRPr lang="en-US" sz="1700" dirty="0"/>
+              <a:t>Four-layer pipeline, from Chapter 2's literature review:</a:t>
+            </a:r>
+            <a:endParaRPr lang="en-US" sz="1800" dirty="0"/>
           </a:p>
         </p:txBody>
       </p:sp>
@@ -7138,7 +7138,7 @@
               <a:buNone/>
             </a:pPr>
             <a:r>
-              <a:rPr lang="en-US" sz="1600" i="1" dirty="0">
+              <a:rPr lang="en-US" sz="1800" i="1" dirty="0">
                 <a:solidFill>
                   <a:schemeClr val="bg1"/>
                 </a:solidFill>
@@ -7146,9 +7146,9 @@
                 <a:ea typeface="Calibri" pitchFamily="34" charset="-122"/>
                 <a:cs typeface="Calibri" pitchFamily="34" charset="-120"/>
               </a:rPr>
-              <a:t>SynapseOS instantiates this pipeline directly — the recoverability algorithm (RQ1) is the part of the Action layer that decides what's safe to run without asking.</a:t>
-            </a:r>
-            <a:endParaRPr lang="en-US" sz="1600" dirty="0"/>
+              <a:t>SynapseOS instantiates this directly — the algorithm (RQ1) governs the Action layer.</a:t>
+            </a:r>
+            <a:endParaRPr lang="en-US" sz="1800" dirty="0"/>
           </a:p>
         </p:txBody>
       </p:sp>
@@ -7629,7 +7629,7 @@
                 <a:ea typeface="Calibri" pitchFamily="34" charset="-122"/>
                 <a:cs typeface="Calibri" pitchFamily="34" charset="-120"/>
               </a:rPr>
-              <a:t>A generated command can destroy data before its author ever reads it</a:t>
+              <a:t>Generated commands can destroy data silently</a:t>
             </a:r>
             <a:endParaRPr lang="en-US" sz="1900" dirty="0"/>
           </a:p>
@@ -7650,7 +7650,7 @@
                 <a:ea typeface="Calibri" pitchFamily="34" charset="-122"/>
                 <a:cs typeface="Calibri" pitchFamily="34" charset="-120"/>
               </a:rPr>
-              <a:t>Existing safeguards (an enumerated pattern list) judge a command by its name — not by what it actually does</a:t>
+              <a:t>Pattern lists judge a command by its name, not its effect</a:t>
             </a:r>
             <a:endParaRPr lang="en-US" sz="1900" dirty="0"/>
           </a:p>
@@ -7671,7 +7671,7 @@
                 <a:ea typeface="Calibri" pitchFamily="34" charset="-122"/>
                 <a:cs typeface="Calibri" pitchFamily="34" charset="-120"/>
               </a:rPr>
-              <a:t>A list either lets unfamiliar commands run (unsafe), or refuses everything it doesn't recognize (safe, but protects nothing and asks constantly)</a:t>
+              <a:t>Binary choice today: unsafe (let it through) or useless (refuse everything)</a:t>
             </a:r>
             <a:endParaRPr lang="en-US" sz="1900" dirty="0"/>
           </a:p>
@@ -7692,7 +7692,7 @@
                 <a:ea typeface="Calibri" pitchFamily="34" charset="-122"/>
                 <a:cs typeface="Calibri" pitchFamily="34" charset="-120"/>
               </a:rPr>
-              <a:t>We need a third option: understand the command well enough to know what it will change, before it runs</a:t>
+              <a:t>Needed: know the command's actual effect before it runs</a:t>
             </a:r>
             <a:endParaRPr lang="en-US" sz="1900" dirty="0"/>
           </a:p>
@@ -7903,7 +7903,7 @@
               <a:buNone/>
             </a:pPr>
             <a:r>
-              <a:rPr lang="en-US" sz="1500" dirty="0">
+              <a:rPr lang="en-US" sz="1600" dirty="0">
                 <a:solidFill>
                   <a:schemeClr val="bg1"/>
                 </a:solidFill>
@@ -7911,9 +7911,9 @@
                 <a:ea typeface="Calibri" pitchFamily="34" charset="-122"/>
                 <a:cs typeface="Calibri" pitchFamily="34" charset="-120"/>
               </a:rPr>
-              <a:t>Sees through find -exec, xargs, loops, command/process substitution, pipelines, redirects, sh -c, sudo and its relatives — earlier parts of a line are visible to later ones.</a:t>
-            </a:r>
-            <a:endParaRPr lang="en-US" sz="1500" dirty="0"/>
+              <a:t>find -exec, xargs, loops, substitution, pipelines, sudo — earlier segments visible to later ones</a:t>
+            </a:r>
+            <a:endParaRPr lang="en-US" sz="1600" dirty="0"/>
           </a:p>
         </p:txBody>
       </p:sp>
@@ -8008,7 +8008,7 @@
               <a:buNone/>
             </a:pPr>
             <a:r>
-              <a:rPr lang="en-US" sz="1500" dirty="0">
+              <a:rPr lang="en-US" sz="1600" dirty="0">
                 <a:solidFill>
                   <a:schemeClr val="bg1"/>
                 </a:solidFill>
@@ -8016,9 +8016,9 @@
                 <a:ea typeface="Calibri" pitchFamily="34" charset="-122"/>
                 <a:cs typeface="Calibri" pitchFamily="34" charset="-120"/>
               </a:rPr>
-              <a:t>Where a target is computed while the command runs (rm $(ls *.log), find -delete, xargs rm), a read-only dry run learns the concrete targets — so a capture plan can be built before anything executes.</a:t>
-            </a:r>
-            <a:endParaRPr lang="en-US" sz="1500" dirty="0"/>
+              <a:t>Targets computed at run time (rm $(ls *.log), find -delete, xargs rm) resolved via a read-only dry run before execution</a:t>
+            </a:r>
+            <a:endParaRPr lang="en-US" sz="1600" dirty="0"/>
           </a:p>
         </p:txBody>
       </p:sp>
@@ -8074,7 +8074,7 @@
               <a:buNone/>
             </a:pPr>
             <a:r>
-              <a:rPr lang="en-US" sz="1500" b="1" dirty="0">
+              <a:rPr lang="en-US" sz="1600" b="1" dirty="0">
                 <a:solidFill>
                   <a:schemeClr val="accent2"/>
                 </a:solidFill>
@@ -8088,7 +8088,7 @@
               <a:buNone/>
             </a:pPr>
             <a:r>
-              <a:rPr lang="en-US" sz="1500" dirty="0">
+              <a:rPr lang="en-US" sz="1600" dirty="0">
                 <a:solidFill>
                   <a:schemeClr val="bg1"/>
                 </a:solidFill>
@@ -8096,9 +8096,9 @@
                 <a:ea typeface="Calibri" pitchFamily="34" charset="-122"/>
                 <a:cs typeface="Calibri" pitchFamily="34" charset="-120"/>
               </a:rPr>
-              <a:t>a command the analysis doesn't model is unknown — and unknown fails closed. It asks, and captures nothing. No broader claim is made.</a:t>
-            </a:r>
-            <a:endParaRPr lang="en-US" sz="1500" dirty="0"/>
+              <a:t>unmodeled commands are unknown → fail closed, ask, capture nothing.</a:t>
+            </a:r>
+            <a:endParaRPr lang="en-US" sz="1600" dirty="0"/>
           </a:p>
         </p:txBody>
       </p:sp>
@@ -8514,7 +8514,7 @@
                   <a:schemeClr val="bg1"/>
                 </a:solidFill>
               </a:rPr>
-              <a:t>Held-out set of generated commands, ground truth from sandboxed execution</a:t>
+              <a:t>Held-out commands, sandboxed ground truth</a:t>
             </a:r>
             <a:endParaRPr lang="en-US" sz="1600" dirty="0"/>
           </a:p>
@@ -8532,7 +8532,7 @@
                   <a:schemeClr val="bg1"/>
                 </a:solidFill>
               </a:rPr>
-              <a:t>Three baselines compared: pattern list, fail-closed list, the algorithm</a:t>
+              <a:t>Three baselines: pattern list, fail-closed list, algorithm</a:t>
             </a:r>
             <a:endParaRPr lang="en-US" sz="1600" dirty="0"/>
           </a:p>
@@ -8550,7 +8550,7 @@
                   <a:schemeClr val="bg1"/>
                 </a:solidFill>
               </a:rPr>
-              <a:t>Answers RQ1 on its own</a:t>
+              <a:t>Answers RQ1 independently</a:t>
             </a:r>
             <a:endParaRPr lang="en-US" sz="1600" dirty="0"/>
           </a:p>
@@ -8674,7 +8674,7 @@
                   <a:schemeClr val="bg1"/>
                 </a:solidFill>
               </a:rPr>
-              <a:t>Each person vs. their own daily OS (expert baseline)</a:t>
+              <a:t>Each person vs. their own daily OS</a:t>
             </a:r>
             <a:endParaRPr lang="en-US" sz="1600" dirty="0"/>
           </a:p>
@@ -8692,7 +8692,7 @@
                   <a:schemeClr val="bg1"/>
                 </a:solidFill>
               </a:rPr>
-              <a:t>Task suite: OSWorld + custom cross-platform tasks</a:t>
+              <a:t>OSWorld + custom cross-platform task suite</a:t>
             </a:r>
             <a:endParaRPr lang="en-US" sz="1600" dirty="0"/>
           </a:p>
@@ -8710,7 +8710,7 @@
                   <a:schemeClr val="bg1"/>
                 </a:solidFill>
               </a:rPr>
-              <a:t>Waits on IRB / ethics approval</a:t>
+              <a:t>Pending IRB / ethics approval</a:t>
             </a:r>
             <a:endParaRPr lang="en-US" sz="1600" dirty="0"/>
           </a:p>

</xml_diff>

<commit_message>
docs(defense): shorten notes to plain-language cues, down from academic prose
3-5 sentence academic notes read like a paragraph per slide out loud —
too long for a live audience. Cut to 2-3 short sentences each, in
plain words instead of jargon (a safe test run, not a read-only dry
run; a lookup table, not an enumerated rule table), written as if the
audience is smart but not a specialist in this subfield.
</commit_message>
<xml_diff>
--- a/thesis 1/defense/SynapseOS_Proposal_Defense.pptx
+++ b/thesis 1/defense/SynapseOS_Proposal_Defense.pptx
@@ -1124,7 +1124,7 @@
           <a:p>
             <a:r>
               <a:rPr lang="en-US" dirty="0"/>
-              <a:t>Good [morning/afternoon], panel. We present the Thesis 1 proposal for SynapseOS, a conversational interface layer for personal computing, developed to let a person operate a Linux desktop in ordinary language rather than through memorized commands or a fixed menu of GUI actions. This defense addresses the research plan and methodology set out in Chapters 1 through 3; the comparative user study itself has not yet been conducted, so our results today are necessarily preliminary, not final. We will walk through the research gap motivating this work, our two independent research contributions, how each will be evaluated, our current progress against the proposed timeline, and, finally, one open question we want to raise ourselves before the panel does.</a:t>
+              <a:t>Good [morning/afternoon]. We're presenting our Thesis 1 proposal for SynapseOS — software that lets someone control a computer by typing plain English instead of memorized commands. This is a proposal defense, so we're presenting our plan, not final results — the comparison study with real users hasn't run yet.</a:t>
             </a:r>
             <a:endParaRPr lang="en-US" dirty="0"/>
           </a:p>
@@ -1212,7 +1212,7 @@
           <a:p>
             <a:r>
               <a:rPr lang="en-US" dirty="0"/>
-              <a:t>Out of the 405 commands in our held-out corpus that touch something outside the filesystem or lose data outright, the existing pattern list allows silent data loss in 41.2 percent of cases — a figure that, in a real deployment, represents irreversible harm the user was never even asked to accept. Both the fail-closed list and our algorithm reduce that figure to exactly zero. This equivalence is itself an important, somewhat counterintuitive finding: on the silent-loss metric alone, the two safe approaches are statistically indistinguishable, which tells us directly that the verdict a system reaches is not, by itself, the contribution worth claiming.</a:t>
+              <a:t>Out of several hundred risky commands we tested, today's safety list let data get silently destroyed over 40 percent of the time — damage the user never agreed to. Our algorithm, and a much stricter 'block everything unfamiliar' approach, both brought that down to essentially zero.</a:t>
             </a:r>
             <a:endParaRPr lang="en-US" dirty="0"/>
           </a:p>
@@ -1300,7 +1300,7 @@
           <a:p>
             <a:r>
               <a:rPr lang="en-US" dirty="0"/>
-              <a:t>Silent-loss safety is necessary but not sufficient — a system that simply refuses everything it does not recognize is equally safe by that measure, yet protects nothing. This second chart is where the approaches actually separate: of the 325 commands in our corpus that do lose something recoverable, the fail-closed list restores none of them, by construction, since it never attempts capture at all. Our algorithm, by contrast, restores 89.5 percent of those losses, with every restoration independently verified by executing the command in a sandbox and comparing the resulting filesystem tree. We want to be transparent that this result comes from a single held-out round with a single annotator; a second annotator and a larger corpus remain open work, tracked explicitly in our documentation rather than left implicit.</a:t>
+              <a:t>Being safe isn't enough on its own — a system that blocks everything is also 'safe', but useless, because it never actually saves anything. Our algorithm actually recovers the lost data about 9 times out of 10; the overly-cautious approach recovers none of it, because it never even tries.</a:t>
             </a:r>
             <a:endParaRPr lang="en-US" dirty="0"/>
           </a:p>
@@ -1388,7 +1388,7 @@
           <a:p>
             <a:r>
               <a:rPr lang="en-US" dirty="0"/>
-              <a:t>The comparative study follows a within-subjects design, meaning every participant serves as their own control, evaluated against whichever operating system they already use daily — Windows, macOS, or Linux. We deliberately recruit two distinct populations: individuals fluent in neither the command line nor the graphical desktop, and individuals fluent in both. The gap between these two populations, rather than the raw performance of either group in isolation, is our primary outcome of interest, because it is the most direct test of our central hypothesis. Task performance is measured using the OSWorld benchmark together with a custom cross-platform task suite we developed, while subjective experience is captured through the System Usability Scale, the NASA Task Load Index, and a semi-structured post-study interview.</a:t>
+              <a:t>We'll compare SynapseOS against whatever operating system each participant already uses every day. We're deliberately recruiting two kinds of users — people comfortable with neither the command line nor a typical desktop, and people comfortable with both — because the gap between those two groups is what we actually care about measuring.</a:t>
             </a:r>
             <a:endParaRPr lang="en-US" dirty="0"/>
           </a:p>
@@ -1476,7 +1476,7 @@
           <a:p>
             <a:r>
               <a:rPr lang="en-US" dirty="0"/>
-              <a:t>Our adviser's own written feedback on an earlier draft instructed us, in those exact words, to manage our scope carefully — a fair concern, given that this proposal combines algorithm development, corpus construction, interface engineering, and a controlled user study within a single undergraduate thesis. Our response is a written, explicit priority ordering rather than a vague reassurance: the recoverability algorithm and the GUI-mode session launch, which together constitute the distribution we intend to ship, are treated as the mandatory deliverable. Model fine-tuning details and the full forty-participant comparative study remain real, planned work, but they are explicitly the first components we would scale back if our timeline comes under pressure. This ordering reflects priority, not ambition — we are not abandoning either track, only stating plainly which one yields first.</a:t>
+              <a:t>Our adviser told us, directly, to manage our scope carefully — fair, since this thesis covers a lot of ground. Our answer: the safety algorithm and getting the interface running are non-negotiable; fine-tuning the AI model and the full user study are real plans, but the first things we'd trim if we run short on time.</a:t>
             </a:r>
             <a:endParaRPr lang="en-US" dirty="0"/>
           </a:p>
@@ -1564,7 +1564,7 @@
           <a:p>
             <a:r>
               <a:rPr lang="en-US" dirty="0"/>
-              <a:t>As of today, the algorithm track is essentially complete, with round seven standing as our reported, frozen result. The build track — the runtime and the GUI-mode session launch — remains actively in progress. The genuine bottleneck is ethics: our study instruments are fully drafted, but the institutional review board application itself has not yet been submitted. Because IRB turnaround is the least controllable variable in our entire timeline, we are prioritizing its submission now, in parallel with remaining build work, rather than sequencing it afterward.</a:t>
+              <a:t>The algorithm work is basically finished. The interface build is underway. The real bottleneck is ethics approval — our paperwork is ready, but not yet submitted, so that's our top priority right now.</a:t>
             </a:r>
             <a:endParaRPr lang="en-US" dirty="0"/>
           </a:p>
@@ -1652,7 +1652,7 @@
           <a:p>
             <a:r>
               <a:rPr lang="en-US" dirty="0"/>
-              <a:t>We would rather raise this question ourselves than have it put to us cold, because our adviser has in fact already asked it, in an earlier review, and it deserves a direct answer rather than an evasive one. At present, our answer is a prose argument rather than a measured number: we contend that the per-command rule table underlying the algorithm is itself simply a list, comparable in kind to the baseline we compare against, and that what we actually claim credit for is what the algorithm builds on top of that table — composition through wrappers, and resolution of run-time targets. We have not yet isolated the rule table's own contribution as an explicit ablation, and we say so plainly rather than let the panel discover the gap on their own. Our concrete plan to close it: add a flag to the analyzer that routes all wrapper and composition handling to an opaque fallback instead of resolving through it, run that configuration as a fourth comparison column against the same held-out corpus, and report whatever delta results — a scoped, well-defined next step, not an open-ended promise.</a:t>
+              <a:t>We're raising this ourselves because our adviser already asked it once: how much of our result comes from the algorithm, versus just the lookup table it's built on? Right now we can only answer that in words, not numbers — but we already have a concrete plan to measure it directly, and we're not hiding that gap.</a:t>
             </a:r>
             <a:endParaRPr lang="en-US" dirty="0"/>
           </a:p>
@@ -1740,7 +1740,7 @@
           <a:p>
             <a:r>
               <a:rPr lang="en-US" dirty="0"/>
-              <a:t>Should both evaluations proceed as designed, SynapseOS will have produced two genuinely independent contributions. The first is a recoverability algorithm, measurably safer and more useful than the pattern-matching approach it extends, evaluated entirely without human participants. The second, pending institutional approval, is the first controlled empirical evidence addressing whether a conversational interface actually narrows the gap between users fluent in the command line and users fluent in neither existing interface. Critically, each contribution stands on its own merit even if the other is delayed or scaled back — that mutual independence was a deliberate decision made early in this project's design, not a fortunate accident discovered later.</a:t>
+              <a:t>If both halves of this project succeed, we'll have two separate wins: a safer, more useful way to catch dangerous commands, and, pending approval, the first real evidence on whether talking to a computer actually helps people who struggle with existing interfaces. Each one holds up on its own even if the other gets delayed.</a:t>
             </a:r>
             <a:endParaRPr lang="en-US" dirty="0"/>
           </a:p>
@@ -1828,7 +1828,7 @@
           <a:p>
             <a:r>
               <a:rPr lang="en-US" dirty="0"/>
-              <a:t>We welcome the panel's questions, and thank you for your time and consideration.</a:t>
+              <a:t>Thank you — we're happy to take your questions.</a:t>
             </a:r>
             <a:endParaRPr lang="en-US" dirty="0"/>
           </a:p>
@@ -1916,7 +1916,7 @@
           <a:p>
             <a:r>
               <a:rPr lang="en-US" dirty="0"/>
-              <a:t>The command line can, in principle, express nearly any operation a computer supports, but only for someone fluent enough to write the syntax. The graphical desktop removed that syntactic barrier, but replaced it with a different one: a user can only do what the interface's designers anticipated and built a control for. Large language models have reopened a research thread that is, in fact, decades old — the Berkeley UNIX Consultant demonstrated a working natural-language interface to Unix as early as 1988 — but with substantially greater capability than was available then. What remains missing, despite this renewed interest, is an implemented and empirically evaluated system that places a conversational layer over the entire Linux desktop session, rather than over the shell alone or a single application; that is precisely the gap this study addresses.</a:t>
+              <a:t>The command line can do almost anything, but only if you know the right words to type. A graphical desktop is easier, but limits you to the buttons someone else thought to add. Nobody has yet built and tested a system that lets you control a whole Linux desktop just by talking to it normally — that's the gap we're filling.</a:t>
             </a:r>
             <a:endParaRPr lang="en-US" dirty="0"/>
           </a:p>
@@ -2004,7 +2004,7 @@
           <a:p>
             <a:r>
               <a:rPr lang="en-US" dirty="0"/>
-              <a:t>This statement captures the thesis's central premise: a computer's functional capability does not change between the command line and the graphical desktop, but a person's ability to reach that capability does, depending entirely on which interface they happen to be fluent in. SynapseOS proposes a third interface — natural language — specifically because it is the one mode of expression most people already possess, regardless of technical background. Chapters 1 through 3 of this proposal exist to argue that such an interface can be built, and, more importantly, that its value can be measured rather than merely asserted.</a:t>
+              <a:t>In one line: what a computer can actually do for you depends on which interface you already know how to use. Our goal is a third option, ordinary language, that closes that gap for people regardless of technical background.</a:t>
             </a:r>
             <a:endParaRPr lang="en-US" dirty="0"/>
           </a:p>
@@ -2092,7 +2092,7 @@
           <a:p>
             <a:r>
               <a:rPr lang="en-US" dirty="0"/>
-              <a:t>These four research questions were deliberately reordered following an earlier review, in which our adviser posed a pointed test: if the conversational interface were removed entirely, would any research contribution survive? For the manuscript as it then stood, the honest answer was no. In response, we restructured the proposal so that the recoverability algorithm now leads as RQ1, standing as an independent, corpus-evaluated contribution that requires no human participants at all. Research Questions 2 through 4 remain the interface questions, and these are what the 40-participant comparative study is designed to answer. Our four research objectives mirror these questions one-to-one, so satisfying each objective directly answers its corresponding question.</a:t>
+              <a:t>We reordered these after an earlier review — our adviser asked whether anything would be left if we removed the chat interface entirely. So we made the safety algorithm its own standalone contribution, listed first; the other three questions are about the interface itself, and our user study answers those.</a:t>
             </a:r>
             <a:endParaRPr lang="en-US" dirty="0"/>
           </a:p>
@@ -2180,7 +2180,7 @@
           <a:p>
             <a:r>
               <a:rPr lang="en-US" dirty="0"/>
-              <a:t>This four-layer pipeline — Input, Reasoning, Action, and Operating-System Integration — is the organizing framework developed in Chapter 2's review of the literature. It proved diagnostic in practice: nearly every surveyed system's principal limitation could be located at exactly one of these four layers, which is what makes the framework useful rather than merely descriptive. SynapseOS instantiates the pipeline directly — natural language enters at Input, a locally-hosted small language model reasons over it, the resulting shell commands execute at the Action layer, and the system spans the full graphical session rather than a single application at the Operating-System Integration layer. The recoverability algorithm that answers RQ1 lives specifically within the Action layer: it is the mechanism that decides, before anything executes, whether a command is safe to run outright or must first be confirmed.</a:t>
+              <a:t>This four-stage flow — understand the request, decide what to do, act on the computer, fit into the existing desktop — comes from our literature review in Chapter 2. SynapseOS follows this same flow, and the safety algorithm we'll discuss next lives in the 'acting' stage, right before anything actually runs.</a:t>
             </a:r>
             <a:endParaRPr lang="en-US" dirty="0"/>
           </a:p>
@@ -2268,7 +2268,7 @@
           <a:p>
             <a:r>
               <a:rPr lang="en-US" dirty="0"/>
-              <a:t>This slide is a placeholder for a recorded, verified terminal session, which we will substitute once captured. What it will show, concretely, is a plain-English request typed by a user, the shell command SynapseOS generates in response, the confirmation gate intervening before anything irreversible occurs, and the resulting output. We include this here deliberately, ahead of the algorithm's technical details, to make one point plain before anything else: this system already runs, today, on real hardware, and is not merely a design on paper.</a:t>
+              <a:t>This slide will show a real recording once we finish capturing and checking it — someone typing a plain request, the command SynapseOS generates, a safety check, and the result. We're showing this early to make one thing clear: this already works today, it isn't just a plan on paper.</a:t>
             </a:r>
             <a:endParaRPr lang="en-US" dirty="0"/>
           </a:p>
@@ -2356,7 +2356,7 @@
           <a:p>
             <a:r>
               <a:rPr lang="en-US" dirty="0"/>
-              <a:t>Allowing a language model to act on a real filesystem introduces a risk the interface layer alone cannot resolve: a generated command may destroy data before its author has any opportunity to review it. The conventional safeguard — matching a command against an enumerated list of known-dangerous patterns — judges the command by its surface form, its name, rather than by what it will actually do, so a disguised or simply unfamiliar variant of a dangerous operation passes through undetected. The naive alternative, refusing every command the list does not recognize, is safe in the narrow sense but practically useless: it protects nothing and interrupts the user constantly. What this study proposes instead is a third approach — an algorithm that understands a command's effects well enough, before execution, to know specifically what it will change.</a:t>
+              <a:t>If an AI types commands for you, it might accidentally delete something important before anyone notices. Today's safety check just looks at whether a command looks familiar, not at what it actually does. That leaves two bad options: let unfamiliar commands through and risk damage, or block everything unfamiliar and interrupt the user constantly. We want a third option.</a:t>
             </a:r>
             <a:endParaRPr lang="en-US" dirty="0"/>
           </a:p>
@@ -2444,7 +2444,7 @@
           <a:p>
             <a:r>
               <a:rPr lang="en-US" dirty="0"/>
-              <a:t>The algorithm's claim is deliberately narrow, and that narrowness is itself a design decision rather than a limitation we are apologizing for. It claims exactly two abilities: composition through wrappers, meaning it sees through constructs such as find -exec, xargs, shell loops, command and process substitution, pipelines, and sudo, treating earlier segments of a line as visible context for later ones; and resolution of run-time targets, meaning that where a target is computed only at execution time, a read-only dry run establishes the concrete targets in advance, so a capture plan can be built before anything actually runs. Commands with explicit, statically-named targets remain the responsibility of the existing pattern list, which already handled them adequately in our pilot work. Anything the analysis does not model is simply treated as unknown, and unknown fails closed by design — the system asks for confirmation and captures nothing, rather than guessing. We want to be explicit that we are not claiming to have solved recoverability in general; we are claiming these two specific abilities, and measuring them against baselines.</a:t>
+              <a:t>Our algorithm does two things, deliberately, and nothing more. First, it can see through common tricks for hiding what a command really does — loops, shortcuts, chaining several commands together. Second, when it can't know a command's target until the moment it runs, it does a safe test run first to find out exactly what would be affected. If a command is too unusual for it to understand, it simply stops and asks — it never guesses.</a:t>
             </a:r>
             <a:endParaRPr lang="en-US" dirty="0"/>
           </a:p>
@@ -2532,7 +2532,7 @@
           <a:p>
             <a:r>
               <a:rPr lang="en-US" dirty="0"/>
-              <a:t>We report the algorithm study and the user study as two genuinely independent contributions, because they are established through entirely separate evidence. The algorithm study requires no human participants at all: it is evaluated against a held-out corpus of generated commands, with ground truth established by sandboxed execution rather than human judgment, compared across the existing pattern list, that same list made to fail closed, and our algorithm. The user study, by contrast, follows a classical within-subjects design, comparing each of 40 participants against the operating system they already use daily, with task performance measured through OSWorld and a custom cross-platform suite, and subjective experience measured through the System Usability Scale and the NASA Task Load Index. That second study is the one still awaiting institutional ethics approval before it can proceed.</a:t>
+              <a:t>We're proving these two halves of our thesis in two separate ways. The safety algorithm is tested against hundreds of sample commands, with no human volunteers needed at all. The interface itself will be tested with 40 real users, once we have ethics approval to run that study.</a:t>
             </a:r>
             <a:endParaRPr lang="en-US" dirty="0"/>
           </a:p>

</xml_diff>

<commit_message>
docs(defense): drop Linux framing, intro quote slides, add a closing roadmap
Linux is this prototype's test substrate, not the thesis's claim
(D27/D28 draw the same line already) - removed from slide text and
notes. Every quote-bearing slide's note now opens by pointing at what's
on screen before explaining it, instead of diving straight into the
content. Added a "What's Next" slide before Q&A, framed generically
rather than naming specific course numbers. Documented the plan for
the two remaining placeholders in outline.md: a looping GIF for the
live-exchange slide, a static screenshot for the safety-gate slide.
</commit_message>
<xml_diff>
--- a/thesis 1/defense/SynapseOS_Proposal_Defense.pptx
+++ b/thesis 1/defense/SynapseOS_Proposal_Defense.pptx
@@ -22,9 +22,10 @@
     <p:sldId id="270" r:id="rId16"/>
     <p:sldId id="271" r:id="rId17"/>
     <p:sldId id="272" r:id="rId18"/>
+    <p:sldId id="273" r:id="rId19"/>
   </p:sldIdLst>
   <p:notesMasterIdLst>
-    <p:notesMasterId r:id="rId19"/>
+    <p:notesMasterId r:id="rId20"/>
   </p:notesMasterIdLst>
   <p:sldSz cx="12192000" cy="6858000"/>
   <p:notesSz cx="6858000" cy="12192000"/>
@@ -1476,7 +1477,7 @@
           <a:p>
             <a:r>
               <a:rPr lang="en-US" dirty="0"/>
-              <a:t>Our adviser told us, directly, to manage our scope carefully — fair, since this thesis covers a lot of ground. Our answer: the safety algorithm and getting the interface running are non-negotiable; fine-tuning the AI model and the full user study are real plans, but the first things we'd trim if we run short on time.</a:t>
+              <a:t>What's on screen is our adviser's own feedback, word for word: manage your scope carefully — fair, given how much ground this thesis covers. Our answer: the safety algorithm and getting the interface running are non-negotiable; fine-tuning the AI model and the full user study are real plans, but the first things we'd trim if we run short on time.</a:t>
             </a:r>
             <a:endParaRPr lang="en-US" dirty="0"/>
           </a:p>
@@ -1652,7 +1653,7 @@
           <a:p>
             <a:r>
               <a:rPr lang="en-US" dirty="0"/>
-              <a:t>We're raising this ourselves because our adviser already asked it once: how much of our result comes from the algorithm, versus just the lookup table it's built on? Right now we can only answer that in words, not numbers — but we already have a concrete plan to measure it directly, and we're not hiding that gap.</a:t>
+              <a:t>That's a question our adviser already put to us, in an earlier review, and we're putting it on screen ourselves rather than waiting for it to be asked again. Right now we can only answer it in words, not numbers — but we already have a concrete plan to measure it directly, and we're not hiding that gap.</a:t>
             </a:r>
             <a:endParaRPr lang="en-US" dirty="0"/>
           </a:p>
@@ -1828,7 +1829,7 @@
           <a:p>
             <a:r>
               <a:rPr lang="en-US" dirty="0"/>
-              <a:t>Thank you — we're happy to take your questions.</a:t>
+              <a:t>Once this proposal is approved, three things happen next: we submit for ethics approval, finish building the interface, and run the full study with real participants. The next time we present, we'll be showing actual results instead of a plan.</a:t>
             </a:r>
             <a:endParaRPr lang="en-US" dirty="0"/>
           </a:p>
@@ -1852,6 +1853,94 @@
             <a:fld id="{F7021451-1387-4CA6-816F-3879F97B5CBC}" type="slidenum">
               <a:rPr lang="en-US"/>
               <a:t>17</a:t>
+            </a:fld>
+            <a:endParaRPr lang="en-US"/>
+          </a:p>
+        </p:txBody>
+      </p:sp>
+    </p:spTree>
+    <p:extLst>
+      <p:ext uri="{BB962C8B-B14F-4D97-AF65-F5344CB8AC3E}">
+        <p14:creationId xmlns:p14="http://schemas.microsoft.com/office/powerpoint/2010/main" val="1024086991"/>
+      </p:ext>
+    </p:extLst>
+  </p:cSld>
+  <p:clrMapOvr>
+    <a:masterClrMapping/>
+  </p:clrMapOvr>
+</p:notes>
+</file>
+
+<file path=ppt/notesSlides/notesSlide18.xml><?xml version="1.0" encoding="utf-8"?>
+<p:notes xmlns:a="http://schemas.openxmlformats.org/drawingml/2006/main" xmlns:r="http://schemas.openxmlformats.org/officeDocument/2006/relationships" xmlns:p="http://schemas.openxmlformats.org/presentationml/2006/main">
+  <p:cSld>
+    <p:spTree>
+      <p:nvGrpSpPr>
+        <p:cNvPr id="1" name=""/>
+        <p:cNvGrpSpPr/>
+        <p:nvPr/>
+      </p:nvGrpSpPr>
+      <p:grpSpPr>
+        <a:xfrm>
+          <a:off x="0" y="0"/>
+          <a:ext cx="0" cy="0"/>
+          <a:chOff x="0" y="0"/>
+          <a:chExt cx="0" cy="0"/>
+        </a:xfrm>
+      </p:grpSpPr>
+      <p:sp>
+        <p:nvSpPr>
+          <p:cNvPr id="2" name="Slide Image Placeholder 1"/>
+          <p:cNvSpPr>
+            <a:spLocks noGrp="1" noRot="1" noChangeAspect="1"/>
+          </p:cNvSpPr>
+          <p:nvPr>
+            <p:ph type="sldImg"/>
+          </p:nvPr>
+        </p:nvSpPr>
+        <p:spPr/>
+      </p:sp>
+      <p:sp>
+        <p:nvSpPr>
+          <p:cNvPr id="3" name="Notes Placeholder 2"/>
+          <p:cNvSpPr>
+            <a:spLocks noGrp="1"/>
+          </p:cNvSpPr>
+          <p:nvPr>
+            <p:ph type="body" idx="1"/>
+          </p:nvPr>
+        </p:nvSpPr>
+        <p:spPr/>
+        <p:txBody>
+          <a:bodyPr/>
+          <a:lstStyle/>
+          <a:p>
+            <a:r>
+              <a:rPr lang="en-US" dirty="0"/>
+              <a:t>Thank you — we're happy to take your questions.</a:t>
+            </a:r>
+            <a:endParaRPr lang="en-US" dirty="0"/>
+          </a:p>
+        </p:txBody>
+      </p:sp>
+      <p:sp>
+        <p:nvSpPr>
+          <p:cNvPr id="4" name="Slide Number Placeholder 3"/>
+          <p:cNvSpPr>
+            <a:spLocks noGrp="1"/>
+          </p:cNvSpPr>
+          <p:nvPr>
+            <p:ph type="sldNum" sz="quarter" idx="10"/>
+          </p:nvPr>
+        </p:nvSpPr>
+        <p:spPr/>
+        <p:txBody>
+          <a:bodyPr/>
+          <a:lstStyle/>
+          <a:p>
+            <a:fld id="{F7021451-1387-4CA6-816F-3879F97B5CBC}" type="slidenum">
+              <a:rPr lang="en-US"/>
+              <a:t>18</a:t>
             </a:fld>
             <a:endParaRPr lang="en-US"/>
           </a:p>
@@ -1916,7 +2005,7 @@
           <a:p>
             <a:r>
               <a:rPr lang="en-US" dirty="0"/>
-              <a:t>The command line can do almost anything, but only if you know the right words to type. A graphical desktop is easier, but limits you to the buttons someone else thought to add. Nobody has yet built and tested a system that lets you control a whole Linux desktop just by talking to it normally — that's the gap we're filling.</a:t>
+              <a:t>The command line can do almost anything, but only if you know the right words to type. A graphical desktop is easier, but limits you to the buttons someone else thought to add. Nobody has yet built and tested a system that lets you control a whole desktop just by talking to it normally — that's the gap we're filling.</a:t>
             </a:r>
             <a:endParaRPr lang="en-US" dirty="0"/>
           </a:p>
@@ -2004,7 +2093,7 @@
           <a:p>
             <a:r>
               <a:rPr lang="en-US" dirty="0"/>
-              <a:t>In one line: what a computer can actually do for you depends on which interface you already know how to use. Our goal is a third option, ordinary language, that closes that gap for people regardless of technical background.</a:t>
+              <a:t>This is our problem statement, on screen, in one line: what a computer can actually do for you depends on which interface you already know how to use. Our goal is a third option, ordinary language, that closes that gap for people regardless of technical background.</a:t>
             </a:r>
             <a:endParaRPr lang="en-US" dirty="0"/>
           </a:p>
@@ -5679,6 +5768,228 @@
         </p:nvSpPr>
         <p:spPr>
           <a:xfrm>
+            <a:off x="548640" y="365760"/>
+            <a:ext cx="11064240" cy="914400"/>
+          </a:xfrm>
+          <a:prstGeom prst="rect">
+            <a:avLst/>
+          </a:prstGeom>
+          <a:noFill/>
+          <a:ln/>
+        </p:spPr>
+        <p:txBody>
+          <a:bodyPr wrap="square" rtlCol="0" anchor="t"/>
+          <a:lstStyle/>
+          <a:p>
+            <a:pPr algn="l" indent="0" marL="0">
+              <a:buNone/>
+            </a:pPr>
+            <a:r>
+              <a:rPr lang="en-US" sz="3400" b="1" dirty="0">
+                <a:solidFill>
+                  <a:schemeClr val="accent1"/>
+                </a:solidFill>
+                <a:latin typeface="Courier New" pitchFamily="34" charset="0"/>
+                <a:ea typeface="Courier New" pitchFamily="34" charset="-122"/>
+                <a:cs typeface="Courier New" pitchFamily="34" charset="-120"/>
+              </a:rPr>
+              <a:t>What's Next</a:t>
+            </a:r>
+            <a:endParaRPr lang="en-US" sz="3400" dirty="0"/>
+          </a:p>
+        </p:txBody>
+      </p:sp>
+      <p:sp>
+        <p:nvSpPr>
+          <p:cNvPr id="3" name="Text 0"/>
+          <p:cNvSpPr/>
+          <p:nvPr>
+            <p:ph idx="101" type="body" hasCustomPrompt="1"/>
+          </p:nvPr>
+        </p:nvSpPr>
+        <p:spPr>
+          <a:xfrm>
+            <a:off x="548640" y="1463040"/>
+            <a:ext cx="11064240" cy="4983480"/>
+          </a:xfrm>
+          <a:prstGeom prst="rect">
+            <a:avLst/>
+          </a:prstGeom>
+          <a:noFill/>
+          <a:ln/>
+        </p:spPr>
+        <p:txBody>
+          <a:bodyPr wrap="square" rtlCol="0" anchor="t"/>
+          <a:lstStyle/>
+          <a:p>
+            <a:pPr algn="l" marL="342900" indent="-342900">
+              <a:spcAft>
+                <a:spcPts val="1600"/>
+              </a:spcAft>
+              <a:buSzPct val="100000"/>
+              <a:buChar char="▸"/>
+            </a:pPr>
+            <a:r>
+              <a:rPr lang="en-US" sz="1900" dirty="0">
+                <a:solidFill>
+                  <a:schemeClr val="bg1"/>
+                </a:solidFill>
+                <a:latin typeface="Calibri" pitchFamily="34" charset="0"/>
+                <a:ea typeface="Calibri" pitchFamily="34" charset="-122"/>
+                <a:cs typeface="Calibri" pitchFamily="34" charset="-120"/>
+              </a:rPr>
+              <a:t>Submit the ethics application</a:t>
+            </a:r>
+            <a:endParaRPr lang="en-US" sz="1900" dirty="0"/>
+          </a:p>
+          <a:p>
+            <a:pPr algn="l" marL="342900" indent="-342900">
+              <a:spcAft>
+                <a:spcPts val="1600"/>
+              </a:spcAft>
+              <a:buSzPct val="100000"/>
+              <a:buChar char="▸"/>
+            </a:pPr>
+            <a:r>
+              <a:rPr lang="en-US" sz="1900" dirty="0">
+                <a:solidFill>
+                  <a:schemeClr val="bg1"/>
+                </a:solidFill>
+                <a:latin typeface="Calibri" pitchFamily="34" charset="0"/>
+                <a:ea typeface="Calibri" pitchFamily="34" charset="-122"/>
+                <a:cs typeface="Calibri" pitchFamily="34" charset="-120"/>
+              </a:rPr>
+              <a:t>Finish the interface build</a:t>
+            </a:r>
+            <a:endParaRPr lang="en-US" sz="1900" dirty="0"/>
+          </a:p>
+          <a:p>
+            <a:pPr algn="l" marL="342900" indent="-342900">
+              <a:spcAft>
+                <a:spcPts val="1600"/>
+              </a:spcAft>
+              <a:buSzPct val="100000"/>
+              <a:buChar char="▸"/>
+            </a:pPr>
+            <a:r>
+              <a:rPr lang="en-US" sz="1900" dirty="0">
+                <a:solidFill>
+                  <a:schemeClr val="bg1"/>
+                </a:solidFill>
+                <a:latin typeface="Calibri" pitchFamily="34" charset="0"/>
+                <a:ea typeface="Calibri" pitchFamily="34" charset="-122"/>
+                <a:cs typeface="Calibri" pitchFamily="34" charset="-120"/>
+              </a:rPr>
+              <a:t>Run the study with real participants</a:t>
+            </a:r>
+            <a:endParaRPr lang="en-US" sz="1900" dirty="0"/>
+          </a:p>
+          <a:p>
+            <a:pPr algn="l" marL="342900" indent="-342900">
+              <a:spcAft>
+                <a:spcPts val="1600"/>
+              </a:spcAft>
+              <a:buSzPct val="100000"/>
+              <a:buChar char="▸"/>
+            </a:pPr>
+            <a:r>
+              <a:rPr lang="en-US" sz="1900" dirty="0">
+                <a:solidFill>
+                  <a:schemeClr val="bg1"/>
+                </a:solidFill>
+                <a:latin typeface="Calibri" pitchFamily="34" charset="0"/>
+                <a:ea typeface="Calibri" pitchFamily="34" charset="-122"/>
+                <a:cs typeface="Calibri" pitchFamily="34" charset="-120"/>
+              </a:rPr>
+              <a:t>Return with results, not just a plan</a:t>
+            </a:r>
+            <a:endParaRPr lang="en-US" sz="1900" dirty="0"/>
+          </a:p>
+        </p:txBody>
+      </p:sp>
+      <p:sp>
+        <p:nvSpPr>
+          <p:cNvPr id="25" name="Slide Number Placeholder 0"/>
+          <p:cNvSpPr>
+            <a:spLocks noGrp="1"/>
+          </p:cNvSpPr>
+          <p:nvPr>
+            <p:ph type="sldNum" sz="quarter" idx="4294967295"/>
+          </p:nvPr>
+        </p:nvSpPr>
+        <p:spPr>
+          <a:xfrm>
+            <a:off x="11521440" y="6537960"/>
+            <a:ext cx="800000" cy="300000"/>
+          </a:xfrm>
+          <a:prstGeom prst="rect">
+            <a:avLst/>
+          </a:prstGeom>
+          <a:extLst>
+            <a:ext uri="{C572A759-6A51-4108-AA02-DFA0A04FC94B}">
+              <ma14:wrappingTextBoxFlag xmlns:ma14="http://schemas.microsoft.com/office/mac/drawingml/2011/main" val="0"/>
+            </a:ext>
+          </a:extLst>
+        </p:spPr>
+        <p:txBody>
+          <a:bodyPr/>
+          <a:lstStyle>
+            <a:lvl1pPr>
+              <a:defRPr sz="1000">
+                <a:solidFill>
+                  <a:schemeClr val="bg2"/>
+                </a:solidFill>
+                <a:latin typeface="Calibri"/>
+                <a:ea typeface="Calibri"/>
+                <a:cs typeface="Calibri"/>
+              </a:defRPr>
+            </a:lvl1pPr>
+          </a:lstStyle>
+          <a:p>
+            <a:pPr algn="l"/>
+            <a:fld id="{F7021451-1387-4CA6-816F-3879F97B5CBC}" type="slidenum">
+              <a:rPr b="0" lang="en-US"/>
+              <a:t>17</a:t>
+            </a:fld>
+            <a:endParaRPr lang="en-US"/>
+          </a:p>
+        </p:txBody>
+      </p:sp>
+    </p:spTree>
+  </p:cSld>
+  <p:clrMapOvr>
+    <a:masterClrMapping/>
+  </p:clrMapOvr>
+</p:sld>
+</file>
+
+<file path=ppt/slides/slide18.xml><?xml version="1.0" encoding="utf-8"?>
+<p:sld xmlns:a="http://schemas.openxmlformats.org/drawingml/2006/main" xmlns:r="http://schemas.openxmlformats.org/officeDocument/2006/relationships" xmlns:p="http://schemas.openxmlformats.org/presentationml/2006/main">
+  <p:cSld name="Slide 18">
+    <p:spTree>
+      <p:nvGrpSpPr>
+        <p:cNvPr id="1" name=""/>
+        <p:cNvGrpSpPr/>
+        <p:nvPr/>
+      </p:nvGrpSpPr>
+      <p:grpSpPr>
+        <a:xfrm>
+          <a:off x="0" y="0"/>
+          <a:ext cx="0" cy="0"/>
+          <a:chOff x="0" y="0"/>
+          <a:chExt cx="0" cy="0"/>
+        </a:xfrm>
+      </p:grpSpPr>
+      <p:sp>
+        <p:nvSpPr>
+          <p:cNvPr id="2" name="Text 0"/>
+          <p:cNvSpPr/>
+          <p:nvPr>
+            <p:ph idx="100" type="title" hasCustomPrompt="1"/>
+          </p:nvPr>
+        </p:nvSpPr>
+        <p:spPr>
+          <a:xfrm>
             <a:off x="822960" y="2194560"/>
             <a:ext cx="10515600" cy="1554480"/>
           </a:xfrm>
@@ -5919,7 +6230,7 @@
                 <a:ea typeface="Calibri" pitchFamily="34" charset="-122"/>
                 <a:cs typeface="Calibri" pitchFamily="34" charset="-120"/>
               </a:rPr>
-              <a:t>Missing: an implemented, evaluated system for the whole Linux desktop session</a:t>
+              <a:t>Missing: an implemented, evaluated system for the whole desktop session</a:t>
             </a:r>
             <a:endParaRPr lang="en-US" sz="1900" dirty="0"/>
           </a:p>
@@ -6309,7 +6620,7 @@
                 <a:ea typeface="Calibri" pitchFamily="34" charset="-122"/>
                 <a:cs typeface="Calibri" pitchFamily="34" charset="-120"/>
               </a:rPr>
-              <a:t>RQ2 — Direct a full Linux desktop in ordinary language</a:t>
+              <a:t>RQ2 — Direct a full desktop in ordinary language</a:t>
             </a:r>
             <a:endParaRPr lang="en-US" sz="1900" dirty="0"/>
           </a:p>

</xml_diff>

<commit_message>
docs(defense): replace both placeholders with real captured footage
Slides 6 and 8 now show the actual prototype instead of a dashed
placeholder box: a looping GIF of a full exchange ("what's in this
folder?" -> command -> answer), and a screenshot of the safety gate
actually catching rm -f *.log and asking for confirmation. Both are
real captures, not mockups - driven through a real pty with scripted
keystrokes and rendered straight from the captured terminal state via
pyte + Pillow, no X11/screen-recording/sudo needed. Reworked slide 8's
layout (shrunk the two ability cards) to fit the screenshot properly.
</commit_message>
<xml_diff>
--- a/thesis 1/defense/SynapseOS_Proposal_Defense.pptx
+++ b/thesis 1/defense/SynapseOS_Proposal_Defense.pptx
@@ -2357,7 +2357,7 @@
           <a:p>
             <a:r>
               <a:rPr lang="en-US" dirty="0"/>
-              <a:t>This slide will show a real recording once we finish capturing and checking it — someone typing a plain request, the command SynapseOS generates, a safety check, and the result. We're showing this early to make one thing clear: this already works today, it isn't just a plan on paper.</a:t>
+              <a:t>This is a real, recorded exchange — someone typing a plain request, the command SynapseOS generates, and the result. We're showing this early to make one thing clear: this already works today, it isn't just a plan on paper.</a:t>
             </a:r>
             <a:endParaRPr lang="en-US" dirty="0"/>
           </a:p>
@@ -7607,159 +7607,33 @@
           </a:p>
         </p:txBody>
       </p:sp>
-      <p:sp>
-        <p:nvSpPr>
-          <p:cNvPr id="3" name="Shape 1"/>
-          <p:cNvSpPr/>
+      <p:pic>
+        <p:nvPicPr>
+          <p:cNvPr id="3" name="Image 0" descr="media/what-it-looks-like.gif">    </p:cNvPr>
+          <p:cNvPicPr>
+            <a:picLocks noChangeAspect="1"/>
+          </p:cNvPicPr>
           <p:nvPr/>
-        </p:nvSpPr>
-        <p:spPr>
-          <a:xfrm>
-            <a:off x="1188720" y="1600200"/>
-            <a:ext cx="9784080" cy="4572000"/>
-          </a:xfrm>
-          <a:prstGeom prst="roundRect">
-            <a:avLst>
-              <a:gd name="adj" fmla="val 1600"/>
-            </a:avLst>
-          </a:prstGeom>
-          <a:solidFill>
-            <a:srgbClr val="161B22"/>
-          </a:solidFill>
-          <a:ln w="12700">
-            <a:solidFill>
-              <a:srgbClr val="8B949E"/>
-            </a:solidFill>
-            <a:prstDash val="dash"/>
-          </a:ln>
-          <a:effectLst>
-            <a:outerShdw sx="100000" sy="100000" kx="0" ky="0" algn="bl" rotWithShape="0" blurRad="76200" dist="38100" dir="5400000">
-              <a:srgbClr val="000000">
-                <a:alpha val="40000"/>
-              </a:srgbClr>
-            </a:outerShdw>
-          </a:effectLst>
-        </p:spPr>
-      </p:sp>
-      <p:sp>
-        <p:nvSpPr>
-          <p:cNvPr id="4" name="Shape 2"/>
-          <p:cNvSpPr/>
-          <p:nvPr/>
-        </p:nvSpPr>
-        <p:spPr>
-          <a:xfrm>
-            <a:off x="1389888" y="1783080"/>
-            <a:ext cx="128016" cy="128016"/>
-          </a:xfrm>
-          <a:prstGeom prst="ellipse">
-            <a:avLst/>
-          </a:prstGeom>
-          <a:solidFill>
-            <a:srgbClr val="F85149"/>
-          </a:solidFill>
-          <a:ln/>
-        </p:spPr>
-      </p:sp>
-      <p:sp>
-        <p:nvSpPr>
-          <p:cNvPr id="5" name="Shape 3"/>
-          <p:cNvSpPr/>
-          <p:nvPr/>
-        </p:nvSpPr>
-        <p:spPr>
-          <a:xfrm>
-            <a:off x="1627632" y="1783080"/>
-            <a:ext cx="128016" cy="128016"/>
-          </a:xfrm>
-          <a:prstGeom prst="ellipse">
-            <a:avLst/>
-          </a:prstGeom>
-          <a:solidFill>
-            <a:srgbClr val="F0A500"/>
-          </a:solidFill>
-          <a:ln/>
-        </p:spPr>
-      </p:sp>
-      <p:sp>
-        <p:nvSpPr>
-          <p:cNvPr id="6" name="Shape 4"/>
-          <p:cNvSpPr/>
-          <p:nvPr/>
-        </p:nvSpPr>
-        <p:spPr>
-          <a:xfrm>
-            <a:off x="1865376" y="1783080"/>
-            <a:ext cx="128016" cy="128016"/>
-          </a:xfrm>
-          <a:prstGeom prst="ellipse">
-            <a:avLst/>
-          </a:prstGeom>
-          <a:solidFill>
-            <a:srgbClr val="3FB950"/>
-          </a:solidFill>
-          <a:ln/>
-        </p:spPr>
-      </p:sp>
-      <p:sp>
-        <p:nvSpPr>
-          <p:cNvPr id="7" name="Text 5"/>
-          <p:cNvSpPr txBox="1"/>
-          <p:nvPr/>
-        </p:nvSpPr>
-        <p:spPr>
-          <a:xfrm>
-            <a:off x="1554480" y="2148840"/>
-            <a:ext cx="9052560" cy="3657600"/>
-          </a:xfrm>
-          <a:prstGeom prst="rect">
-            <a:avLst/>
-          </a:prstGeom>
-          <a:noFill/>
-          <a:ln/>
-        </p:spPr>
-        <p:txBody>
-          <a:bodyPr wrap="square" lIns="0" tIns="0" rIns="0" bIns="0" rtlCol="0" anchor="ctr"/>
-          <a:lstStyle/>
-          <a:p>
-            <a:pPr algn="ctr" indent="0" marL="0">
-              <a:buNone/>
-            </a:pPr>
-            <a:r>
-              <a:rPr lang="en-US" sz="1600" i="1" dirty="0">
-                <a:solidFill>
-                  <a:schemeClr val="bg2"/>
-                </a:solidFill>
-                <a:latin typeface="Courier New" pitchFamily="34" charset="0"/>
-                <a:ea typeface="Courier New" pitchFamily="34" charset="-122"/>
-                <a:cs typeface="Courier New" pitchFamily="34" charset="-120"/>
-              </a:rPr>
-              <a:t>[ placeholder — terminal capture: a natural-language request,</a:t>
-            </a:r>
-            <a:endParaRPr lang="en-US" sz="1600" dirty="0"/>
-          </a:p>
-          <a:p>
-            <a:pPr algn="ctr" indent="0" marL="0">
-              <a:buNone/>
-            </a:pPr>
-            <a:r>
-              <a:rPr lang="en-US" sz="1600" i="1" dirty="0">
-                <a:solidFill>
-                  <a:schemeClr val="bg2"/>
-                </a:solidFill>
-                <a:latin typeface="Courier New" pitchFamily="34" charset="0"/>
-                <a:ea typeface="Courier New" pitchFamily="34" charset="-122"/>
-                <a:cs typeface="Courier New" pitchFamily="34" charset="-120"/>
-              </a:rPr>
-              <a:t>the generated command, the confirmation gate, and the result ]</a:t>
-            </a:r>
-            <a:endParaRPr lang="en-US" sz="1600" dirty="0"/>
-          </a:p>
-        </p:txBody>
-      </p:sp>
-      <p:sp>
-        <p:nvSpPr>
-          <p:cNvPr id="9" name="Text 0"/>
+        </p:nvPicPr>
+        <p:blipFill>
+          <a:blip r:embed="rId1"/>
+          <a:stretch>
+            <a:fillRect/>
+          </a:stretch>
+        </p:blipFill>
+        <p:spPr>
+          <a:xfrm>
+            <a:off x="1234440" y="1828800"/>
+            <a:ext cx="9692640" cy="4087368"/>
+          </a:xfrm>
+          <a:prstGeom prst="rect">
+            <a:avLst/>
+          </a:prstGeom>
+        </p:spPr>
+      </p:pic>
+      <p:sp>
+        <p:nvSpPr>
+          <p:cNvPr id="5" name="Text 0"/>
           <p:cNvSpPr/>
           <p:nvPr>
             <p:ph idx="101" type="body" hasCustomPrompt="1"/>
@@ -8131,12 +8005,12 @@
         </p:nvSpPr>
         <p:spPr>
           <a:xfrm>
-            <a:off x="548640" y="1463040"/>
-            <a:ext cx="5349240" cy="2514600"/>
+            <a:off x="548640" y="1371600"/>
+            <a:ext cx="5349240" cy="1691640"/>
           </a:xfrm>
           <a:prstGeom prst="roundRect">
             <a:avLst>
-              <a:gd name="adj" fmla="val 2909"/>
+              <a:gd name="adj" fmla="val 4324"/>
             </a:avLst>
           </a:prstGeom>
           <a:solidFill>
@@ -8158,8 +8032,8 @@
         </p:nvSpPr>
         <p:spPr>
           <a:xfrm>
-            <a:off x="777240" y="1645920"/>
-            <a:ext cx="4892040" cy="502920"/>
+            <a:off x="777240" y="1508760"/>
+            <a:ext cx="4892040" cy="457200"/>
           </a:xfrm>
           <a:prstGeom prst="rect">
             <a:avLst/>
@@ -8175,7 +8049,7 @@
               <a:buNone/>
             </a:pPr>
             <a:r>
-              <a:rPr lang="en-US" sz="1700" b="1" dirty="0">
+              <a:rPr lang="en-US" sz="1600" b="1" dirty="0">
                 <a:solidFill>
                   <a:schemeClr val="accent1"/>
                 </a:solidFill>
@@ -8185,7 +8059,7 @@
               </a:rPr>
               <a:t>Composition through wrappers</a:t>
             </a:r>
-            <a:endParaRPr lang="en-US" sz="1700" dirty="0"/>
+            <a:endParaRPr lang="en-US" sz="1600" dirty="0"/>
           </a:p>
         </p:txBody>
       </p:sp>
@@ -8197,8 +8071,8 @@
         </p:nvSpPr>
         <p:spPr>
           <a:xfrm>
-            <a:off x="777240" y="2194560"/>
-            <a:ext cx="4892040" cy="1691640"/>
+            <a:off x="777240" y="2011680"/>
+            <a:ext cx="4892040" cy="1005840"/>
           </a:xfrm>
           <a:prstGeom prst="rect">
             <a:avLst/>
@@ -8214,7 +8088,7 @@
               <a:buNone/>
             </a:pPr>
             <a:r>
-              <a:rPr lang="en-US" sz="1600" dirty="0">
+              <a:rPr lang="en-US" sz="1500" dirty="0">
                 <a:solidFill>
                   <a:schemeClr val="bg1"/>
                 </a:solidFill>
@@ -8224,7 +8098,7 @@
               </a:rPr>
               <a:t>find -exec, xargs, loops, substitution, pipelines, sudo — earlier segments visible to later ones</a:t>
             </a:r>
-            <a:endParaRPr lang="en-US" sz="1600" dirty="0"/>
+            <a:endParaRPr lang="en-US" sz="1500" dirty="0"/>
           </a:p>
         </p:txBody>
       </p:sp>
@@ -8236,12 +8110,12 @@
         </p:nvSpPr>
         <p:spPr>
           <a:xfrm>
-            <a:off x="6172200" y="1463040"/>
-            <a:ext cx="5349240" cy="2514600"/>
+            <a:off x="6172200" y="1371600"/>
+            <a:ext cx="5349240" cy="1691640"/>
           </a:xfrm>
           <a:prstGeom prst="roundRect">
             <a:avLst>
-              <a:gd name="adj" fmla="val 2909"/>
+              <a:gd name="adj" fmla="val 4324"/>
             </a:avLst>
           </a:prstGeom>
           <a:solidFill>
@@ -8263,8 +8137,8 @@
         </p:nvSpPr>
         <p:spPr>
           <a:xfrm>
-            <a:off x="6400800" y="1645920"/>
-            <a:ext cx="4892040" cy="502920"/>
+            <a:off x="6400800" y="1508760"/>
+            <a:ext cx="4892040" cy="457200"/>
           </a:xfrm>
           <a:prstGeom prst="rect">
             <a:avLst/>
@@ -8280,7 +8154,7 @@
               <a:buNone/>
             </a:pPr>
             <a:r>
-              <a:rPr lang="en-US" sz="1700" b="1" dirty="0">
+              <a:rPr lang="en-US" sz="1600" b="1" dirty="0">
                 <a:solidFill>
                   <a:schemeClr val="accent1"/>
                 </a:solidFill>
@@ -8290,7 +8164,7 @@
               </a:rPr>
               <a:t>Resolution of run-time targets</a:t>
             </a:r>
-            <a:endParaRPr lang="en-US" sz="1700" dirty="0"/>
+            <a:endParaRPr lang="en-US" sz="1600" dirty="0"/>
           </a:p>
         </p:txBody>
       </p:sp>
@@ -8302,8 +8176,8 @@
         </p:nvSpPr>
         <p:spPr>
           <a:xfrm>
-            <a:off x="6400800" y="2194560"/>
-            <a:ext cx="4892040" cy="1691640"/>
+            <a:off x="6400800" y="2011680"/>
+            <a:ext cx="4892040" cy="1005840"/>
           </a:xfrm>
           <a:prstGeom prst="rect">
             <a:avLst/>
@@ -8319,7 +8193,7 @@
               <a:buNone/>
             </a:pPr>
             <a:r>
-              <a:rPr lang="en-US" sz="1600" dirty="0">
+              <a:rPr lang="en-US" sz="1500" dirty="0">
                 <a:solidFill>
                   <a:schemeClr val="bg1"/>
                 </a:solidFill>
@@ -8329,7 +8203,7 @@
               </a:rPr>
               <a:t>Targets computed at run time (rm $(ls *.log), find -delete, xargs rm) resolved via a read-only dry run before execution</a:t>
             </a:r>
-            <a:endParaRPr lang="en-US" sz="1600" dirty="0"/>
+            <a:endParaRPr lang="en-US" sz="1500" dirty="0"/>
           </a:p>
         </p:txBody>
       </p:sp>
@@ -8341,12 +8215,12 @@
         </p:nvSpPr>
         <p:spPr>
           <a:xfrm>
-            <a:off x="548640" y="4160520"/>
-            <a:ext cx="10972800" cy="777240"/>
+            <a:off x="548640" y="3246120"/>
+            <a:ext cx="10972800" cy="594360"/>
           </a:xfrm>
           <a:prstGeom prst="roundRect">
             <a:avLst>
-              <a:gd name="adj" fmla="val 7059"/>
+              <a:gd name="adj" fmla="val 9231"/>
             </a:avLst>
           </a:prstGeom>
           <a:solidFill>
@@ -8368,8 +8242,8 @@
         </p:nvSpPr>
         <p:spPr>
           <a:xfrm>
-            <a:off x="822960" y="4160520"/>
-            <a:ext cx="10424160" cy="777240"/>
+            <a:off x="822960" y="3246120"/>
+            <a:ext cx="10424160" cy="594360"/>
           </a:xfrm>
           <a:prstGeom prst="rect">
             <a:avLst/>
@@ -8385,7 +8259,7 @@
               <a:buNone/>
             </a:pPr>
             <a:r>
-              <a:rPr lang="en-US" sz="1600" b="1" dirty="0">
+              <a:rPr lang="en-US" sz="1500" b="1" dirty="0">
                 <a:solidFill>
                   <a:schemeClr val="accent2"/>
                 </a:solidFill>
@@ -8399,7 +8273,7 @@
               <a:buNone/>
             </a:pPr>
             <a:r>
-              <a:rPr lang="en-US" sz="1600" dirty="0">
+              <a:rPr lang="en-US" sz="1500" dirty="0">
                 <a:solidFill>
                   <a:schemeClr val="bg1"/>
                 </a:solidFill>
@@ -8409,163 +8283,37 @@
               </a:rPr>
               <a:t>unmodeled commands are unknown → fail closed, ask, capture nothing.</a:t>
             </a:r>
-            <a:endParaRPr lang="en-US" sz="1600" dirty="0"/>
-          </a:p>
-        </p:txBody>
-      </p:sp>
-      <p:sp>
-        <p:nvSpPr>
-          <p:cNvPr id="11" name="Shape 9"/>
-          <p:cNvSpPr/>
+            <a:endParaRPr lang="en-US" sz="1500" dirty="0"/>
+          </a:p>
+        </p:txBody>
+      </p:sp>
+      <p:pic>
+        <p:nvPicPr>
+          <p:cNvPr id="11" name="Image 0" descr="media/safety-gate.png">    </p:cNvPr>
+          <p:cNvPicPr>
+            <a:picLocks noChangeAspect="1"/>
+          </p:cNvPicPr>
           <p:nvPr/>
-        </p:nvSpPr>
-        <p:spPr>
-          <a:xfrm>
-            <a:off x="548640" y="5074920"/>
-            <a:ext cx="10972800" cy="1325880"/>
-          </a:xfrm>
-          <a:prstGeom prst="roundRect">
-            <a:avLst>
-              <a:gd name="adj" fmla="val 5517"/>
-            </a:avLst>
-          </a:prstGeom>
-          <a:solidFill>
-            <a:srgbClr val="161B22"/>
-          </a:solidFill>
-          <a:ln w="12700">
-            <a:solidFill>
-              <a:srgbClr val="8B949E"/>
-            </a:solidFill>
-            <a:prstDash val="dash"/>
-          </a:ln>
-          <a:effectLst>
-            <a:outerShdw sx="100000" sy="100000" kx="0" ky="0" algn="bl" rotWithShape="0" blurRad="76200" dist="38100" dir="5400000">
-              <a:srgbClr val="000000">
-                <a:alpha val="40000"/>
-              </a:srgbClr>
-            </a:outerShdw>
-          </a:effectLst>
-        </p:spPr>
-      </p:sp>
-      <p:sp>
-        <p:nvSpPr>
-          <p:cNvPr id="12" name="Shape 10"/>
-          <p:cNvSpPr/>
-          <p:nvPr/>
-        </p:nvSpPr>
-        <p:spPr>
-          <a:xfrm>
-            <a:off x="749808" y="5257800"/>
-            <a:ext cx="128016" cy="128016"/>
-          </a:xfrm>
-          <a:prstGeom prst="ellipse">
-            <a:avLst/>
-          </a:prstGeom>
-          <a:solidFill>
-            <a:srgbClr val="F85149"/>
-          </a:solidFill>
-          <a:ln/>
-        </p:spPr>
-      </p:sp>
-      <p:sp>
-        <p:nvSpPr>
-          <p:cNvPr id="13" name="Shape 11"/>
-          <p:cNvSpPr/>
-          <p:nvPr/>
-        </p:nvSpPr>
-        <p:spPr>
-          <a:xfrm>
-            <a:off x="987552" y="5257800"/>
-            <a:ext cx="128016" cy="128016"/>
-          </a:xfrm>
-          <a:prstGeom prst="ellipse">
-            <a:avLst/>
-          </a:prstGeom>
-          <a:solidFill>
-            <a:srgbClr val="F0A500"/>
-          </a:solidFill>
-          <a:ln/>
-        </p:spPr>
-      </p:sp>
-      <p:sp>
-        <p:nvSpPr>
-          <p:cNvPr id="14" name="Shape 12"/>
-          <p:cNvSpPr/>
-          <p:nvPr/>
-        </p:nvSpPr>
-        <p:spPr>
-          <a:xfrm>
-            <a:off x="1225296" y="5257800"/>
-            <a:ext cx="128016" cy="128016"/>
-          </a:xfrm>
-          <a:prstGeom prst="ellipse">
-            <a:avLst/>
-          </a:prstGeom>
-          <a:solidFill>
-            <a:srgbClr val="3FB950"/>
-          </a:solidFill>
-          <a:ln/>
-        </p:spPr>
-      </p:sp>
-      <p:sp>
-        <p:nvSpPr>
-          <p:cNvPr id="15" name="Text 13"/>
-          <p:cNvSpPr txBox="1"/>
-          <p:nvPr/>
-        </p:nvSpPr>
-        <p:spPr>
-          <a:xfrm>
-            <a:off x="914400" y="5623560"/>
-            <a:ext cx="10241280" cy="411480"/>
-          </a:xfrm>
-          <a:prstGeom prst="rect">
-            <a:avLst/>
-          </a:prstGeom>
-          <a:noFill/>
-          <a:ln/>
-        </p:spPr>
-        <p:txBody>
-          <a:bodyPr wrap="square" lIns="0" tIns="0" rIns="0" bIns="0" rtlCol="0" anchor="ctr"/>
-          <a:lstStyle/>
-          <a:p>
-            <a:pPr algn="ctr" indent="0" marL="0">
-              <a:buNone/>
-            </a:pPr>
-            <a:r>
-              <a:rPr lang="en-US" sz="1600" i="1" dirty="0">
-                <a:solidFill>
-                  <a:schemeClr val="bg2"/>
-                </a:solidFill>
-                <a:latin typeface="Courier New" pitchFamily="34" charset="0"/>
-                <a:ea typeface="Courier New" pitchFamily="34" charset="-122"/>
-                <a:cs typeface="Courier New" pitchFamily="34" charset="-120"/>
-              </a:rPr>
-              <a:t>[ placeholder — terminal capture: the safety gate catching a destructive</a:t>
-            </a:r>
-            <a:endParaRPr lang="en-US" sz="1600" dirty="0"/>
-          </a:p>
-          <a:p>
-            <a:pPr algn="ctr" indent="0" marL="0">
-              <a:buNone/>
-            </a:pPr>
-            <a:r>
-              <a:rPr lang="en-US" sz="1600" i="1" dirty="0">
-                <a:solidFill>
-                  <a:schemeClr val="bg2"/>
-                </a:solidFill>
-                <a:latin typeface="Courier New" pitchFamily="34" charset="0"/>
-                <a:ea typeface="Courier New" pitchFamily="34" charset="-122"/>
-                <a:cs typeface="Courier New" pitchFamily="34" charset="-120"/>
-              </a:rPr>
-              <a:t>command and asking for confirmation before it runs ]</a:t>
-            </a:r>
-            <a:endParaRPr lang="en-US" sz="1600" dirty="0"/>
-          </a:p>
-        </p:txBody>
-      </p:sp>
-      <p:sp>
-        <p:nvSpPr>
-          <p:cNvPr id="17" name="Text 0"/>
+        </p:nvPicPr>
+        <p:blipFill>
+          <a:blip r:embed="rId1"/>
+          <a:stretch>
+            <a:fillRect/>
+          </a:stretch>
+        </p:blipFill>
+        <p:spPr>
+          <a:xfrm>
+            <a:off x="2240280" y="4023360"/>
+            <a:ext cx="7680960" cy="2468880"/>
+          </a:xfrm>
+          <a:prstGeom prst="rect">
+            <a:avLst/>
+          </a:prstGeom>
+        </p:spPr>
+      </p:pic>
+      <p:sp>
+        <p:nvSpPr>
+          <p:cNvPr id="13" name="Text 0"/>
           <p:cNvSpPr/>
           <p:nvPr>
             <p:ph idx="101" type="body" hasCustomPrompt="1"/>

</xml_diff>

<commit_message>
docs(defense): show three varied commands on slide 6 instead of one
A single "what's in this folder?" listing undersold the system - adds
a rename (an action, not just a read) and a file count (a different
question shape) to the same looping GIF, all real captures from the
same recording session.
</commit_message>
<xml_diff>
--- a/thesis 1/defense/SynapseOS_Proposal_Defense.pptx
+++ b/thesis 1/defense/SynapseOS_Proposal_Defense.pptx
@@ -2357,7 +2357,7 @@
           <a:p>
             <a:r>
               <a:rPr lang="en-US" dirty="0"/>
-              <a:t>This is a real, recorded exchange — someone typing a plain request, the command SynapseOS generates, and the result. We're showing this early to make one thing clear: this already works today, it isn't just a plan on paper.</a:t>
+              <a:t>This is a real recording, three requests in a row — listing a folder, renaming a file, counting photos — plain English in, a real command and a real answer out each time. We're showing this early to make one thing clear: this already works today, it isn't just a plan on paper.</a:t>
             </a:r>
             <a:endParaRPr lang="en-US" dirty="0"/>
           </a:p>
@@ -7623,8 +7623,8 @@
         </p:blipFill>
         <p:spPr>
           <a:xfrm>
-            <a:off x="1234440" y="1828800"/>
-            <a:ext cx="9692640" cy="4087368"/>
+            <a:off x="1234440" y="1691640"/>
+            <a:ext cx="9692640" cy="4407408"/>
           </a:xfrm>
           <a:prstGeom prst="rect">
             <a:avLst/>

</xml_diff>

<commit_message>
docs(defense): add an algorithm-trace slide, soften the background, visible VM advice
New slide 7 answers "what does the algorithm actually look like" with
a real screenshot of effexplain, a debugging tool built for the
algorithm itself, reasoning about a real command - not the chat
interface, the algorithm's own trace. Captured against a new real,
locally-browsable demo folder (~/Documents/SynapseOS-Demo-Algorithm),
consistent with the other two real-footage slides.

Background softened from stark white to a light gray page with white
cards (F6F8FA/FFFFFF) - pure white read as too extreme on screen.
Slide 5's note simplified further after reading as too deep on a first
pass. Slide 14's adviser advice to rent a cloud testing machine is now
a visible callout on the slide, not just in the speaker note.
</commit_message>
<xml_diff>
--- a/thesis 1/defense/SynapseOS_Proposal_Defense.pptx
+++ b/thesis 1/defense/SynapseOS_Proposal_Defense.pptx
@@ -23,9 +23,10 @@
     <p:sldId id="271" r:id="rId17"/>
     <p:sldId id="272" r:id="rId18"/>
     <p:sldId id="273" r:id="rId19"/>
+    <p:sldId id="274" r:id="rId20"/>
   </p:sldIdLst>
   <p:notesMasterIdLst>
-    <p:notesMasterId r:id="rId20"/>
+    <p:notesMasterId r:id="rId21"/>
   </p:notesMasterIdLst>
   <p:sldSz cx="12192000" cy="6858000"/>
   <p:notesSz cx="6858000" cy="12192000"/>
@@ -1213,7 +1214,7 @@
           <a:p>
             <a:r>
               <a:rPr lang="en-US" dirty="0"/>
-              <a:t>This chart shows how often each approach silently destroys data the user never agreed to lose. The method most tools use today — a list of known-dangerous commands — fails over 40 percent of the time. Our algorithm brings that down to essentially zero, matching the safest possible approach.</a:t>
+              <a:t>This research has two separate parts: the safety algorithm, and the chat interface. We test the algorithm against hundreds of sample commands, with no human volunteers needed at all. We test the interface with 40 real users, comparing it to the computer they already use — once that study is cleared to run.</a:t>
             </a:r>
             <a:endParaRPr lang="en-US" dirty="0"/>
           </a:p>
@@ -1301,7 +1302,7 @@
           <a:p>
             <a:r>
               <a:rPr lang="en-US" dirty="0"/>
-              <a:t>This chart shows how often each approach actually recovers data after something is deleted. Being safe isn't enough by itself — a system that blocks everything is 'safe' too, but saves nothing. Our algorithm recovers the lost data about 9 times out of 10; the overly-cautious approach recovers none of it, because it never tries to.</a:t>
+              <a:t>This chart shows how often each approach silently destroys data the user never agreed to lose. The method most tools use today — a list of known-dangerous commands — fails over 40 percent of the time. Our algorithm brings that down to essentially zero, matching the safest possible approach.</a:t>
             </a:r>
             <a:endParaRPr lang="en-US" dirty="0"/>
           </a:p>
@@ -1389,7 +1390,7 @@
           <a:p>
             <a:r>
               <a:rPr lang="en-US" dirty="0"/>
-              <a:t>On screen is how we'll test the interface with real people: comparing SynapseOS against whatever computer and operating system each person already uses every day. We're recruiting two kinds of users on purpose — people who struggle with both existing options, and people fluent in both — because the gap between those two groups is what we actually care about measuring.</a:t>
+              <a:t>This chart shows how often each approach actually recovers data after something is deleted. Being safe isn't enough by itself — a system that blocks everything is 'safe' too, but saves nothing. Our algorithm recovers the lost data about 9 times out of 10; the overly-cautious approach recovers none of it, because it never tries to.</a:t>
             </a:r>
             <a:endParaRPr lang="en-US" dirty="0"/>
           </a:p>
@@ -1477,7 +1478,7 @@
           <a:p>
             <a:r>
               <a:rPr lang="en-US" dirty="0"/>
-              <a:t>What's on screen is our adviser's own feedback, word for word: manage your scope carefully. Fair — we are managing a research algorithm and an entirely new interface at the same time. Period. Our answer: the algorithm and getting the interface running are non-negotiable; fine-tuning the model and the full user study are real plans, but the first things we'd trim if time runs short. Our adviser also advised renting a cloud machine for testing instead of buying new hardware, which keeps our costs down.</a:t>
+              <a:t>On screen is how we'll test the interface with real people: comparing SynapseOS against whatever computer and operating system each person already uses every day. We're recruiting two kinds of users on purpose — people who struggle with both existing options, and people fluent in both — because the gap between those two groups is what we actually care about measuring.</a:t>
             </a:r>
             <a:endParaRPr lang="en-US" dirty="0"/>
           </a:p>
@@ -1565,7 +1566,7 @@
           <a:p>
             <a:r>
               <a:rPr lang="en-US" dirty="0"/>
-              <a:t>Here's where we actually stand. The algorithm is essentially done — round seven is our reported result. The interface build is underway. Testing used to be a real bottleneck, since destructive testing needs a disposable machine we're willing to break — but thanks to our adviser's advice, we're renting a cloud machine instead of buying new hardware, so that's solved, not blocking us.</a:t>
+              <a:t>What's on screen is our adviser's own feedback, word for word: manage your scope carefully. Fair — we are managing a research algorithm and an entirely new interface at the same time. Period. Our answer: the algorithm and getting the interface running are non-negotiable; fine-tuning the model and the full user study are real plans, but the first things we'd trim if time runs short. Our adviser also advised renting a cloud machine for testing instead of buying new hardware, which keeps our costs down.</a:t>
             </a:r>
             <a:endParaRPr lang="en-US" dirty="0"/>
           </a:p>
@@ -1653,7 +1654,7 @@
           <a:p>
             <a:r>
               <a:rPr lang="en-US" dirty="0"/>
-              <a:t>Before you ask — here's a question our adviser already raised in an earlier review, so we're putting it on screen and answering it ourselves. Please read the quote above. Our answer today is words, not a number yet: the table underneath the algorithm is itself just a list, and what we're actually claiming credit for is what's built on top of it. We already have a concrete plan to turn that into an actual measured number.</a:t>
+              <a:t>Here's where we actually stand. The algorithm is essentially done — round seven is our reported result. The interface build is underway. Testing used to be a real bottleneck, since destructive testing needs a disposable machine we're willing to break — but thanks to our adviser's advice, we're renting a cloud machine instead of buying new hardware, so that's solved, not blocking us.</a:t>
             </a:r>
             <a:endParaRPr lang="en-US" dirty="0"/>
           </a:p>
@@ -1741,7 +1742,7 @@
           <a:p>
             <a:r>
               <a:rPr lang="en-US" dirty="0"/>
-              <a:t>As soon as this project succeeds, it delivers two separate results: a safer, more useful way to catch dangerous commands, and the first real evidence on whether talking to a computer actually helps people who struggle with existing interfaces. Each result stands on its own, even if the other is delayed.</a:t>
+              <a:t>Before you ask — here's a question our adviser already raised in an earlier review, so we're putting it on screen and answering it ourselves. Please read the quote above. Our answer today is words, not a number yet: the table underneath the algorithm is itself just a list, and what we're actually claiming credit for is what's built on top of it. We already have a concrete plan to turn that into an actual measured number.</a:t>
             </a:r>
             <a:endParaRPr lang="en-US" dirty="0"/>
           </a:p>
@@ -1829,7 +1830,7 @@
           <a:p>
             <a:r>
               <a:rPr lang="en-US" dirty="0"/>
-              <a:t>Once this proposal is approved, here's what happens next: we set up our rented testing machine, finish building the interface, and run the full study with real participants. The next time we present, we'll be showing actual results instead of a plan.</a:t>
+              <a:t>As soon as this project succeeds, it delivers two separate results: a safer, more useful way to catch dangerous commands, and the first real evidence on whether talking to a computer actually helps people who struggle with existing interfaces. Each result stands on its own, even if the other is delayed.</a:t>
             </a:r>
             <a:endParaRPr lang="en-US" dirty="0"/>
           </a:p>
@@ -1917,7 +1918,7 @@
           <a:p>
             <a:r>
               <a:rPr lang="en-US" dirty="0"/>
-              <a:t>Thank you for your time and consideration today. We're glad to take any questions you have about the plan, the algorithm, or anything else we've covered.</a:t>
+              <a:t>Once this proposal is approved, here's what happens next: we set up our rented testing machine, finish building the interface, and run the full study with real participants. The next time we present, we'll be showing actual results instead of a plan.</a:t>
             </a:r>
             <a:endParaRPr lang="en-US" dirty="0"/>
           </a:p>
@@ -1941,6 +1942,94 @@
             <a:fld id="{F7021451-1387-4CA6-816F-3879F97B5CBC}" type="slidenum">
               <a:rPr lang="en-US"/>
               <a:t>18</a:t>
+            </a:fld>
+            <a:endParaRPr lang="en-US"/>
+          </a:p>
+        </p:txBody>
+      </p:sp>
+    </p:spTree>
+    <p:extLst>
+      <p:ext uri="{BB962C8B-B14F-4D97-AF65-F5344CB8AC3E}">
+        <p14:creationId xmlns:p14="http://schemas.microsoft.com/office/powerpoint/2010/main" val="1024086991"/>
+      </p:ext>
+    </p:extLst>
+  </p:cSld>
+  <p:clrMapOvr>
+    <a:masterClrMapping/>
+  </p:clrMapOvr>
+</p:notes>
+</file>
+
+<file path=ppt/notesSlides/notesSlide19.xml><?xml version="1.0" encoding="utf-8"?>
+<p:notes xmlns:a="http://schemas.openxmlformats.org/drawingml/2006/main" xmlns:r="http://schemas.openxmlformats.org/officeDocument/2006/relationships" xmlns:p="http://schemas.openxmlformats.org/presentationml/2006/main">
+  <p:cSld>
+    <p:spTree>
+      <p:nvGrpSpPr>
+        <p:cNvPr id="1" name=""/>
+        <p:cNvGrpSpPr/>
+        <p:nvPr/>
+      </p:nvGrpSpPr>
+      <p:grpSpPr>
+        <a:xfrm>
+          <a:off x="0" y="0"/>
+          <a:ext cx="0" cy="0"/>
+          <a:chOff x="0" y="0"/>
+          <a:chExt cx="0" cy="0"/>
+        </a:xfrm>
+      </p:grpSpPr>
+      <p:sp>
+        <p:nvSpPr>
+          <p:cNvPr id="2" name="Slide Image Placeholder 1"/>
+          <p:cNvSpPr>
+            <a:spLocks noGrp="1" noRot="1" noChangeAspect="1"/>
+          </p:cNvSpPr>
+          <p:nvPr>
+            <p:ph type="sldImg"/>
+          </p:nvPr>
+        </p:nvSpPr>
+        <p:spPr/>
+      </p:sp>
+      <p:sp>
+        <p:nvSpPr>
+          <p:cNvPr id="3" name="Notes Placeholder 2"/>
+          <p:cNvSpPr>
+            <a:spLocks noGrp="1"/>
+          </p:cNvSpPr>
+          <p:nvPr>
+            <p:ph type="body" idx="1"/>
+          </p:nvPr>
+        </p:nvSpPr>
+        <p:spPr/>
+        <p:txBody>
+          <a:bodyPr/>
+          <a:lstStyle/>
+          <a:p>
+            <a:r>
+              <a:rPr lang="en-US" dirty="0"/>
+              <a:t>Thank you for your time and consideration today. We're glad to take any questions you have about the plan, the algorithm, or anything else we've covered.</a:t>
+            </a:r>
+            <a:endParaRPr lang="en-US" dirty="0"/>
+          </a:p>
+        </p:txBody>
+      </p:sp>
+      <p:sp>
+        <p:nvSpPr>
+          <p:cNvPr id="4" name="Slide Number Placeholder 3"/>
+          <p:cNvSpPr>
+            <a:spLocks noGrp="1"/>
+          </p:cNvSpPr>
+          <p:nvPr>
+            <p:ph type="sldNum" sz="quarter" idx="10"/>
+          </p:nvPr>
+        </p:nvSpPr>
+        <p:spPr/>
+        <p:txBody>
+          <a:bodyPr/>
+          <a:lstStyle/>
+          <a:p>
+            <a:fld id="{F7021451-1387-4CA6-816F-3879F97B5CBC}" type="slidenum">
+              <a:rPr lang="en-US"/>
+              <a:t>19</a:t>
             </a:fld>
             <a:endParaRPr lang="en-US"/>
           </a:p>
@@ -2269,7 +2358,7 @@
           <a:p>
             <a:r>
               <a:rPr lang="en-US" dirty="0"/>
-              <a:t>On screen is the four-step flow every system like this follows: understand the request, decide what to do, act on the computer, then fit into the existing desktop. SynapseOS follows the same four steps, and the safety algorithm we'll cover next sits in the third step — right before anything actually runs.</a:t>
+              <a:t>On screen is simply the four-step flow behind a system like this: understand what you asked, decide what to do, act on the computer, then fit into your existing desktop. SynapseOS follows this same flow, and the safety check we'll show next happens right before anything actually runs.</a:t>
             </a:r>
             <a:endParaRPr lang="en-US" dirty="0"/>
           </a:p>
@@ -2445,7 +2534,7 @@
           <a:p>
             <a:r>
               <a:rPr lang="en-US" dirty="0"/>
-              <a:t>If an AI types commands for you, it might delete something important before you even notice. Today's safety checks only look at whether a command looks familiar, not at what it actually does — so you either let unfamiliar commands through and risk damage, or block everything and get interrupted constantly. Our algorithm lives in real code, not a formula — in our repository, under internal/effects — and it actually reads what a command would do before deciding.</a:t>
+              <a:t>This is the algorithm itself running, not the friendly chat interface you just saw — a debugging tool we built called effexplain. Give it a command, and it shows exactly how it reasons: it sees through the find-exec wrapper, works out the real files it would touch, and labels the result recoverable, with a plan to capture those files first. This is what's actually happening underneath the conversation from a moment ago.</a:t>
             </a:r>
             <a:endParaRPr lang="en-US" dirty="0"/>
           </a:p>
@@ -2533,7 +2622,7 @@
           <a:p>
             <a:r>
               <a:rPr lang="en-US" dirty="0"/>
-              <a:t>Our algorithm does two things. It sees through tricks that hide what a command really does, like chaining several commands together. And when it can't know a command's target in advance, it does a safe test run first to find out. Anything it doesn't understand, it simply stops and asks — it never guesses.</a:t>
+              <a:t>If an AI types commands for you, it might delete something important before you even notice. Today's safety checks only look at whether a command looks familiar, not at what it actually does — so you either let unfamiliar commands through and risk damage, or block everything and get interrupted constantly. Our algorithm lives in real code, not a formula — in our repository, under internal/effects — and it actually reads what a command would do before deciding.</a:t>
             </a:r>
             <a:endParaRPr lang="en-US" dirty="0"/>
           </a:p>
@@ -2621,7 +2710,7 @@
           <a:p>
             <a:r>
               <a:rPr lang="en-US" dirty="0"/>
-              <a:t>This research has two separate parts: the safety algorithm, and the chat interface. We test the algorithm against hundreds of sample commands, with no human volunteers needed at all. We test the interface with 40 real users, comparing it to the computer they already use — once that study is cleared to run.</a:t>
+              <a:t>Our algorithm does two things. It sees through tricks that hide what a command really does, like chaining several commands together. And when it can't know a command's target in advance, it does a safe test run first to find out. Anything it doesn't understand, it simply stops and asks — it never guesses.</a:t>
             </a:r>
             <a:endParaRPr lang="en-US" dirty="0"/>
           </a:p>
@@ -2699,7 +2788,7 @@
     <p:bg>
       <p:bgPr>
         <a:solidFill>
-          <a:srgbClr val="FFFFFF"/>
+          <a:srgbClr val="F6F8FA"/>
         </a:solidFill>
       </p:bgPr>
     </p:bg>
@@ -2815,7 +2904,7 @@
     <p:bg>
       <p:bgPr>
         <a:solidFill>
-          <a:srgbClr val="FFFFFF"/>
+          <a:srgbClr val="F6F8FA"/>
         </a:solidFill>
       </p:bgPr>
     </p:bg>
@@ -3018,7 +3107,7 @@
     <p:bg>
       <p:bgPr>
         <a:solidFill>
-          <a:srgbClr val="FFFFFF"/>
+          <a:srgbClr val="F6F8FA"/>
         </a:solidFill>
       </p:bgPr>
     </p:bg>
@@ -3714,38 +3803,49 @@
                 <a:ea typeface="Courier New" pitchFamily="34" charset="-122"/>
                 <a:cs typeface="Courier New" pitchFamily="34" charset="-120"/>
               </a:rPr>
-              <a:t>Algorithm Result — Silent Data Loss</a:t>
+              <a:t>Evaluation Design — Two Independent Studies</a:t>
             </a:r>
             <a:endParaRPr lang="en-US" sz="3400" dirty="0"/>
           </a:p>
         </p:txBody>
       </p:sp>
-      <p:graphicFrame>
-        <p:nvGraphicFramePr>
-          <p:cNvPr id="3" name="Chart 0" descr=""/>
-          <p:cNvGraphicFramePr/>
+      <p:sp>
+        <p:nvSpPr>
+          <p:cNvPr id="3" name="Shape 1"/>
+          <p:cNvSpPr/>
           <p:nvPr/>
-        </p:nvGraphicFramePr>
-        <p:xfrm>
-          <a:off x="2194560" y="1554480"/>
-          <a:ext cx="7772400" cy="4480560"/>
-        </p:xfrm>
-        <a:graphic xmlns:a="http://schemas.openxmlformats.org/drawingml/2006/main">
-          <a:graphicData uri="http://schemas.openxmlformats.org/drawingml/2006/chart">
-            <c:chart xmlns:c="http://schemas.openxmlformats.org/drawingml/2006/chart" r:id="rId1"/>
-          </a:graphicData>
-        </a:graphic>
-      </p:graphicFrame>
-      <p:sp>
-        <p:nvSpPr>
-          <p:cNvPr id="4" name="Text 1"/>
+        </p:nvSpPr>
+        <p:spPr>
+          <a:xfrm>
+            <a:off x="548640" y="1554480"/>
+            <a:ext cx="5349240" cy="4297680"/>
+          </a:xfrm>
+          <a:prstGeom prst="roundRect">
+            <a:avLst>
+              <a:gd name="adj" fmla="val 1702"/>
+            </a:avLst>
+          </a:prstGeom>
+          <a:solidFill>
+            <a:srgbClr val="FFFFFF"/>
+          </a:solidFill>
+          <a:ln w="15240">
+            <a:solidFill>
+              <a:srgbClr val="1A7F37"/>
+            </a:solidFill>
+            <a:prstDash val="solid"/>
+          </a:ln>
+        </p:spPr>
+      </p:sp>
+      <p:sp>
+        <p:nvSpPr>
+          <p:cNvPr id="4" name="Text 2"/>
           <p:cNvSpPr txBox="1"/>
           <p:nvPr/>
         </p:nvSpPr>
         <p:spPr>
           <a:xfrm>
-            <a:off x="548640" y="6172200"/>
-            <a:ext cx="11064240" cy="365760"/>
+            <a:off x="822960" y="1783080"/>
+            <a:ext cx="4800600" cy="502920"/>
           </a:xfrm>
           <a:prstGeom prst="rect">
             <a:avLst/>
@@ -3761,17 +3861,301 @@
               <a:buNone/>
             </a:pPr>
             <a:r>
-              <a:rPr lang="en-US" sz="1300" i="1" dirty="0">
-                <a:solidFill>
-                  <a:schemeClr val="bg2"/>
-                </a:solidFill>
-                <a:latin typeface="Calibri" pitchFamily="34" charset="0"/>
-                <a:ea typeface="Calibri" pitchFamily="34" charset="-122"/>
-                <a:cs typeface="Calibri" pitchFamily="34" charset="-120"/>
-              </a:rPr>
-              <a:t>Out of 405 commands that touch something outside the filesystem or lose data.</a:t>
-            </a:r>
-            <a:endParaRPr lang="en-US" sz="1300" dirty="0"/>
+              <a:rPr lang="en-US" sz="1900" b="1" dirty="0">
+                <a:solidFill>
+                  <a:srgbClr val="1A7F37"/>
+                </a:solidFill>
+                <a:latin typeface="Courier New" pitchFamily="34" charset="0"/>
+                <a:ea typeface="Courier New" pitchFamily="34" charset="-122"/>
+                <a:cs typeface="Courier New" pitchFamily="34" charset="-120"/>
+              </a:rPr>
+              <a:t>Algorithm study (RQ1)</a:t>
+            </a:r>
+            <a:endParaRPr lang="en-US" sz="1900" dirty="0"/>
+          </a:p>
+        </p:txBody>
+      </p:sp>
+      <p:sp>
+        <p:nvSpPr>
+          <p:cNvPr id="5" name="Text 3"/>
+          <p:cNvSpPr txBox="1"/>
+          <p:nvPr/>
+        </p:nvSpPr>
+        <p:spPr>
+          <a:xfrm>
+            <a:off x="822960" y="2377440"/>
+            <a:ext cx="4800600" cy="3383280"/>
+          </a:xfrm>
+          <a:prstGeom prst="rect">
+            <a:avLst/>
+          </a:prstGeom>
+          <a:noFill/>
+          <a:ln/>
+        </p:spPr>
+        <p:txBody>
+          <a:bodyPr wrap="square" lIns="0" tIns="0" rIns="0" bIns="0" rtlCol="0" anchor="ctr"/>
+          <a:lstStyle/>
+          <a:p>
+            <a:pPr marL="342900" indent="-342900">
+              <a:spcAft>
+                <a:spcPts val="1200"/>
+              </a:spcAft>
+              <a:buSzPct val="100000"/>
+              <a:buChar char="▸"/>
+            </a:pPr>
+            <a:r>
+              <a:rPr lang="en-US" sz="1600" dirty="0">
+                <a:solidFill>
+                  <a:schemeClr val="bg1"/>
+                </a:solidFill>
+              </a:rPr>
+              <a:t>Corpus-based — no participants</a:t>
+            </a:r>
+            <a:endParaRPr lang="en-US" sz="1600" dirty="0"/>
+          </a:p>
+          <a:p>
+            <a:pPr marL="342900" indent="-342900">
+              <a:spcAft>
+                <a:spcPts val="1200"/>
+              </a:spcAft>
+              <a:buSzPct val="100000"/>
+              <a:buChar char="▸"/>
+            </a:pPr>
+            <a:r>
+              <a:rPr lang="en-US" sz="1600" dirty="0">
+                <a:solidFill>
+                  <a:schemeClr val="bg1"/>
+                </a:solidFill>
+              </a:rPr>
+              <a:t>Held-out commands, sandboxed ground truth</a:t>
+            </a:r>
+            <a:endParaRPr lang="en-US" sz="1600" dirty="0"/>
+          </a:p>
+          <a:p>
+            <a:pPr marL="342900" indent="-342900">
+              <a:spcAft>
+                <a:spcPts val="1200"/>
+              </a:spcAft>
+              <a:buSzPct val="100000"/>
+              <a:buChar char="▸"/>
+            </a:pPr>
+            <a:r>
+              <a:rPr lang="en-US" sz="1600" dirty="0">
+                <a:solidFill>
+                  <a:schemeClr val="bg1"/>
+                </a:solidFill>
+              </a:rPr>
+              <a:t>Three baselines: pattern list, fail-closed list, algorithm</a:t>
+            </a:r>
+            <a:endParaRPr lang="en-US" sz="1600" dirty="0"/>
+          </a:p>
+          <a:p>
+            <a:pPr marL="342900" indent="-342900">
+              <a:spcAft>
+                <a:spcPts val="1200"/>
+              </a:spcAft>
+              <a:buSzPct val="100000"/>
+              <a:buChar char="▸"/>
+            </a:pPr>
+            <a:r>
+              <a:rPr lang="en-US" sz="1600" dirty="0">
+                <a:solidFill>
+                  <a:schemeClr val="bg1"/>
+                </a:solidFill>
+              </a:rPr>
+              <a:t>Answers RQ1 independently</a:t>
+            </a:r>
+            <a:endParaRPr lang="en-US" sz="1600" dirty="0"/>
+          </a:p>
+        </p:txBody>
+      </p:sp>
+      <p:sp>
+        <p:nvSpPr>
+          <p:cNvPr id="6" name="Shape 4"/>
+          <p:cNvSpPr/>
+          <p:nvPr/>
+        </p:nvSpPr>
+        <p:spPr>
+          <a:xfrm>
+            <a:off x="6172200" y="1554480"/>
+            <a:ext cx="5349240" cy="4297680"/>
+          </a:xfrm>
+          <a:prstGeom prst="roundRect">
+            <a:avLst>
+              <a:gd name="adj" fmla="val 1702"/>
+            </a:avLst>
+          </a:prstGeom>
+          <a:solidFill>
+            <a:srgbClr val="FFFFFF"/>
+          </a:solidFill>
+          <a:ln w="15240">
+            <a:solidFill>
+              <a:srgbClr val="0969DA"/>
+            </a:solidFill>
+            <a:prstDash val="solid"/>
+          </a:ln>
+        </p:spPr>
+      </p:sp>
+      <p:sp>
+        <p:nvSpPr>
+          <p:cNvPr id="7" name="Text 5"/>
+          <p:cNvSpPr txBox="1"/>
+          <p:nvPr/>
+        </p:nvSpPr>
+        <p:spPr>
+          <a:xfrm>
+            <a:off x="6446520" y="1783080"/>
+            <a:ext cx="4800600" cy="502920"/>
+          </a:xfrm>
+          <a:prstGeom prst="rect">
+            <a:avLst/>
+          </a:prstGeom>
+          <a:noFill/>
+          <a:ln/>
+        </p:spPr>
+        <p:txBody>
+          <a:bodyPr wrap="square" lIns="0" tIns="0" rIns="0" bIns="0" rtlCol="0" anchor="ctr"/>
+          <a:lstStyle/>
+          <a:p>
+            <a:pPr indent="0" marL="0">
+              <a:buNone/>
+            </a:pPr>
+            <a:r>
+              <a:rPr lang="en-US" sz="1900" b="1" dirty="0">
+                <a:solidFill>
+                  <a:srgbClr val="0969DA"/>
+                </a:solidFill>
+                <a:latin typeface="Courier New" pitchFamily="34" charset="0"/>
+                <a:ea typeface="Courier New" pitchFamily="34" charset="-122"/>
+                <a:cs typeface="Courier New" pitchFamily="34" charset="-120"/>
+              </a:rPr>
+              <a:t>User study (RQ2–4)</a:t>
+            </a:r>
+            <a:endParaRPr lang="en-US" sz="1900" dirty="0"/>
+          </a:p>
+        </p:txBody>
+      </p:sp>
+      <p:sp>
+        <p:nvSpPr>
+          <p:cNvPr id="8" name="Text 6"/>
+          <p:cNvSpPr txBox="1"/>
+          <p:nvPr/>
+        </p:nvSpPr>
+        <p:spPr>
+          <a:xfrm>
+            <a:off x="6446520" y="2377440"/>
+            <a:ext cx="4800600" cy="3383280"/>
+          </a:xfrm>
+          <a:prstGeom prst="rect">
+            <a:avLst/>
+          </a:prstGeom>
+          <a:noFill/>
+          <a:ln/>
+        </p:spPr>
+        <p:txBody>
+          <a:bodyPr wrap="square" lIns="0" tIns="0" rIns="0" bIns="0" rtlCol="0" anchor="ctr"/>
+          <a:lstStyle/>
+          <a:p>
+            <a:pPr marL="342900" indent="-342900">
+              <a:spcAft>
+                <a:spcPts val="1200"/>
+              </a:spcAft>
+              <a:buSzPct val="100000"/>
+              <a:buChar char="▸"/>
+            </a:pPr>
+            <a:r>
+              <a:rPr lang="en-US" sz="1600" dirty="0">
+                <a:solidFill>
+                  <a:schemeClr val="bg1"/>
+                </a:solidFill>
+              </a:rPr>
+              <a:t>40 participants, within-subjects</a:t>
+            </a:r>
+            <a:endParaRPr lang="en-US" sz="1600" dirty="0"/>
+          </a:p>
+          <a:p>
+            <a:pPr marL="342900" indent="-342900">
+              <a:spcAft>
+                <a:spcPts val="1200"/>
+              </a:spcAft>
+              <a:buSzPct val="100000"/>
+              <a:buChar char="▸"/>
+            </a:pPr>
+            <a:r>
+              <a:rPr lang="en-US" sz="1600" dirty="0">
+                <a:solidFill>
+                  <a:schemeClr val="bg1"/>
+                </a:solidFill>
+              </a:rPr>
+              <a:t>Each person vs. their own daily OS</a:t>
+            </a:r>
+            <a:endParaRPr lang="en-US" sz="1600" dirty="0"/>
+          </a:p>
+          <a:p>
+            <a:pPr marL="342900" indent="-342900">
+              <a:spcAft>
+                <a:spcPts val="1200"/>
+              </a:spcAft>
+              <a:buSzPct val="100000"/>
+              <a:buChar char="▸"/>
+            </a:pPr>
+            <a:r>
+              <a:rPr lang="en-US" sz="1600" dirty="0">
+                <a:solidFill>
+                  <a:schemeClr val="bg1"/>
+                </a:solidFill>
+              </a:rPr>
+              <a:t>OSWorld + custom cross-platform task suite</a:t>
+            </a:r>
+            <a:endParaRPr lang="en-US" sz="1600" dirty="0"/>
+          </a:p>
+          <a:p>
+            <a:pPr marL="342900" indent="-342900">
+              <a:spcAft>
+                <a:spcPts val="1200"/>
+              </a:spcAft>
+              <a:buSzPct val="100000"/>
+              <a:buChar char="▸"/>
+            </a:pPr>
+            <a:r>
+              <a:rPr lang="en-US" sz="1600" dirty="0">
+                <a:solidFill>
+                  <a:schemeClr val="bg1"/>
+                </a:solidFill>
+              </a:rPr>
+              <a:t>Awaiting clearance to begin</a:t>
+            </a:r>
+            <a:endParaRPr lang="en-US" sz="1600" dirty="0"/>
+          </a:p>
+        </p:txBody>
+      </p:sp>
+      <p:sp>
+        <p:nvSpPr>
+          <p:cNvPr id="10" name="Text 0"/>
+          <p:cNvSpPr/>
+          <p:nvPr>
+            <p:ph idx="101" type="body" hasCustomPrompt="1"/>
+          </p:nvPr>
+        </p:nvSpPr>
+        <p:spPr>
+          <a:xfrm>
+            <a:off x="548640" y="1463040"/>
+            <a:ext cx="11064240" cy="4983480"/>
+          </a:xfrm>
+          <a:prstGeom prst="rect">
+            <a:avLst/>
+          </a:prstGeom>
+          <a:noFill/>
+          <a:ln/>
+        </p:spPr>
+        <p:txBody>
+          <a:bodyPr wrap="square" rtlCol="0" anchor="t"/>
+          <a:lstStyle/>
+          <a:p>
+            <a:pPr algn="l" indent="0" marL="0">
+              <a:buNone/>
+            </a:pPr>
+            <a:endParaRPr lang="en-US" sz="1900" dirty="0"/>
           </a:p>
         </p:txBody>
       </p:sp>
@@ -3883,7 +4267,7 @@
                 <a:ea typeface="Courier New" pitchFamily="34" charset="-122"/>
                 <a:cs typeface="Courier New" pitchFamily="34" charset="-120"/>
               </a:rPr>
-              <a:t>Algorithm Result — Restoration Coverage</a:t>
+              <a:t>Algorithm Result — Silent Data Loss</a:t>
             </a:r>
             <a:endParaRPr lang="en-US" sz="3400" dirty="0"/>
           </a:p>
@@ -3938,7 +4322,7 @@
                 <a:ea typeface="Calibri" pitchFamily="34" charset="-122"/>
                 <a:cs typeface="Calibri" pitchFamily="34" charset="-120"/>
               </a:rPr>
-              <a:t>Single-annotator corpus, one held-out round — a second annotator and a larger sample are still open (open-problems.md, row 27).</a:t>
+              <a:t>Out of 405 commands that touch something outside the filesystem or lose data.</a:t>
             </a:r>
             <a:endParaRPr lang="en-US" sz="1300" dirty="0"/>
           </a:p>
@@ -4052,24 +4436,38 @@
                 <a:ea typeface="Courier New" pitchFamily="34" charset="-122"/>
                 <a:cs typeface="Courier New" pitchFamily="34" charset="-120"/>
               </a:rPr>
-              <a:t>Interface Evaluation Plan (RQ2–4)</a:t>
+              <a:t>Algorithm Result — Restoration Coverage</a:t>
             </a:r>
             <a:endParaRPr lang="en-US" sz="3400" dirty="0"/>
           </a:p>
         </p:txBody>
       </p:sp>
-      <p:sp>
-        <p:nvSpPr>
-          <p:cNvPr id="3" name="Text 0"/>
-          <p:cNvSpPr/>
-          <p:nvPr>
-            <p:ph idx="101" type="body" hasCustomPrompt="1"/>
-          </p:nvPr>
-        </p:nvSpPr>
-        <p:spPr>
-          <a:xfrm>
-            <a:off x="548640" y="1463040"/>
-            <a:ext cx="11064240" cy="4983480"/>
+      <p:graphicFrame>
+        <p:nvGraphicFramePr>
+          <p:cNvPr id="3" name="Chart 0" descr=""/>
+          <p:cNvGraphicFramePr/>
+          <p:nvPr/>
+        </p:nvGraphicFramePr>
+        <p:xfrm>
+          <a:off x="2194560" y="1554480"/>
+          <a:ext cx="7772400" cy="4480560"/>
+        </p:xfrm>
+        <a:graphic xmlns:a="http://schemas.openxmlformats.org/drawingml/2006/main">
+          <a:graphicData uri="http://schemas.openxmlformats.org/drawingml/2006/chart">
+            <c:chart xmlns:c="http://schemas.openxmlformats.org/drawingml/2006/chart" r:id="rId1"/>
+          </a:graphicData>
+        </a:graphic>
+      </p:graphicFrame>
+      <p:sp>
+        <p:nvSpPr>
+          <p:cNvPr id="4" name="Text 1"/>
+          <p:cNvSpPr txBox="1"/>
+          <p:nvPr/>
+        </p:nvSpPr>
+        <p:spPr>
+          <a:xfrm>
+            <a:off x="548640" y="6172200"/>
+            <a:ext cx="11064240" cy="365760"/>
           </a:xfrm>
           <a:prstGeom prst="rect">
             <a:avLst/>
@@ -4078,91 +4476,24 @@
           <a:ln/>
         </p:spPr>
         <p:txBody>
-          <a:bodyPr wrap="square" rtlCol="0" anchor="t"/>
-          <a:lstStyle/>
-          <a:p>
-            <a:pPr algn="l" marL="342900" indent="-342900">
-              <a:spcAft>
-                <a:spcPts val="1600"/>
-              </a:spcAft>
-              <a:buSzPct val="100000"/>
-              <a:buChar char="▸"/>
-            </a:pPr>
-            <a:r>
-              <a:rPr lang="en-US" sz="1900" dirty="0">
-                <a:solidFill>
-                  <a:schemeClr val="bg1"/>
+          <a:bodyPr wrap="square" lIns="0" tIns="0" rIns="0" bIns="0" rtlCol="0" anchor="ctr"/>
+          <a:lstStyle/>
+          <a:p>
+            <a:pPr indent="0" marL="0">
+              <a:buNone/>
+            </a:pPr>
+            <a:r>
+              <a:rPr lang="en-US" sz="1300" i="1" dirty="0">
+                <a:solidFill>
+                  <a:schemeClr val="bg2"/>
                 </a:solidFill>
                 <a:latin typeface="Calibri" pitchFamily="34" charset="0"/>
                 <a:ea typeface="Calibri" pitchFamily="34" charset="-122"/>
                 <a:cs typeface="Calibri" pitchFamily="34" charset="-120"/>
               </a:rPr>
-              <a:t>Within-subjects: 40 participants vs. their own primary OS</a:t>
-            </a:r>
-            <a:endParaRPr lang="en-US" sz="1900" dirty="0"/>
-          </a:p>
-          <a:p>
-            <a:pPr algn="l" marL="342900" indent="-342900">
-              <a:spcAft>
-                <a:spcPts val="1600"/>
-              </a:spcAft>
-              <a:buSzPct val="100000"/>
-              <a:buChar char="▸"/>
-            </a:pPr>
-            <a:r>
-              <a:rPr lang="en-US" sz="1900" dirty="0">
-                <a:solidFill>
-                  <a:schemeClr val="bg1"/>
-                </a:solidFill>
-                <a:latin typeface="Calibri" pitchFamily="34" charset="0"/>
-                <a:ea typeface="Calibri" pitchFamily="34" charset="-122"/>
-                <a:cs typeface="Calibri" pitchFamily="34" charset="-120"/>
-              </a:rPr>
-              <a:t>Two populations: fluent in neither interface, fluent in both</a:t>
-            </a:r>
-            <a:endParaRPr lang="en-US" sz="1900" dirty="0"/>
-          </a:p>
-          <a:p>
-            <a:pPr algn="l" marL="342900" indent="-342900">
-              <a:spcAft>
-                <a:spcPts val="1600"/>
-              </a:spcAft>
-              <a:buSzPct val="100000"/>
-              <a:buChar char="▸"/>
-            </a:pPr>
-            <a:r>
-              <a:rPr lang="en-US" sz="1900" dirty="0">
-                <a:solidFill>
-                  <a:schemeClr val="bg1"/>
-                </a:solidFill>
-                <a:latin typeface="Calibri" pitchFamily="34" charset="0"/>
-                <a:ea typeface="Calibri" pitchFamily="34" charset="-122"/>
-                <a:cs typeface="Calibri" pitchFamily="34" charset="-120"/>
-              </a:rPr>
-              <a:t>Tasks: OSWorld benchmark + custom cross-platform suite</a:t>
-            </a:r>
-            <a:endParaRPr lang="en-US" sz="1900" dirty="0"/>
-          </a:p>
-          <a:p>
-            <a:pPr algn="l" marL="342900" indent="-342900">
-              <a:spcAft>
-                <a:spcPts val="1600"/>
-              </a:spcAft>
-              <a:buSzPct val="100000"/>
-              <a:buChar char="▸"/>
-            </a:pPr>
-            <a:r>
-              <a:rPr lang="en-US" sz="1900" dirty="0">
-                <a:solidFill>
-                  <a:schemeClr val="bg1"/>
-                </a:solidFill>
-                <a:latin typeface="Calibri" pitchFamily="34" charset="0"/>
-                <a:ea typeface="Calibri" pitchFamily="34" charset="-122"/>
-                <a:cs typeface="Calibri" pitchFamily="34" charset="-120"/>
-              </a:rPr>
-              <a:t>Measures: completion time, error rate, SUS, NASA-TLX, interview</a:t>
-            </a:r>
-            <a:endParaRPr lang="en-US" sz="1900" dirty="0"/>
+              <a:t>Single-annotator corpus, one held-out round — a second annotator and a larger sample are still open (open-problems.md, row 27).</a:t>
+            </a:r>
+            <a:endParaRPr lang="en-US" sz="1300" dirty="0"/>
           </a:p>
         </p:txBody>
       </p:sp>
@@ -4274,7 +4605,7 @@
                 <a:ea typeface="Courier New" pitchFamily="34" charset="-122"/>
                 <a:cs typeface="Courier New" pitchFamily="34" charset="-120"/>
               </a:rPr>
-              <a:t>Scope &amp; Sequencing</a:t>
+              <a:t>Interface Evaluation Plan (RQ2–4)</a:t>
             </a:r>
             <a:endParaRPr lang="en-US" sz="3400" dirty="0"/>
           </a:p>
@@ -4282,41 +4613,16 @@
       </p:sp>
       <p:sp>
         <p:nvSpPr>
-          <p:cNvPr id="3" name="Shape 1"/>
+          <p:cNvPr id="3" name="Text 0"/>
           <p:cNvSpPr/>
-          <p:nvPr/>
-        </p:nvSpPr>
-        <p:spPr>
-          <a:xfrm>
-            <a:off x="548640" y="1554480"/>
-            <a:ext cx="11064240" cy="1920240"/>
-          </a:xfrm>
-          <a:prstGeom prst="roundRect">
-            <a:avLst>
-              <a:gd name="adj" fmla="val 3810"/>
-            </a:avLst>
-          </a:prstGeom>
-          <a:solidFill>
-            <a:srgbClr val="F3F4F6"/>
-          </a:solidFill>
-          <a:ln w="15240">
-            <a:solidFill>
-              <a:srgbClr val="9A6700"/>
-            </a:solidFill>
-            <a:prstDash val="solid"/>
-          </a:ln>
-        </p:spPr>
-      </p:sp>
-      <p:sp>
-        <p:nvSpPr>
-          <p:cNvPr id="4" name="Text 2"/>
-          <p:cNvSpPr txBox="1"/>
-          <p:nvPr/>
-        </p:nvSpPr>
-        <p:spPr>
-          <a:xfrm>
-            <a:off x="868680" y="1737360"/>
-            <a:ext cx="10424160" cy="1600200"/>
+          <p:nvPr>
+            <p:ph idx="101" type="body" hasCustomPrompt="1"/>
+          </p:nvPr>
+        </p:nvSpPr>
+        <p:spPr>
+          <a:xfrm>
+            <a:off x="548640" y="1463040"/>
+            <a:ext cx="11064240" cy="4983480"/>
           </a:xfrm>
           <a:prstGeom prst="rect">
             <a:avLst/>
@@ -4325,32 +4631,39 @@
           <a:ln/>
         </p:spPr>
         <p:txBody>
-          <a:bodyPr wrap="square" lIns="0" tIns="0" rIns="0" bIns="0" rtlCol="0" anchor="ctr"/>
-          <a:lstStyle/>
-          <a:p>
-            <a:pPr indent="0" marL="0">
-              <a:buNone/>
-            </a:pPr>
-            <a:r>
-              <a:rPr lang="en-US" sz="1900" b="1" dirty="0">
-                <a:solidFill>
-                  <a:schemeClr val="accent2"/>
+          <a:bodyPr wrap="square" rtlCol="0" anchor="t"/>
+          <a:lstStyle/>
+          <a:p>
+            <a:pPr algn="l" marL="342900" indent="-342900">
+              <a:spcAft>
+                <a:spcPts val="1600"/>
+              </a:spcAft>
+              <a:buSzPct val="100000"/>
+              <a:buChar char="▸"/>
+            </a:pPr>
+            <a:r>
+              <a:rPr lang="en-US" sz="1900" dirty="0">
+                <a:solidFill>
+                  <a:schemeClr val="bg1"/>
                 </a:solidFill>
                 <a:latin typeface="Calibri" pitchFamily="34" charset="0"/>
                 <a:ea typeface="Calibri" pitchFamily="34" charset="-122"/>
                 <a:cs typeface="Calibri" pitchFamily="34" charset="-120"/>
               </a:rPr>
-              <a:t>Responding directly to “manage scope carefully”:
-</a:t>
+              <a:t>Within-subjects: 40 participants vs. their own primary OS</a:t>
             </a:r>
             <a:endParaRPr lang="en-US" sz="1900" dirty="0"/>
           </a:p>
           <a:p>
-            <a:pPr indent="0" marL="0">
-              <a:buNone/>
-            </a:pPr>
-            <a:r>
-              <a:rPr lang="en-US" sz="1800" dirty="0">
+            <a:pPr algn="l" marL="342900" indent="-342900">
+              <a:spcAft>
+                <a:spcPts val="1600"/>
+              </a:spcAft>
+              <a:buSzPct val="100000"/>
+              <a:buChar char="▸"/>
+            </a:pPr>
+            <a:r>
+              <a:rPr lang="en-US" sz="1900" dirty="0">
                 <a:solidFill>
                   <a:schemeClr val="bg1"/>
                 </a:solidFill>
@@ -4358,77 +4671,50 @@
                 <a:ea typeface="Calibri" pitchFamily="34" charset="-122"/>
                 <a:cs typeface="Calibri" pitchFamily="34" charset="-120"/>
               </a:rPr>
-              <a:t>Algorithm + interface launch — mandatory. Model fine-tuning + full comparative study — real, but first to shrink.</a:t>
+              <a:t>Two populations: fluent in neither interface, fluent in both</a:t>
             </a:r>
             <a:endParaRPr lang="en-US" sz="1900" dirty="0"/>
           </a:p>
-        </p:txBody>
-      </p:sp>
-      <p:sp>
-        <p:nvSpPr>
-          <p:cNvPr id="5" name="Text 3"/>
-          <p:cNvSpPr txBox="1"/>
-          <p:nvPr/>
-        </p:nvSpPr>
-        <p:spPr>
-          <a:xfrm>
-            <a:off x="548640" y="3749040"/>
-            <a:ext cx="11064240" cy="731520"/>
-          </a:xfrm>
-          <a:prstGeom prst="rect">
-            <a:avLst/>
-          </a:prstGeom>
-          <a:noFill/>
-          <a:ln/>
-        </p:spPr>
-        <p:txBody>
-          <a:bodyPr wrap="square" lIns="0" tIns="0" rIns="0" bIns="0" rtlCol="0" anchor="ctr"/>
-          <a:lstStyle/>
-          <a:p>
-            <a:pPr indent="0" marL="0">
-              <a:buNone/>
-            </a:pPr>
-            <a:r>
-              <a:rPr lang="en-US" sz="1800" i="1" dirty="0">
-                <a:solidFill>
-                  <a:schemeClr val="bg2"/>
+          <a:p>
+            <a:pPr algn="l" marL="342900" indent="-342900">
+              <a:spcAft>
+                <a:spcPts val="1600"/>
+              </a:spcAft>
+              <a:buSzPct val="100000"/>
+              <a:buChar char="▸"/>
+            </a:pPr>
+            <a:r>
+              <a:rPr lang="en-US" sz="1900" dirty="0">
+                <a:solidFill>
+                  <a:schemeClr val="bg1"/>
                 </a:solidFill>
                 <a:latin typeface="Calibri" pitchFamily="34" charset="0"/>
                 <a:ea typeface="Calibri" pitchFamily="34" charset="-122"/>
                 <a:cs typeface="Calibri" pitchFamily="34" charset="-120"/>
               </a:rPr>
-              <a:t>We are managing a research algorithm and an entirely new interface at the same time. Period.</a:t>
-            </a:r>
-            <a:endParaRPr lang="en-US" sz="1800" dirty="0"/>
-          </a:p>
-        </p:txBody>
-      </p:sp>
-      <p:sp>
-        <p:nvSpPr>
-          <p:cNvPr id="7" name="Text 0"/>
-          <p:cNvSpPr/>
-          <p:nvPr>
-            <p:ph idx="101" type="body" hasCustomPrompt="1"/>
-          </p:nvPr>
-        </p:nvSpPr>
-        <p:spPr>
-          <a:xfrm>
-            <a:off x="548640" y="1463040"/>
-            <a:ext cx="11064240" cy="4983480"/>
-          </a:xfrm>
-          <a:prstGeom prst="rect">
-            <a:avLst/>
-          </a:prstGeom>
-          <a:noFill/>
-          <a:ln/>
-        </p:spPr>
-        <p:txBody>
-          <a:bodyPr wrap="square" rtlCol="0" anchor="t"/>
-          <a:lstStyle/>
-          <a:p>
-            <a:pPr algn="l" indent="0" marL="0">
-              <a:buNone/>
-            </a:pPr>
+              <a:t>Tasks: OSWorld benchmark + custom cross-platform suite</a:t>
+            </a:r>
+            <a:endParaRPr lang="en-US" sz="1900" dirty="0"/>
+          </a:p>
+          <a:p>
+            <a:pPr algn="l" marL="342900" indent="-342900">
+              <a:spcAft>
+                <a:spcPts val="1600"/>
+              </a:spcAft>
+              <a:buSzPct val="100000"/>
+              <a:buChar char="▸"/>
+            </a:pPr>
+            <a:r>
+              <a:rPr lang="en-US" sz="1900" dirty="0">
+                <a:solidFill>
+                  <a:schemeClr val="bg1"/>
+                </a:solidFill>
+                <a:latin typeface="Calibri" pitchFamily="34" charset="0"/>
+                <a:ea typeface="Calibri" pitchFamily="34" charset="-122"/>
+                <a:cs typeface="Calibri" pitchFamily="34" charset="-120"/>
+              </a:rPr>
+              <a:t>Measures: completion time, error rate, SUS, NASA-TLX, interview</a:t>
+            </a:r>
             <a:endParaRPr lang="en-US" sz="1900" dirty="0"/>
           </a:p>
         </p:txBody>
@@ -4541,7 +4827,7 @@
                 <a:ea typeface="Courier New" pitchFamily="34" charset="-122"/>
                 <a:cs typeface="Courier New" pitchFamily="34" charset="-120"/>
               </a:rPr>
-              <a:t>Current Status</a:t>
+              <a:t>Scope &amp; Sequencing</a:t>
             </a:r>
             <a:endParaRPr lang="en-US" sz="3400" dirty="0"/>
           </a:p>
@@ -4555,20 +4841,143 @@
         </p:nvSpPr>
         <p:spPr>
           <a:xfrm>
-            <a:off x="548640" y="1737360"/>
-            <a:ext cx="11064240" cy="1188720"/>
+            <a:off x="548640" y="1554480"/>
+            <a:ext cx="11064240" cy="1920240"/>
           </a:xfrm>
           <a:prstGeom prst="roundRect">
             <a:avLst>
-              <a:gd name="adj" fmla="val 4615"/>
+              <a:gd name="adj" fmla="val 3810"/>
             </a:avLst>
           </a:prstGeom>
           <a:solidFill>
-            <a:srgbClr val="F3F4F6"/>
+            <a:srgbClr val="FFFFFF"/>
+          </a:solidFill>
+          <a:ln w="15240">
+            <a:solidFill>
+              <a:srgbClr val="9A6700"/>
+            </a:solidFill>
+            <a:prstDash val="solid"/>
+          </a:ln>
+        </p:spPr>
+      </p:sp>
+      <p:sp>
+        <p:nvSpPr>
+          <p:cNvPr id="4" name="Text 2"/>
+          <p:cNvSpPr txBox="1"/>
+          <p:nvPr/>
+        </p:nvSpPr>
+        <p:spPr>
+          <a:xfrm>
+            <a:off x="868680" y="1737360"/>
+            <a:ext cx="10424160" cy="1600200"/>
+          </a:xfrm>
+          <a:prstGeom prst="rect">
+            <a:avLst/>
+          </a:prstGeom>
+          <a:noFill/>
+          <a:ln/>
+        </p:spPr>
+        <p:txBody>
+          <a:bodyPr wrap="square" lIns="0" tIns="0" rIns="0" bIns="0" rtlCol="0" anchor="ctr"/>
+          <a:lstStyle/>
+          <a:p>
+            <a:pPr indent="0" marL="0">
+              <a:buNone/>
+            </a:pPr>
+            <a:r>
+              <a:rPr lang="en-US" sz="1900" b="1" dirty="0">
+                <a:solidFill>
+                  <a:schemeClr val="accent2"/>
+                </a:solidFill>
+                <a:latin typeface="Calibri" pitchFamily="34" charset="0"/>
+                <a:ea typeface="Calibri" pitchFamily="34" charset="-122"/>
+                <a:cs typeface="Calibri" pitchFamily="34" charset="-120"/>
+              </a:rPr>
+              <a:t>Responding directly to “manage scope carefully”:
+</a:t>
+            </a:r>
+            <a:endParaRPr lang="en-US" sz="1900" dirty="0"/>
+          </a:p>
+          <a:p>
+            <a:pPr indent="0" marL="0">
+              <a:buNone/>
+            </a:pPr>
+            <a:r>
+              <a:rPr lang="en-US" sz="1800" dirty="0">
+                <a:solidFill>
+                  <a:schemeClr val="bg1"/>
+                </a:solidFill>
+                <a:latin typeface="Calibri" pitchFamily="34" charset="0"/>
+                <a:ea typeface="Calibri" pitchFamily="34" charset="-122"/>
+                <a:cs typeface="Calibri" pitchFamily="34" charset="-120"/>
+              </a:rPr>
+              <a:t>Algorithm + interface launch — mandatory. Model fine-tuning + full comparative study — real, but first to shrink.</a:t>
+            </a:r>
+            <a:endParaRPr lang="en-US" sz="1900" dirty="0"/>
+          </a:p>
+        </p:txBody>
+      </p:sp>
+      <p:sp>
+        <p:nvSpPr>
+          <p:cNvPr id="5" name="Text 3"/>
+          <p:cNvSpPr txBox="1"/>
+          <p:nvPr/>
+        </p:nvSpPr>
+        <p:spPr>
+          <a:xfrm>
+            <a:off x="548640" y="3749040"/>
+            <a:ext cx="11064240" cy="731520"/>
+          </a:xfrm>
+          <a:prstGeom prst="rect">
+            <a:avLst/>
+          </a:prstGeom>
+          <a:noFill/>
+          <a:ln/>
+        </p:spPr>
+        <p:txBody>
+          <a:bodyPr wrap="square" lIns="0" tIns="0" rIns="0" bIns="0" rtlCol="0" anchor="ctr"/>
+          <a:lstStyle/>
+          <a:p>
+            <a:pPr indent="0" marL="0">
+              <a:buNone/>
+            </a:pPr>
+            <a:r>
+              <a:rPr lang="en-US" sz="1800" i="1" dirty="0">
+                <a:solidFill>
+                  <a:schemeClr val="bg2"/>
+                </a:solidFill>
+                <a:latin typeface="Calibri" pitchFamily="34" charset="0"/>
+                <a:ea typeface="Calibri" pitchFamily="34" charset="-122"/>
+                <a:cs typeface="Calibri" pitchFamily="34" charset="-120"/>
+              </a:rPr>
+              <a:t>We are managing a research algorithm and an entirely new interface at the same time. Period.</a:t>
+            </a:r>
+            <a:endParaRPr lang="en-US" sz="1800" dirty="0"/>
+          </a:p>
+        </p:txBody>
+      </p:sp>
+      <p:sp>
+        <p:nvSpPr>
+          <p:cNvPr id="6" name="Shape 4"/>
+          <p:cNvSpPr/>
+          <p:nvPr/>
+        </p:nvSpPr>
+        <p:spPr>
+          <a:xfrm>
+            <a:off x="548640" y="4572000"/>
+            <a:ext cx="11064240" cy="914400"/>
+          </a:xfrm>
+          <a:prstGeom prst="roundRect">
+            <a:avLst>
+              <a:gd name="adj" fmla="val 8000"/>
+            </a:avLst>
+          </a:prstGeom>
+          <a:solidFill>
+            <a:srgbClr val="FFFFFF"/>
           </a:solidFill>
           <a:ln w="12700">
             <a:solidFill>
-              <a:srgbClr val="D0D7DE"/>
+              <a:srgbClr val="1A7F37"/>
             </a:solidFill>
             <a:prstDash val="solid"/>
           </a:ln>
@@ -4576,34 +4985,14 @@
       </p:sp>
       <p:sp>
         <p:nvSpPr>
-          <p:cNvPr id="4" name="Shape 2"/>
-          <p:cNvSpPr/>
-          <p:nvPr/>
-        </p:nvSpPr>
-        <p:spPr>
-          <a:xfrm>
-            <a:off x="868680" y="2231136"/>
-            <a:ext cx="237744" cy="237744"/>
-          </a:xfrm>
-          <a:prstGeom prst="ellipse">
-            <a:avLst/>
-          </a:prstGeom>
-          <a:solidFill>
-            <a:srgbClr val="1A7F37"/>
-          </a:solidFill>
-          <a:ln/>
-        </p:spPr>
-      </p:sp>
-      <p:sp>
-        <p:nvSpPr>
-          <p:cNvPr id="5" name="Text 3"/>
+          <p:cNvPr id="7" name="Text 5"/>
           <p:cNvSpPr txBox="1"/>
           <p:nvPr/>
         </p:nvSpPr>
         <p:spPr>
           <a:xfrm>
-            <a:off x="1280160" y="1874520"/>
-            <a:ext cx="4480560" cy="914400"/>
+            <a:off x="868680" y="4572000"/>
+            <a:ext cx="10424160" cy="914400"/>
           </a:xfrm>
           <a:prstGeom prst="rect">
             <a:avLst/>
@@ -4619,179 +5008,29 @@
               <a:buNone/>
             </a:pPr>
             <a:r>
-              <a:rPr lang="en-US" sz="1800" b="1" dirty="0">
-                <a:solidFill>
-                  <a:schemeClr val="bg1"/>
-                </a:solidFill>
-                <a:latin typeface="Courier New" pitchFamily="34" charset="0"/>
-                <a:ea typeface="Courier New" pitchFamily="34" charset="-122"/>
-                <a:cs typeface="Courier New" pitchFamily="34" charset="-120"/>
-              </a:rPr>
-              <a:t>Algorithm (RQ1)</a:t>
-            </a:r>
-            <a:endParaRPr lang="en-US" sz="1800" dirty="0"/>
-          </a:p>
-        </p:txBody>
-      </p:sp>
-      <p:sp>
-        <p:nvSpPr>
-          <p:cNvPr id="6" name="Text 4"/>
-          <p:cNvSpPr txBox="1"/>
-          <p:nvPr/>
-        </p:nvSpPr>
-        <p:spPr>
-          <a:xfrm>
-            <a:off x="5852160" y="1874520"/>
-            <a:ext cx="5577840" cy="914400"/>
-          </a:xfrm>
-          <a:prstGeom prst="rect">
-            <a:avLst/>
-          </a:prstGeom>
-          <a:noFill/>
-          <a:ln/>
-        </p:spPr>
-        <p:txBody>
-          <a:bodyPr wrap="square" lIns="0" tIns="0" rIns="0" bIns="0" rtlCol="0" anchor="ctr"/>
-          <a:lstStyle/>
-          <a:p>
-            <a:pPr indent="0" marL="0">
-              <a:buNone/>
-            </a:pPr>
-            <a:r>
-              <a:rPr lang="en-US" sz="1700" dirty="0">
-                <a:solidFill>
-                  <a:schemeClr val="bg2"/>
+              <a:rPr lang="en-US" sz="1700" b="1" dirty="0">
+                <a:solidFill>
+                  <a:schemeClr val="accent1"/>
                 </a:solidFill>
                 <a:latin typeface="Calibri" pitchFamily="34" charset="0"/>
                 <a:ea typeface="Calibri" pitchFamily="34" charset="-122"/>
                 <a:cs typeface="Calibri" pitchFamily="34" charset="-120"/>
               </a:rPr>
-              <a:t>Essentially done — round 7 reported</a:t>
-            </a:r>
-            <a:endParaRPr lang="en-US" sz="1700" dirty="0"/>
-          </a:p>
-        </p:txBody>
-      </p:sp>
-      <p:sp>
-        <p:nvSpPr>
-          <p:cNvPr id="7" name="Shape 5"/>
-          <p:cNvSpPr/>
-          <p:nvPr/>
-        </p:nvSpPr>
-        <p:spPr>
-          <a:xfrm>
-            <a:off x="548640" y="3108960"/>
-            <a:ext cx="11064240" cy="1188720"/>
-          </a:xfrm>
-          <a:prstGeom prst="roundRect">
-            <a:avLst>
-              <a:gd name="adj" fmla="val 4615"/>
-            </a:avLst>
-          </a:prstGeom>
-          <a:solidFill>
-            <a:srgbClr val="F3F4F6"/>
-          </a:solidFill>
-          <a:ln w="12700">
-            <a:solidFill>
-              <a:srgbClr val="D0D7DE"/>
-            </a:solidFill>
-            <a:prstDash val="solid"/>
-          </a:ln>
-        </p:spPr>
-      </p:sp>
-      <p:sp>
-        <p:nvSpPr>
-          <p:cNvPr id="8" name="Shape 6"/>
-          <p:cNvSpPr/>
-          <p:nvPr/>
-        </p:nvSpPr>
-        <p:spPr>
-          <a:xfrm>
-            <a:off x="868680" y="3602736"/>
-            <a:ext cx="237744" cy="237744"/>
-          </a:xfrm>
-          <a:prstGeom prst="ellipse">
-            <a:avLst/>
-          </a:prstGeom>
-          <a:solidFill>
-            <a:srgbClr val="9A6700"/>
-          </a:solidFill>
-          <a:ln/>
-        </p:spPr>
-      </p:sp>
-      <p:sp>
-        <p:nvSpPr>
-          <p:cNvPr id="9" name="Text 7"/>
-          <p:cNvSpPr txBox="1"/>
-          <p:nvPr/>
-        </p:nvSpPr>
-        <p:spPr>
-          <a:xfrm>
-            <a:off x="1280160" y="3246120"/>
-            <a:ext cx="4480560" cy="914400"/>
-          </a:xfrm>
-          <a:prstGeom prst="rect">
-            <a:avLst/>
-          </a:prstGeom>
-          <a:noFill/>
-          <a:ln/>
-        </p:spPr>
-        <p:txBody>
-          <a:bodyPr wrap="square" lIns="0" tIns="0" rIns="0" bIns="0" rtlCol="0" anchor="ctr"/>
-          <a:lstStyle/>
-          <a:p>
+              <a:t>Also advised: </a:t>
+            </a:r>
             <a:pPr indent="0" marL="0">
               <a:buNone/>
             </a:pPr>
             <a:r>
-              <a:rPr lang="en-US" sz="1800" b="1" dirty="0">
+              <a:rPr lang="en-US" sz="1700" dirty="0">
                 <a:solidFill>
                   <a:schemeClr val="bg1"/>
-                </a:solidFill>
-                <a:latin typeface="Courier New" pitchFamily="34" charset="0"/>
-                <a:ea typeface="Courier New" pitchFamily="34" charset="-122"/>
-                <a:cs typeface="Courier New" pitchFamily="34" charset="-120"/>
-              </a:rPr>
-              <a:t>Interface build</a:t>
-            </a:r>
-            <a:endParaRPr lang="en-US" sz="1800" dirty="0"/>
-          </a:p>
-        </p:txBody>
-      </p:sp>
-      <p:sp>
-        <p:nvSpPr>
-          <p:cNvPr id="10" name="Text 8"/>
-          <p:cNvSpPr txBox="1"/>
-          <p:nvPr/>
-        </p:nvSpPr>
-        <p:spPr>
-          <a:xfrm>
-            <a:off x="5852160" y="3246120"/>
-            <a:ext cx="5577840" cy="914400"/>
-          </a:xfrm>
-          <a:prstGeom prst="rect">
-            <a:avLst/>
-          </a:prstGeom>
-          <a:noFill/>
-          <a:ln/>
-        </p:spPr>
-        <p:txBody>
-          <a:bodyPr wrap="square" lIns="0" tIns="0" rIns="0" bIns="0" rtlCol="0" anchor="ctr"/>
-          <a:lstStyle/>
-          <a:p>
-            <a:pPr indent="0" marL="0">
-              <a:buNone/>
-            </a:pPr>
-            <a:r>
-              <a:rPr lang="en-US" sz="1700" dirty="0">
-                <a:solidFill>
-                  <a:schemeClr val="bg2"/>
                 </a:solidFill>
                 <a:latin typeface="Calibri" pitchFamily="34" charset="0"/>
                 <a:ea typeface="Calibri" pitchFamily="34" charset="-122"/>
                 <a:cs typeface="Calibri" pitchFamily="34" charset="-120"/>
               </a:rPr>
-              <a:t>In progress</a:t>
+              <a:t>rent a cloud testing machine instead of buying new hardware — keeps costs down.</a:t>
             </a:r>
             <a:endParaRPr lang="en-US" sz="1700" dirty="0"/>
           </a:p>
@@ -4799,132 +5038,7 @@
       </p:sp>
       <p:sp>
         <p:nvSpPr>
-          <p:cNvPr id="11" name="Shape 9"/>
-          <p:cNvSpPr/>
-          <p:nvPr/>
-        </p:nvSpPr>
-        <p:spPr>
-          <a:xfrm>
-            <a:off x="548640" y="4480560"/>
-            <a:ext cx="11064240" cy="1188720"/>
-          </a:xfrm>
-          <a:prstGeom prst="roundRect">
-            <a:avLst>
-              <a:gd name="adj" fmla="val 4615"/>
-            </a:avLst>
-          </a:prstGeom>
-          <a:solidFill>
-            <a:srgbClr val="F3F4F6"/>
-          </a:solidFill>
-          <a:ln w="12700">
-            <a:solidFill>
-              <a:srgbClr val="D0D7DE"/>
-            </a:solidFill>
-            <a:prstDash val="solid"/>
-          </a:ln>
-        </p:spPr>
-      </p:sp>
-      <p:sp>
-        <p:nvSpPr>
-          <p:cNvPr id="12" name="Shape 10"/>
-          <p:cNvSpPr/>
-          <p:nvPr/>
-        </p:nvSpPr>
-        <p:spPr>
-          <a:xfrm>
-            <a:off x="868680" y="4974336"/>
-            <a:ext cx="237744" cy="237744"/>
-          </a:xfrm>
-          <a:prstGeom prst="ellipse">
-            <a:avLst/>
-          </a:prstGeom>
-          <a:solidFill>
-            <a:srgbClr val="1A7F37"/>
-          </a:solidFill>
-          <a:ln/>
-        </p:spPr>
-      </p:sp>
-      <p:sp>
-        <p:nvSpPr>
-          <p:cNvPr id="13" name="Text 11"/>
-          <p:cNvSpPr txBox="1"/>
-          <p:nvPr/>
-        </p:nvSpPr>
-        <p:spPr>
-          <a:xfrm>
-            <a:off x="1280160" y="4617720"/>
-            <a:ext cx="4480560" cy="914400"/>
-          </a:xfrm>
-          <a:prstGeom prst="rect">
-            <a:avLst/>
-          </a:prstGeom>
-          <a:noFill/>
-          <a:ln/>
-        </p:spPr>
-        <p:txBody>
-          <a:bodyPr wrap="square" lIns="0" tIns="0" rIns="0" bIns="0" rtlCol="0" anchor="ctr"/>
-          <a:lstStyle/>
-          <a:p>
-            <a:pPr indent="0" marL="0">
-              <a:buNone/>
-            </a:pPr>
-            <a:r>
-              <a:rPr lang="en-US" sz="1800" b="1" dirty="0">
-                <a:solidFill>
-                  <a:schemeClr val="bg1"/>
-                </a:solidFill>
-                <a:latin typeface="Courier New" pitchFamily="34" charset="0"/>
-                <a:ea typeface="Courier New" pitchFamily="34" charset="-122"/>
-                <a:cs typeface="Courier New" pitchFamily="34" charset="-120"/>
-              </a:rPr>
-              <a:t>Testing machine</a:t>
-            </a:r>
-            <a:endParaRPr lang="en-US" sz="1800" dirty="0"/>
-          </a:p>
-        </p:txBody>
-      </p:sp>
-      <p:sp>
-        <p:nvSpPr>
-          <p:cNvPr id="14" name="Text 12"/>
-          <p:cNvSpPr txBox="1"/>
-          <p:nvPr/>
-        </p:nvSpPr>
-        <p:spPr>
-          <a:xfrm>
-            <a:off x="5852160" y="4617720"/>
-            <a:ext cx="5577840" cy="914400"/>
-          </a:xfrm>
-          <a:prstGeom prst="rect">
-            <a:avLst/>
-          </a:prstGeom>
-          <a:noFill/>
-          <a:ln/>
-        </p:spPr>
-        <p:txBody>
-          <a:bodyPr wrap="square" lIns="0" tIns="0" rIns="0" bIns="0" rtlCol="0" anchor="ctr"/>
-          <a:lstStyle/>
-          <a:p>
-            <a:pPr indent="0" marL="0">
-              <a:buNone/>
-            </a:pPr>
-            <a:r>
-              <a:rPr lang="en-US" sz="1700" dirty="0">
-                <a:solidFill>
-                  <a:schemeClr val="bg2"/>
-                </a:solidFill>
-                <a:latin typeface="Calibri" pitchFamily="34" charset="0"/>
-                <a:ea typeface="Calibri" pitchFamily="34" charset="-122"/>
-                <a:cs typeface="Calibri" pitchFamily="34" charset="-120"/>
-              </a:rPr>
-              <a:t>Solved — renting a cloud VM instead of buying hardware</a:t>
-            </a:r>
-            <a:endParaRPr lang="en-US" sz="1700" dirty="0"/>
-          </a:p>
-        </p:txBody>
-      </p:sp>
-      <p:sp>
-        <p:nvSpPr>
-          <p:cNvPr id="16" name="Text 0"/>
+          <p:cNvPr id="9" name="Text 0"/>
           <p:cNvSpPr/>
           <p:nvPr>
             <p:ph idx="101" type="body" hasCustomPrompt="1"/>
@@ -5060,7 +5174,7 @@
                 <a:ea typeface="Courier New" pitchFamily="34" charset="-122"/>
                 <a:cs typeface="Courier New" pitchFamily="34" charset="-120"/>
               </a:rPr>
-              <a:t>One Question We Want to Raise Ourselves</a:t>
+              <a:t>Current Status</a:t>
             </a:r>
             <a:endParaRPr lang="en-US" sz="3400" dirty="0"/>
           </a:p>
@@ -5074,20 +5188,20 @@
         </p:nvSpPr>
         <p:spPr>
           <a:xfrm>
-            <a:off x="822960" y="1508760"/>
-            <a:ext cx="10515600" cy="1554480"/>
+            <a:off x="548640" y="1737360"/>
+            <a:ext cx="11064240" cy="1188720"/>
           </a:xfrm>
           <a:prstGeom prst="roundRect">
             <a:avLst>
-              <a:gd name="adj" fmla="val 4706"/>
+              <a:gd name="adj" fmla="val 4615"/>
             </a:avLst>
           </a:prstGeom>
           <a:solidFill>
-            <a:srgbClr val="F3F4F6"/>
+            <a:srgbClr val="FFFFFF"/>
           </a:solidFill>
-          <a:ln w="16510">
+          <a:ln w="12700">
             <a:solidFill>
-              <a:srgbClr val="9A6700"/>
+              <a:srgbClr val="D0D7DE"/>
             </a:solidFill>
             <a:prstDash val="solid"/>
           </a:ln>
@@ -5095,14 +5209,34 @@
       </p:sp>
       <p:sp>
         <p:nvSpPr>
-          <p:cNvPr id="4" name="Text 2"/>
+          <p:cNvPr id="4" name="Shape 2"/>
+          <p:cNvSpPr/>
+          <p:nvPr/>
+        </p:nvSpPr>
+        <p:spPr>
+          <a:xfrm>
+            <a:off x="868680" y="2231136"/>
+            <a:ext cx="237744" cy="237744"/>
+          </a:xfrm>
+          <a:prstGeom prst="ellipse">
+            <a:avLst/>
+          </a:prstGeom>
+          <a:solidFill>
+            <a:srgbClr val="1A7F37"/>
+          </a:solidFill>
+          <a:ln/>
+        </p:spPr>
+      </p:sp>
+      <p:sp>
+        <p:nvSpPr>
+          <p:cNvPr id="5" name="Text 3"/>
           <p:cNvSpPr txBox="1"/>
           <p:nvPr/>
         </p:nvSpPr>
         <p:spPr>
           <a:xfrm>
-            <a:off x="1188720" y="1691640"/>
-            <a:ext cx="9784080" cy="1188720"/>
+            <a:off x="1280160" y="1874520"/>
+            <a:ext cx="4480560" cy="914400"/>
           </a:xfrm>
           <a:prstGeom prst="rect">
             <a:avLst/>
@@ -5114,34 +5248,34 @@
           <a:bodyPr wrap="square" lIns="0" tIns="0" rIns="0" bIns="0" rtlCol="0" anchor="ctr"/>
           <a:lstStyle/>
           <a:p>
-            <a:pPr algn="ctr" indent="0" marL="0">
+            <a:pPr indent="0" marL="0">
               <a:buNone/>
             </a:pPr>
             <a:r>
-              <a:rPr lang="en-US" sz="1900" i="1" dirty="0">
-                <a:solidFill>
-                  <a:schemeClr val="accent2"/>
+              <a:rPr lang="en-US" sz="1800" b="1" dirty="0">
+                <a:solidFill>
+                  <a:schemeClr val="bg1"/>
                 </a:solidFill>
                 <a:latin typeface="Courier New" pitchFamily="34" charset="0"/>
                 <a:ea typeface="Courier New" pitchFamily="34" charset="-122"/>
                 <a:cs typeface="Courier New" pitchFamily="34" charset="-120"/>
               </a:rPr>
-              <a:t>“How much of this result comes from the algorithm itself, versus the hand-built rule tables underneath it?”</a:t>
-            </a:r>
-            <a:endParaRPr lang="en-US" sz="1900" dirty="0"/>
-          </a:p>
-        </p:txBody>
-      </p:sp>
-      <p:sp>
-        <p:nvSpPr>
-          <p:cNvPr id="5" name="Text 3"/>
+              <a:t>Algorithm (RQ1)</a:t>
+            </a:r>
+            <a:endParaRPr lang="en-US" sz="1800" dirty="0"/>
+          </a:p>
+        </p:txBody>
+      </p:sp>
+      <p:sp>
+        <p:nvSpPr>
+          <p:cNvPr id="6" name="Text 4"/>
           <p:cNvSpPr txBox="1"/>
           <p:nvPr/>
         </p:nvSpPr>
         <p:spPr>
           <a:xfrm>
-            <a:off x="822960" y="3337560"/>
-            <a:ext cx="10515600" cy="2926080"/>
+            <a:off x="5852160" y="1874520"/>
+            <a:ext cx="5577840" cy="914400"/>
           </a:xfrm>
           <a:prstGeom prst="rect">
             <a:avLst/>
@@ -5153,82 +5287,277 @@
           <a:bodyPr wrap="square" lIns="0" tIns="0" rIns="0" bIns="0" rtlCol="0" anchor="ctr"/>
           <a:lstStyle/>
           <a:p>
-            <a:pPr marL="342900" indent="-342900">
-              <a:spcAft>
-                <a:spcPts val="1600"/>
-              </a:spcAft>
-              <a:buSzPct val="100000"/>
-              <a:buChar char="▸"/>
+            <a:pPr indent="0" marL="0">
+              <a:buNone/>
             </a:pPr>
             <a:r>
               <a:rPr lang="en-US" sz="1700" dirty="0">
                 <a:solidFill>
+                  <a:schemeClr val="bg2"/>
+                </a:solidFill>
+                <a:latin typeface="Calibri" pitchFamily="34" charset="0"/>
+                <a:ea typeface="Calibri" pitchFamily="34" charset="-122"/>
+                <a:cs typeface="Calibri" pitchFamily="34" charset="-120"/>
+              </a:rPr>
+              <a:t>Essentially done — round 7 reported</a:t>
+            </a:r>
+            <a:endParaRPr lang="en-US" sz="1700" dirty="0"/>
+          </a:p>
+        </p:txBody>
+      </p:sp>
+      <p:sp>
+        <p:nvSpPr>
+          <p:cNvPr id="7" name="Shape 5"/>
+          <p:cNvSpPr/>
+          <p:nvPr/>
+        </p:nvSpPr>
+        <p:spPr>
+          <a:xfrm>
+            <a:off x="548640" y="3108960"/>
+            <a:ext cx="11064240" cy="1188720"/>
+          </a:xfrm>
+          <a:prstGeom prst="roundRect">
+            <a:avLst>
+              <a:gd name="adj" fmla="val 4615"/>
+            </a:avLst>
+          </a:prstGeom>
+          <a:solidFill>
+            <a:srgbClr val="FFFFFF"/>
+          </a:solidFill>
+          <a:ln w="12700">
+            <a:solidFill>
+              <a:srgbClr val="D0D7DE"/>
+            </a:solidFill>
+            <a:prstDash val="solid"/>
+          </a:ln>
+        </p:spPr>
+      </p:sp>
+      <p:sp>
+        <p:nvSpPr>
+          <p:cNvPr id="8" name="Shape 6"/>
+          <p:cNvSpPr/>
+          <p:nvPr/>
+        </p:nvSpPr>
+        <p:spPr>
+          <a:xfrm>
+            <a:off x="868680" y="3602736"/>
+            <a:ext cx="237744" cy="237744"/>
+          </a:xfrm>
+          <a:prstGeom prst="ellipse">
+            <a:avLst/>
+          </a:prstGeom>
+          <a:solidFill>
+            <a:srgbClr val="9A6700"/>
+          </a:solidFill>
+          <a:ln/>
+        </p:spPr>
+      </p:sp>
+      <p:sp>
+        <p:nvSpPr>
+          <p:cNvPr id="9" name="Text 7"/>
+          <p:cNvSpPr txBox="1"/>
+          <p:nvPr/>
+        </p:nvSpPr>
+        <p:spPr>
+          <a:xfrm>
+            <a:off x="1280160" y="3246120"/>
+            <a:ext cx="4480560" cy="914400"/>
+          </a:xfrm>
+          <a:prstGeom prst="rect">
+            <a:avLst/>
+          </a:prstGeom>
+          <a:noFill/>
+          <a:ln/>
+        </p:spPr>
+        <p:txBody>
+          <a:bodyPr wrap="square" lIns="0" tIns="0" rIns="0" bIns="0" rtlCol="0" anchor="ctr"/>
+          <a:lstStyle/>
+          <a:p>
+            <a:pPr indent="0" marL="0">
+              <a:buNone/>
+            </a:pPr>
+            <a:r>
+              <a:rPr lang="en-US" sz="1800" b="1" dirty="0">
+                <a:solidFill>
                   <a:schemeClr val="bg1"/>
                 </a:solidFill>
-              </a:rPr>
-              <a:t>Already asked once, by our adviser</a:t>
+                <a:latin typeface="Courier New" pitchFamily="34" charset="0"/>
+                <a:ea typeface="Courier New" pitchFamily="34" charset="-122"/>
+                <a:cs typeface="Courier New" pitchFamily="34" charset="-120"/>
+              </a:rPr>
+              <a:t>Interface build</a:t>
+            </a:r>
+            <a:endParaRPr lang="en-US" sz="1800" dirty="0"/>
+          </a:p>
+        </p:txBody>
+      </p:sp>
+      <p:sp>
+        <p:nvSpPr>
+          <p:cNvPr id="10" name="Text 8"/>
+          <p:cNvSpPr txBox="1"/>
+          <p:nvPr/>
+        </p:nvSpPr>
+        <p:spPr>
+          <a:xfrm>
+            <a:off x="5852160" y="3246120"/>
+            <a:ext cx="5577840" cy="914400"/>
+          </a:xfrm>
+          <a:prstGeom prst="rect">
+            <a:avLst/>
+          </a:prstGeom>
+          <a:noFill/>
+          <a:ln/>
+        </p:spPr>
+        <p:txBody>
+          <a:bodyPr wrap="square" lIns="0" tIns="0" rIns="0" bIns="0" rtlCol="0" anchor="ctr"/>
+          <a:lstStyle/>
+          <a:p>
+            <a:pPr indent="0" marL="0">
+              <a:buNone/>
+            </a:pPr>
+            <a:r>
+              <a:rPr lang="en-US" sz="1700" dirty="0">
+                <a:solidFill>
+                  <a:schemeClr val="bg2"/>
+                </a:solidFill>
+                <a:latin typeface="Calibri" pitchFamily="34" charset="0"/>
+                <a:ea typeface="Calibri" pitchFamily="34" charset="-122"/>
+                <a:cs typeface="Calibri" pitchFamily="34" charset="-120"/>
+              </a:rPr>
+              <a:t>In progress</a:t>
             </a:r>
             <a:endParaRPr lang="en-US" sz="1700" dirty="0"/>
           </a:p>
-          <a:p>
-            <a:pPr marL="342900" indent="-342900">
-              <a:spcAft>
-                <a:spcPts val="1600"/>
-              </a:spcAft>
-              <a:buSzPct val="100000"/>
-              <a:buChar char="▸"/>
+        </p:txBody>
+      </p:sp>
+      <p:sp>
+        <p:nvSpPr>
+          <p:cNvPr id="11" name="Shape 9"/>
+          <p:cNvSpPr/>
+          <p:nvPr/>
+        </p:nvSpPr>
+        <p:spPr>
+          <a:xfrm>
+            <a:off x="548640" y="4480560"/>
+            <a:ext cx="11064240" cy="1188720"/>
+          </a:xfrm>
+          <a:prstGeom prst="roundRect">
+            <a:avLst>
+              <a:gd name="adj" fmla="val 4615"/>
+            </a:avLst>
+          </a:prstGeom>
+          <a:solidFill>
+            <a:srgbClr val="FFFFFF"/>
+          </a:solidFill>
+          <a:ln w="12700">
+            <a:solidFill>
+              <a:srgbClr val="D0D7DE"/>
+            </a:solidFill>
+            <a:prstDash val="solid"/>
+          </a:ln>
+        </p:spPr>
+      </p:sp>
+      <p:sp>
+        <p:nvSpPr>
+          <p:cNvPr id="12" name="Shape 10"/>
+          <p:cNvSpPr/>
+          <p:nvPr/>
+        </p:nvSpPr>
+        <p:spPr>
+          <a:xfrm>
+            <a:off x="868680" y="4974336"/>
+            <a:ext cx="237744" cy="237744"/>
+          </a:xfrm>
+          <a:prstGeom prst="ellipse">
+            <a:avLst/>
+          </a:prstGeom>
+          <a:solidFill>
+            <a:srgbClr val="1A7F37"/>
+          </a:solidFill>
+          <a:ln/>
+        </p:spPr>
+      </p:sp>
+      <p:sp>
+        <p:nvSpPr>
+          <p:cNvPr id="13" name="Text 11"/>
+          <p:cNvSpPr txBox="1"/>
+          <p:nvPr/>
+        </p:nvSpPr>
+        <p:spPr>
+          <a:xfrm>
+            <a:off x="1280160" y="4617720"/>
+            <a:ext cx="4480560" cy="914400"/>
+          </a:xfrm>
+          <a:prstGeom prst="rect">
+            <a:avLst/>
+          </a:prstGeom>
+          <a:noFill/>
+          <a:ln/>
+        </p:spPr>
+        <p:txBody>
+          <a:bodyPr wrap="square" lIns="0" tIns="0" rIns="0" bIns="0" rtlCol="0" anchor="ctr"/>
+          <a:lstStyle/>
+          <a:p>
+            <a:pPr indent="0" marL="0">
+              <a:buNone/>
+            </a:pPr>
+            <a:r>
+              <a:rPr lang="en-US" sz="1800" b="1" dirty="0">
+                <a:solidFill>
+                  <a:schemeClr val="bg1"/>
+                </a:solidFill>
+                <a:latin typeface="Courier New" pitchFamily="34" charset="0"/>
+                <a:ea typeface="Courier New" pitchFamily="34" charset="-122"/>
+                <a:cs typeface="Courier New" pitchFamily="34" charset="-120"/>
+              </a:rPr>
+              <a:t>Testing machine</a:t>
+            </a:r>
+            <a:endParaRPr lang="en-US" sz="1800" dirty="0"/>
+          </a:p>
+        </p:txBody>
+      </p:sp>
+      <p:sp>
+        <p:nvSpPr>
+          <p:cNvPr id="14" name="Text 12"/>
+          <p:cNvSpPr txBox="1"/>
+          <p:nvPr/>
+        </p:nvSpPr>
+        <p:spPr>
+          <a:xfrm>
+            <a:off x="5852160" y="4617720"/>
+            <a:ext cx="5577840" cy="914400"/>
+          </a:xfrm>
+          <a:prstGeom prst="rect">
+            <a:avLst/>
+          </a:prstGeom>
+          <a:noFill/>
+          <a:ln/>
+        </p:spPr>
+        <p:txBody>
+          <a:bodyPr wrap="square" lIns="0" tIns="0" rIns="0" bIns="0" rtlCol="0" anchor="ctr"/>
+          <a:lstStyle/>
+          <a:p>
+            <a:pPr indent="0" marL="0">
+              <a:buNone/>
             </a:pPr>
             <a:r>
               <a:rPr lang="en-US" sz="1700" dirty="0">
                 <a:solidFill>
-                  <a:schemeClr val="bg1"/>
-                </a:solidFill>
-              </a:rPr>
-              <a:t>Current answer: a prose argument — the rule table is itself a list</a:t>
+                  <a:schemeClr val="bg2"/>
+                </a:solidFill>
+                <a:latin typeface="Calibri" pitchFamily="34" charset="0"/>
+                <a:ea typeface="Calibri" pitchFamily="34" charset="-122"/>
+                <a:cs typeface="Calibri" pitchFamily="34" charset="-120"/>
+              </a:rPr>
+              <a:t>Solved — renting a cloud VM instead of buying hardware</a:t>
             </a:r>
             <a:endParaRPr lang="en-US" sz="1700" dirty="0"/>
           </a:p>
-          <a:p>
-            <a:pPr marL="342900" indent="-342900">
-              <a:spcAft>
-                <a:spcPts val="1600"/>
-              </a:spcAft>
-              <a:buSzPct val="100000"/>
-              <a:buChar char="▸"/>
-            </a:pPr>
-            <a:r>
-              <a:rPr lang="en-US" sz="1700" dirty="0">
-                <a:solidFill>
-                  <a:schemeClr val="bg1"/>
-                </a:solidFill>
-              </a:rPr>
-              <a:t>Not yet a number — no ablation performed</a:t>
-            </a:r>
-            <a:endParaRPr lang="en-US" sz="1700" dirty="0"/>
-          </a:p>
-          <a:p>
-            <a:pPr marL="342900" indent="-342900">
-              <a:spcAft>
-                <a:spcPts val="1600"/>
-              </a:spcAft>
-              <a:buSzPct val="100000"/>
-              <a:buChar char="▸"/>
-            </a:pPr>
-            <a:r>
-              <a:rPr lang="en-US" sz="1700" dirty="0">
-                <a:solidFill>
-                  <a:schemeClr val="bg1"/>
-                </a:solidFill>
-              </a:rPr>
-              <a:t>Plan: analyzer flag → opaque fallback → fourth corpus column</a:t>
-            </a:r>
-            <a:endParaRPr lang="en-US" sz="1700" dirty="0"/>
-          </a:p>
-        </p:txBody>
-      </p:sp>
-      <p:sp>
-        <p:nvSpPr>
-          <p:cNvPr id="7" name="Text 0"/>
+        </p:txBody>
+      </p:sp>
+      <p:sp>
+        <p:nvSpPr>
+          <p:cNvPr id="16" name="Text 0"/>
           <p:cNvSpPr/>
           <p:nvPr>
             <p:ph idx="101" type="body" hasCustomPrompt="1"/>
@@ -5364,7 +5693,7 @@
                 <a:ea typeface="Courier New" pitchFamily="34" charset="-122"/>
                 <a:cs typeface="Courier New" pitchFamily="34" charset="-120"/>
               </a:rPr>
-              <a:t>Expected Contribution</a:t>
+              <a:t>One Question We Want to Raise Ourselves</a:t>
             </a:r>
             <a:endParaRPr lang="en-US" sz="3400" dirty="0"/>
           </a:p>
@@ -5378,20 +5707,20 @@
         </p:nvSpPr>
         <p:spPr>
           <a:xfrm>
-            <a:off x="548640" y="1600200"/>
-            <a:ext cx="3566160" cy="4023360"/>
+            <a:off x="822960" y="1508760"/>
+            <a:ext cx="10515600" cy="1554480"/>
           </a:xfrm>
           <a:prstGeom prst="roundRect">
             <a:avLst>
-              <a:gd name="adj" fmla="val 2051"/>
+              <a:gd name="adj" fmla="val 4706"/>
             </a:avLst>
           </a:prstGeom>
           <a:solidFill>
-            <a:srgbClr val="F3F4F6"/>
+            <a:srgbClr val="FFFFFF"/>
           </a:solidFill>
-          <a:ln w="12700">
+          <a:ln w="16510">
             <a:solidFill>
-              <a:srgbClr val="D0D7DE"/>
+              <a:srgbClr val="9A6700"/>
             </a:solidFill>
             <a:prstDash val="solid"/>
           </a:ln>
@@ -5405,8 +5734,8 @@
         </p:nvSpPr>
         <p:spPr>
           <a:xfrm>
-            <a:off x="548640" y="1783080"/>
-            <a:ext cx="3566160" cy="960120"/>
+            <a:off x="1188720" y="1691640"/>
+            <a:ext cx="9784080" cy="1188720"/>
           </a:xfrm>
           <a:prstGeom prst="rect">
             <a:avLst/>
@@ -5422,17 +5751,17 @@
               <a:buNone/>
             </a:pPr>
             <a:r>
-              <a:rPr lang="en-US" sz="3200" b="1" dirty="0">
-                <a:solidFill>
-                  <a:srgbClr val="1A7F37"/>
+              <a:rPr lang="en-US" sz="1900" i="1" dirty="0">
+                <a:solidFill>
+                  <a:schemeClr val="accent2"/>
                 </a:solidFill>
                 <a:latin typeface="Courier New" pitchFamily="34" charset="0"/>
                 <a:ea typeface="Courier New" pitchFamily="34" charset="-122"/>
                 <a:cs typeface="Courier New" pitchFamily="34" charset="-120"/>
               </a:rPr>
-              <a:t>RQ1</a:t>
-            </a:r>
-            <a:endParaRPr lang="en-US" sz="3200" dirty="0"/>
+              <a:t>“How much of this result comes from the algorithm itself, versus the hand-built rule tables underneath it?”</a:t>
+            </a:r>
+            <a:endParaRPr lang="en-US" sz="1900" dirty="0"/>
           </a:p>
         </p:txBody>
       </p:sp>
@@ -5444,8 +5773,8 @@
         </p:nvSpPr>
         <p:spPr>
           <a:xfrm>
-            <a:off x="822960" y="2788920"/>
-            <a:ext cx="3017520" cy="2651760"/>
+            <a:off x="822960" y="3337560"/>
+            <a:ext cx="10515600" cy="2926080"/>
           </a:xfrm>
           <a:prstGeom prst="rect">
             <a:avLst/>
@@ -5454,240 +5783,85 @@
           <a:ln/>
         </p:spPr>
         <p:txBody>
-          <a:bodyPr wrap="square" lIns="0" tIns="0" rIns="0" bIns="0" rtlCol="0" anchor="t"/>
-          <a:lstStyle/>
-          <a:p>
-            <a:pPr algn="ctr" indent="0" marL="0">
-              <a:buNone/>
+          <a:bodyPr wrap="square" lIns="0" tIns="0" rIns="0" bIns="0" rtlCol="0" anchor="ctr"/>
+          <a:lstStyle/>
+          <a:p>
+            <a:pPr marL="342900" indent="-342900">
+              <a:spcAft>
+                <a:spcPts val="1600"/>
+              </a:spcAft>
+              <a:buSzPct val="100000"/>
+              <a:buChar char="▸"/>
             </a:pPr>
             <a:r>
               <a:rPr lang="en-US" sz="1700" dirty="0">
                 <a:solidFill>
                   <a:schemeClr val="bg1"/>
                 </a:solidFill>
-                <a:latin typeface="Calibri" pitchFamily="34" charset="0"/>
-                <a:ea typeface="Calibri" pitchFamily="34" charset="-122"/>
-                <a:cs typeface="Calibri" pitchFamily="34" charset="-120"/>
-              </a:rPr>
-              <a:t>Composition- and resolution-aware algorithm, evaluated against two baselines</a:t>
+              </a:rPr>
+              <a:t>Already asked once, by our adviser</a:t>
             </a:r>
             <a:endParaRPr lang="en-US" sz="1700" dirty="0"/>
           </a:p>
-        </p:txBody>
-      </p:sp>
-      <p:sp>
-        <p:nvSpPr>
-          <p:cNvPr id="6" name="Shape 4"/>
-          <p:cNvSpPr/>
-          <p:nvPr/>
-        </p:nvSpPr>
-        <p:spPr>
-          <a:xfrm>
-            <a:off x="4297680" y="1600200"/>
-            <a:ext cx="3566160" cy="4023360"/>
-          </a:xfrm>
-          <a:prstGeom prst="roundRect">
-            <a:avLst>
-              <a:gd name="adj" fmla="val 2051"/>
-            </a:avLst>
-          </a:prstGeom>
-          <a:solidFill>
-            <a:srgbClr val="F3F4F6"/>
-          </a:solidFill>
-          <a:ln w="12700">
-            <a:solidFill>
-              <a:srgbClr val="D0D7DE"/>
-            </a:solidFill>
-            <a:prstDash val="solid"/>
-          </a:ln>
-        </p:spPr>
-      </p:sp>
-      <p:sp>
-        <p:nvSpPr>
-          <p:cNvPr id="7" name="Text 5"/>
-          <p:cNvSpPr txBox="1"/>
-          <p:nvPr/>
-        </p:nvSpPr>
-        <p:spPr>
-          <a:xfrm>
-            <a:off x="4297680" y="1783080"/>
-            <a:ext cx="3566160" cy="960120"/>
-          </a:xfrm>
-          <a:prstGeom prst="rect">
-            <a:avLst/>
-          </a:prstGeom>
-          <a:noFill/>
-          <a:ln/>
-        </p:spPr>
-        <p:txBody>
-          <a:bodyPr wrap="square" lIns="0" tIns="0" rIns="0" bIns="0" rtlCol="0" anchor="ctr"/>
-          <a:lstStyle/>
-          <a:p>
-            <a:pPr algn="ctr" indent="0" marL="0">
-              <a:buNone/>
-            </a:pPr>
-            <a:r>
-              <a:rPr lang="en-US" sz="3200" b="1" dirty="0">
-                <a:solidFill>
-                  <a:srgbClr val="0969DA"/>
-                </a:solidFill>
-                <a:latin typeface="Courier New" pitchFamily="34" charset="0"/>
-                <a:ea typeface="Courier New" pitchFamily="34" charset="-122"/>
-                <a:cs typeface="Courier New" pitchFamily="34" charset="-120"/>
-              </a:rPr>
-              <a:t>RQ2-3</a:t>
-            </a:r>
-            <a:endParaRPr lang="en-US" sz="3200" dirty="0"/>
-          </a:p>
-        </p:txBody>
-      </p:sp>
-      <p:sp>
-        <p:nvSpPr>
-          <p:cNvPr id="8" name="Text 6"/>
-          <p:cNvSpPr txBox="1"/>
-          <p:nvPr/>
-        </p:nvSpPr>
-        <p:spPr>
-          <a:xfrm>
-            <a:off x="4572000" y="2788920"/>
-            <a:ext cx="3017520" cy="2651760"/>
-          </a:xfrm>
-          <a:prstGeom prst="rect">
-            <a:avLst/>
-          </a:prstGeom>
-          <a:noFill/>
-          <a:ln/>
-        </p:spPr>
-        <p:txBody>
-          <a:bodyPr wrap="square" lIns="0" tIns="0" rIns="0" bIns="0" rtlCol="0" anchor="t"/>
-          <a:lstStyle/>
-          <a:p>
-            <a:pPr algn="ctr" indent="0" marL="0">
-              <a:buNone/>
+          <a:p>
+            <a:pPr marL="342900" indent="-342900">
+              <a:spcAft>
+                <a:spcPts val="1600"/>
+              </a:spcAft>
+              <a:buSzPct val="100000"/>
+              <a:buChar char="▸"/>
             </a:pPr>
             <a:r>
               <a:rPr lang="en-US" sz="1700" dirty="0">
                 <a:solidFill>
                   <a:schemeClr val="bg1"/>
                 </a:solidFill>
-                <a:latin typeface="Calibri" pitchFamily="34" charset="0"/>
-                <a:ea typeface="Calibri" pitchFamily="34" charset="-122"/>
-                <a:cs typeface="Calibri" pitchFamily="34" charset="-120"/>
-              </a:rPr>
-              <a:t>Interface layer with a reversibility-based confirmation gate and undo, over an unchanged desktop</a:t>
+              </a:rPr>
+              <a:t>Current answer: a prose argument — the rule table is itself a list</a:t>
             </a:r>
             <a:endParaRPr lang="en-US" sz="1700" dirty="0"/>
           </a:p>
-        </p:txBody>
-      </p:sp>
-      <p:sp>
-        <p:nvSpPr>
-          <p:cNvPr id="9" name="Shape 7"/>
-          <p:cNvSpPr/>
-          <p:nvPr/>
-        </p:nvSpPr>
-        <p:spPr>
-          <a:xfrm>
-            <a:off x="8046720" y="1600200"/>
-            <a:ext cx="3566160" cy="4023360"/>
-          </a:xfrm>
-          <a:prstGeom prst="roundRect">
-            <a:avLst>
-              <a:gd name="adj" fmla="val 2051"/>
-            </a:avLst>
-          </a:prstGeom>
-          <a:solidFill>
-            <a:srgbClr val="F3F4F6"/>
-          </a:solidFill>
-          <a:ln w="12700">
-            <a:solidFill>
-              <a:srgbClr val="D0D7DE"/>
-            </a:solidFill>
-            <a:prstDash val="solid"/>
-          </a:ln>
-        </p:spPr>
-      </p:sp>
-      <p:sp>
-        <p:nvSpPr>
-          <p:cNvPr id="10" name="Text 8"/>
-          <p:cNvSpPr txBox="1"/>
-          <p:nvPr/>
-        </p:nvSpPr>
-        <p:spPr>
-          <a:xfrm>
-            <a:off x="8046720" y="1783080"/>
-            <a:ext cx="3566160" cy="960120"/>
-          </a:xfrm>
-          <a:prstGeom prst="rect">
-            <a:avLst/>
-          </a:prstGeom>
-          <a:noFill/>
-          <a:ln/>
-        </p:spPr>
-        <p:txBody>
-          <a:bodyPr wrap="square" lIns="0" tIns="0" rIns="0" bIns="0" rtlCol="0" anchor="ctr"/>
-          <a:lstStyle/>
-          <a:p>
-            <a:pPr algn="ctr" indent="0" marL="0">
-              <a:buNone/>
-            </a:pPr>
-            <a:r>
-              <a:rPr lang="en-US" sz="3200" b="1" dirty="0">
-                <a:solidFill>
-                  <a:srgbClr val="9A6700"/>
-                </a:solidFill>
-                <a:latin typeface="Courier New" pitchFamily="34" charset="0"/>
-                <a:ea typeface="Courier New" pitchFamily="34" charset="-122"/>
-                <a:cs typeface="Courier New" pitchFamily="34" charset="-120"/>
-              </a:rPr>
-              <a:t>RQ4</a:t>
-            </a:r>
-            <a:endParaRPr lang="en-US" sz="3200" dirty="0"/>
-          </a:p>
-        </p:txBody>
-      </p:sp>
-      <p:sp>
-        <p:nvSpPr>
-          <p:cNvPr id="11" name="Text 9"/>
-          <p:cNvSpPr txBox="1"/>
-          <p:nvPr/>
-        </p:nvSpPr>
-        <p:spPr>
-          <a:xfrm>
-            <a:off x="8321040" y="2788920"/>
-            <a:ext cx="3017520" cy="2651760"/>
-          </a:xfrm>
-          <a:prstGeom prst="rect">
-            <a:avLst/>
-          </a:prstGeom>
-          <a:noFill/>
-          <a:ln/>
-        </p:spPr>
-        <p:txBody>
-          <a:bodyPr wrap="square" lIns="0" tIns="0" rIns="0" bIns="0" rtlCol="0" anchor="t"/>
-          <a:lstStyle/>
-          <a:p>
-            <a:pPr algn="ctr" indent="0" marL="0">
-              <a:buNone/>
+          <a:p>
+            <a:pPr marL="342900" indent="-342900">
+              <a:spcAft>
+                <a:spcPts val="1600"/>
+              </a:spcAft>
+              <a:buSzPct val="100000"/>
+              <a:buChar char="▸"/>
             </a:pPr>
             <a:r>
               <a:rPr lang="en-US" sz="1700" dirty="0">
                 <a:solidFill>
                   <a:schemeClr val="bg1"/>
                 </a:solidFill>
-                <a:latin typeface="Calibri" pitchFamily="34" charset="0"/>
-                <a:ea typeface="Calibri" pitchFamily="34" charset="-122"/>
-                <a:cs typeface="Calibri" pitchFamily="34" charset="-120"/>
-              </a:rPr>
-              <a:t>First controlled evidence on narrowing the CLI/GUI fluency gap</a:t>
+              </a:rPr>
+              <a:t>Not yet a number — no ablation performed</a:t>
             </a:r>
             <a:endParaRPr lang="en-US" sz="1700" dirty="0"/>
           </a:p>
-        </p:txBody>
-      </p:sp>
-      <p:sp>
-        <p:nvSpPr>
-          <p:cNvPr id="13" name="Text 0"/>
+          <a:p>
+            <a:pPr marL="342900" indent="-342900">
+              <a:spcAft>
+                <a:spcPts val="1600"/>
+              </a:spcAft>
+              <a:buSzPct val="100000"/>
+              <a:buChar char="▸"/>
+            </a:pPr>
+            <a:r>
+              <a:rPr lang="en-US" sz="1700" dirty="0">
+                <a:solidFill>
+                  <a:schemeClr val="bg1"/>
+                </a:solidFill>
+              </a:rPr>
+              <a:t>Plan: analyzer flag → opaque fallback → fourth corpus column</a:t>
+            </a:r>
+            <a:endParaRPr lang="en-US" sz="1700" dirty="0"/>
+          </a:p>
+        </p:txBody>
+      </p:sp>
+      <p:sp>
+        <p:nvSpPr>
+          <p:cNvPr id="7" name="Text 0"/>
           <p:cNvSpPr/>
           <p:nvPr>
             <p:ph idx="101" type="body" hasCustomPrompt="1"/>
@@ -5823,7 +5997,7 @@
                 <a:ea typeface="Courier New" pitchFamily="34" charset="-122"/>
                 <a:cs typeface="Courier New" pitchFamily="34" charset="-120"/>
               </a:rPr>
-              <a:t>What's Next</a:t>
+              <a:t>Expected Contribution</a:t>
             </a:r>
             <a:endParaRPr lang="en-US" sz="3400" dirty="0"/>
           </a:p>
@@ -5831,16 +6005,41 @@
       </p:sp>
       <p:sp>
         <p:nvSpPr>
-          <p:cNvPr id="3" name="Text 0"/>
+          <p:cNvPr id="3" name="Shape 1"/>
           <p:cNvSpPr/>
-          <p:nvPr>
-            <p:ph idx="101" type="body" hasCustomPrompt="1"/>
-          </p:nvPr>
-        </p:nvSpPr>
-        <p:spPr>
-          <a:xfrm>
-            <a:off x="548640" y="1463040"/>
-            <a:ext cx="11064240" cy="4983480"/>
+          <p:nvPr/>
+        </p:nvSpPr>
+        <p:spPr>
+          <a:xfrm>
+            <a:off x="548640" y="1600200"/>
+            <a:ext cx="3566160" cy="4023360"/>
+          </a:xfrm>
+          <a:prstGeom prst="roundRect">
+            <a:avLst>
+              <a:gd name="adj" fmla="val 2051"/>
+            </a:avLst>
+          </a:prstGeom>
+          <a:solidFill>
+            <a:srgbClr val="FFFFFF"/>
+          </a:solidFill>
+          <a:ln w="12700">
+            <a:solidFill>
+              <a:srgbClr val="D0D7DE"/>
+            </a:solidFill>
+            <a:prstDash val="solid"/>
+          </a:ln>
+        </p:spPr>
+      </p:sp>
+      <p:sp>
+        <p:nvSpPr>
+          <p:cNvPr id="4" name="Text 2"/>
+          <p:cNvSpPr txBox="1"/>
+          <p:nvPr/>
+        </p:nvSpPr>
+        <p:spPr>
+          <a:xfrm>
+            <a:off x="548640" y="1783080"/>
+            <a:ext cx="3566160" cy="960120"/>
           </a:xfrm>
           <a:prstGeom prst="rect">
             <a:avLst/>
@@ -5849,18 +6048,53 @@
           <a:ln/>
         </p:spPr>
         <p:txBody>
-          <a:bodyPr wrap="square" rtlCol="0" anchor="t"/>
-          <a:lstStyle/>
-          <a:p>
-            <a:pPr algn="l" marL="342900" indent="-342900">
-              <a:spcAft>
-                <a:spcPts val="1600"/>
-              </a:spcAft>
-              <a:buSzPct val="100000"/>
-              <a:buChar char="▸"/>
-            </a:pPr>
-            <a:r>
-              <a:rPr lang="en-US" sz="1900" dirty="0">
+          <a:bodyPr wrap="square" lIns="0" tIns="0" rIns="0" bIns="0" rtlCol="0" anchor="ctr"/>
+          <a:lstStyle/>
+          <a:p>
+            <a:pPr algn="ctr" indent="0" marL="0">
+              <a:buNone/>
+            </a:pPr>
+            <a:r>
+              <a:rPr lang="en-US" sz="3200" b="1" dirty="0">
+                <a:solidFill>
+                  <a:srgbClr val="1A7F37"/>
+                </a:solidFill>
+                <a:latin typeface="Courier New" pitchFamily="34" charset="0"/>
+                <a:ea typeface="Courier New" pitchFamily="34" charset="-122"/>
+                <a:cs typeface="Courier New" pitchFamily="34" charset="-120"/>
+              </a:rPr>
+              <a:t>RQ1</a:t>
+            </a:r>
+            <a:endParaRPr lang="en-US" sz="3200" dirty="0"/>
+          </a:p>
+        </p:txBody>
+      </p:sp>
+      <p:sp>
+        <p:nvSpPr>
+          <p:cNvPr id="5" name="Text 3"/>
+          <p:cNvSpPr txBox="1"/>
+          <p:nvPr/>
+        </p:nvSpPr>
+        <p:spPr>
+          <a:xfrm>
+            <a:off x="822960" y="2788920"/>
+            <a:ext cx="3017520" cy="2651760"/>
+          </a:xfrm>
+          <a:prstGeom prst="rect">
+            <a:avLst/>
+          </a:prstGeom>
+          <a:noFill/>
+          <a:ln/>
+        </p:spPr>
+        <p:txBody>
+          <a:bodyPr wrap="square" lIns="0" tIns="0" rIns="0" bIns="0" rtlCol="0" anchor="t"/>
+          <a:lstStyle/>
+          <a:p>
+            <a:pPr algn="ctr" indent="0" marL="0">
+              <a:buNone/>
+            </a:pPr>
+            <a:r>
+              <a:rPr lang="en-US" sz="1700" dirty="0">
                 <a:solidFill>
                   <a:schemeClr val="bg1"/>
                 </a:solidFill>
@@ -5868,20 +6102,104 @@
                 <a:ea typeface="Calibri" pitchFamily="34" charset="-122"/>
                 <a:cs typeface="Calibri" pitchFamily="34" charset="-120"/>
               </a:rPr>
-              <a:t>Spin up the rented testing machine</a:t>
-            </a:r>
-            <a:endParaRPr lang="en-US" sz="1900" dirty="0"/>
-          </a:p>
-          <a:p>
-            <a:pPr algn="l" marL="342900" indent="-342900">
-              <a:spcAft>
-                <a:spcPts val="1600"/>
-              </a:spcAft>
-              <a:buSzPct val="100000"/>
-              <a:buChar char="▸"/>
-            </a:pPr>
-            <a:r>
-              <a:rPr lang="en-US" sz="1900" dirty="0">
+              <a:t>Composition- and resolution-aware algorithm, evaluated against two baselines</a:t>
+            </a:r>
+            <a:endParaRPr lang="en-US" sz="1700" dirty="0"/>
+          </a:p>
+        </p:txBody>
+      </p:sp>
+      <p:sp>
+        <p:nvSpPr>
+          <p:cNvPr id="6" name="Shape 4"/>
+          <p:cNvSpPr/>
+          <p:nvPr/>
+        </p:nvSpPr>
+        <p:spPr>
+          <a:xfrm>
+            <a:off x="4297680" y="1600200"/>
+            <a:ext cx="3566160" cy="4023360"/>
+          </a:xfrm>
+          <a:prstGeom prst="roundRect">
+            <a:avLst>
+              <a:gd name="adj" fmla="val 2051"/>
+            </a:avLst>
+          </a:prstGeom>
+          <a:solidFill>
+            <a:srgbClr val="FFFFFF"/>
+          </a:solidFill>
+          <a:ln w="12700">
+            <a:solidFill>
+              <a:srgbClr val="D0D7DE"/>
+            </a:solidFill>
+            <a:prstDash val="solid"/>
+          </a:ln>
+        </p:spPr>
+      </p:sp>
+      <p:sp>
+        <p:nvSpPr>
+          <p:cNvPr id="7" name="Text 5"/>
+          <p:cNvSpPr txBox="1"/>
+          <p:nvPr/>
+        </p:nvSpPr>
+        <p:spPr>
+          <a:xfrm>
+            <a:off x="4297680" y="1783080"/>
+            <a:ext cx="3566160" cy="960120"/>
+          </a:xfrm>
+          <a:prstGeom prst="rect">
+            <a:avLst/>
+          </a:prstGeom>
+          <a:noFill/>
+          <a:ln/>
+        </p:spPr>
+        <p:txBody>
+          <a:bodyPr wrap="square" lIns="0" tIns="0" rIns="0" bIns="0" rtlCol="0" anchor="ctr"/>
+          <a:lstStyle/>
+          <a:p>
+            <a:pPr algn="ctr" indent="0" marL="0">
+              <a:buNone/>
+            </a:pPr>
+            <a:r>
+              <a:rPr lang="en-US" sz="3200" b="1" dirty="0">
+                <a:solidFill>
+                  <a:srgbClr val="0969DA"/>
+                </a:solidFill>
+                <a:latin typeface="Courier New" pitchFamily="34" charset="0"/>
+                <a:ea typeface="Courier New" pitchFamily="34" charset="-122"/>
+                <a:cs typeface="Courier New" pitchFamily="34" charset="-120"/>
+              </a:rPr>
+              <a:t>RQ2-3</a:t>
+            </a:r>
+            <a:endParaRPr lang="en-US" sz="3200" dirty="0"/>
+          </a:p>
+        </p:txBody>
+      </p:sp>
+      <p:sp>
+        <p:nvSpPr>
+          <p:cNvPr id="8" name="Text 6"/>
+          <p:cNvSpPr txBox="1"/>
+          <p:nvPr/>
+        </p:nvSpPr>
+        <p:spPr>
+          <a:xfrm>
+            <a:off x="4572000" y="2788920"/>
+            <a:ext cx="3017520" cy="2651760"/>
+          </a:xfrm>
+          <a:prstGeom prst="rect">
+            <a:avLst/>
+          </a:prstGeom>
+          <a:noFill/>
+          <a:ln/>
+        </p:spPr>
+        <p:txBody>
+          <a:bodyPr wrap="square" lIns="0" tIns="0" rIns="0" bIns="0" rtlCol="0" anchor="t"/>
+          <a:lstStyle/>
+          <a:p>
+            <a:pPr algn="ctr" indent="0" marL="0">
+              <a:buNone/>
+            </a:pPr>
+            <a:r>
+              <a:rPr lang="en-US" sz="1700" dirty="0">
                 <a:solidFill>
                   <a:schemeClr val="bg1"/>
                 </a:solidFill>
@@ -5889,20 +6207,104 @@
                 <a:ea typeface="Calibri" pitchFamily="34" charset="-122"/>
                 <a:cs typeface="Calibri" pitchFamily="34" charset="-120"/>
               </a:rPr>
-              <a:t>Finish the interface build</a:t>
-            </a:r>
-            <a:endParaRPr lang="en-US" sz="1900" dirty="0"/>
-          </a:p>
-          <a:p>
-            <a:pPr algn="l" marL="342900" indent="-342900">
-              <a:spcAft>
-                <a:spcPts val="1600"/>
-              </a:spcAft>
-              <a:buSzPct val="100000"/>
-              <a:buChar char="▸"/>
-            </a:pPr>
-            <a:r>
-              <a:rPr lang="en-US" sz="1900" dirty="0">
+              <a:t>Interface layer with a reversibility-based confirmation gate and undo, over an unchanged desktop</a:t>
+            </a:r>
+            <a:endParaRPr lang="en-US" sz="1700" dirty="0"/>
+          </a:p>
+        </p:txBody>
+      </p:sp>
+      <p:sp>
+        <p:nvSpPr>
+          <p:cNvPr id="9" name="Shape 7"/>
+          <p:cNvSpPr/>
+          <p:nvPr/>
+        </p:nvSpPr>
+        <p:spPr>
+          <a:xfrm>
+            <a:off x="8046720" y="1600200"/>
+            <a:ext cx="3566160" cy="4023360"/>
+          </a:xfrm>
+          <a:prstGeom prst="roundRect">
+            <a:avLst>
+              <a:gd name="adj" fmla="val 2051"/>
+            </a:avLst>
+          </a:prstGeom>
+          <a:solidFill>
+            <a:srgbClr val="FFFFFF"/>
+          </a:solidFill>
+          <a:ln w="12700">
+            <a:solidFill>
+              <a:srgbClr val="D0D7DE"/>
+            </a:solidFill>
+            <a:prstDash val="solid"/>
+          </a:ln>
+        </p:spPr>
+      </p:sp>
+      <p:sp>
+        <p:nvSpPr>
+          <p:cNvPr id="10" name="Text 8"/>
+          <p:cNvSpPr txBox="1"/>
+          <p:nvPr/>
+        </p:nvSpPr>
+        <p:spPr>
+          <a:xfrm>
+            <a:off x="8046720" y="1783080"/>
+            <a:ext cx="3566160" cy="960120"/>
+          </a:xfrm>
+          <a:prstGeom prst="rect">
+            <a:avLst/>
+          </a:prstGeom>
+          <a:noFill/>
+          <a:ln/>
+        </p:spPr>
+        <p:txBody>
+          <a:bodyPr wrap="square" lIns="0" tIns="0" rIns="0" bIns="0" rtlCol="0" anchor="ctr"/>
+          <a:lstStyle/>
+          <a:p>
+            <a:pPr algn="ctr" indent="0" marL="0">
+              <a:buNone/>
+            </a:pPr>
+            <a:r>
+              <a:rPr lang="en-US" sz="3200" b="1" dirty="0">
+                <a:solidFill>
+                  <a:srgbClr val="9A6700"/>
+                </a:solidFill>
+                <a:latin typeface="Courier New" pitchFamily="34" charset="0"/>
+                <a:ea typeface="Courier New" pitchFamily="34" charset="-122"/>
+                <a:cs typeface="Courier New" pitchFamily="34" charset="-120"/>
+              </a:rPr>
+              <a:t>RQ4</a:t>
+            </a:r>
+            <a:endParaRPr lang="en-US" sz="3200" dirty="0"/>
+          </a:p>
+        </p:txBody>
+      </p:sp>
+      <p:sp>
+        <p:nvSpPr>
+          <p:cNvPr id="11" name="Text 9"/>
+          <p:cNvSpPr txBox="1"/>
+          <p:nvPr/>
+        </p:nvSpPr>
+        <p:spPr>
+          <a:xfrm>
+            <a:off x="8321040" y="2788920"/>
+            <a:ext cx="3017520" cy="2651760"/>
+          </a:xfrm>
+          <a:prstGeom prst="rect">
+            <a:avLst/>
+          </a:prstGeom>
+          <a:noFill/>
+          <a:ln/>
+        </p:spPr>
+        <p:txBody>
+          <a:bodyPr wrap="square" lIns="0" tIns="0" rIns="0" bIns="0" rtlCol="0" anchor="t"/>
+          <a:lstStyle/>
+          <a:p>
+            <a:pPr algn="ctr" indent="0" marL="0">
+              <a:buNone/>
+            </a:pPr>
+            <a:r>
+              <a:rPr lang="en-US" sz="1700" dirty="0">
                 <a:solidFill>
                   <a:schemeClr val="bg1"/>
                 </a:solidFill>
@@ -5910,29 +6312,38 @@
                 <a:ea typeface="Calibri" pitchFamily="34" charset="-122"/>
                 <a:cs typeface="Calibri" pitchFamily="34" charset="-120"/>
               </a:rPr>
-              <a:t>Run the study with real participants</a:t>
-            </a:r>
-            <a:endParaRPr lang="en-US" sz="1900" dirty="0"/>
-          </a:p>
-          <a:p>
-            <a:pPr algn="l" marL="342900" indent="-342900">
-              <a:spcAft>
-                <a:spcPts val="1600"/>
-              </a:spcAft>
-              <a:buSzPct val="100000"/>
-              <a:buChar char="▸"/>
-            </a:pPr>
-            <a:r>
-              <a:rPr lang="en-US" sz="1900" dirty="0">
-                <a:solidFill>
-                  <a:schemeClr val="bg1"/>
-                </a:solidFill>
-                <a:latin typeface="Calibri" pitchFamily="34" charset="0"/>
-                <a:ea typeface="Calibri" pitchFamily="34" charset="-122"/>
-                <a:cs typeface="Calibri" pitchFamily="34" charset="-120"/>
-              </a:rPr>
-              <a:t>Return with results, not just a plan</a:t>
-            </a:r>
+              <a:t>First controlled evidence on narrowing the CLI/GUI fluency gap</a:t>
+            </a:r>
+            <a:endParaRPr lang="en-US" sz="1700" dirty="0"/>
+          </a:p>
+        </p:txBody>
+      </p:sp>
+      <p:sp>
+        <p:nvSpPr>
+          <p:cNvPr id="13" name="Text 0"/>
+          <p:cNvSpPr/>
+          <p:nvPr>
+            <p:ph idx="101" type="body" hasCustomPrompt="1"/>
+          </p:nvPr>
+        </p:nvSpPr>
+        <p:spPr>
+          <a:xfrm>
+            <a:off x="548640" y="1463040"/>
+            <a:ext cx="11064240" cy="4983480"/>
+          </a:xfrm>
+          <a:prstGeom prst="rect">
+            <a:avLst/>
+          </a:prstGeom>
+          <a:noFill/>
+          <a:ln/>
+        </p:spPr>
+        <p:txBody>
+          <a:bodyPr wrap="square" rtlCol="0" anchor="t"/>
+          <a:lstStyle/>
+          <a:p>
+            <a:pPr algn="l" indent="0" marL="0">
+              <a:buNone/>
+            </a:pPr>
             <a:endParaRPr lang="en-US" sz="1900" dirty="0"/>
           </a:p>
         </p:txBody>
@@ -6020,6 +6431,228 @@
         </p:nvSpPr>
         <p:spPr>
           <a:xfrm>
+            <a:off x="548640" y="365760"/>
+            <a:ext cx="11064240" cy="914400"/>
+          </a:xfrm>
+          <a:prstGeom prst="rect">
+            <a:avLst/>
+          </a:prstGeom>
+          <a:noFill/>
+          <a:ln/>
+        </p:spPr>
+        <p:txBody>
+          <a:bodyPr wrap="square" rtlCol="0" anchor="t"/>
+          <a:lstStyle/>
+          <a:p>
+            <a:pPr algn="l" indent="0" marL="0">
+              <a:buNone/>
+            </a:pPr>
+            <a:r>
+              <a:rPr lang="en-US" sz="3400" b="1" dirty="0">
+                <a:solidFill>
+                  <a:schemeClr val="accent1"/>
+                </a:solidFill>
+                <a:latin typeface="Courier New" pitchFamily="34" charset="0"/>
+                <a:ea typeface="Courier New" pitchFamily="34" charset="-122"/>
+                <a:cs typeface="Courier New" pitchFamily="34" charset="-120"/>
+              </a:rPr>
+              <a:t>What's Next</a:t>
+            </a:r>
+            <a:endParaRPr lang="en-US" sz="3400" dirty="0"/>
+          </a:p>
+        </p:txBody>
+      </p:sp>
+      <p:sp>
+        <p:nvSpPr>
+          <p:cNvPr id="3" name="Text 0"/>
+          <p:cNvSpPr/>
+          <p:nvPr>
+            <p:ph idx="101" type="body" hasCustomPrompt="1"/>
+          </p:nvPr>
+        </p:nvSpPr>
+        <p:spPr>
+          <a:xfrm>
+            <a:off x="548640" y="1463040"/>
+            <a:ext cx="11064240" cy="4983480"/>
+          </a:xfrm>
+          <a:prstGeom prst="rect">
+            <a:avLst/>
+          </a:prstGeom>
+          <a:noFill/>
+          <a:ln/>
+        </p:spPr>
+        <p:txBody>
+          <a:bodyPr wrap="square" rtlCol="0" anchor="t"/>
+          <a:lstStyle/>
+          <a:p>
+            <a:pPr algn="l" marL="342900" indent="-342900">
+              <a:spcAft>
+                <a:spcPts val="1600"/>
+              </a:spcAft>
+              <a:buSzPct val="100000"/>
+              <a:buChar char="▸"/>
+            </a:pPr>
+            <a:r>
+              <a:rPr lang="en-US" sz="1900" dirty="0">
+                <a:solidFill>
+                  <a:schemeClr val="bg1"/>
+                </a:solidFill>
+                <a:latin typeface="Calibri" pitchFamily="34" charset="0"/>
+                <a:ea typeface="Calibri" pitchFamily="34" charset="-122"/>
+                <a:cs typeface="Calibri" pitchFamily="34" charset="-120"/>
+              </a:rPr>
+              <a:t>Spin up the rented testing machine</a:t>
+            </a:r>
+            <a:endParaRPr lang="en-US" sz="1900" dirty="0"/>
+          </a:p>
+          <a:p>
+            <a:pPr algn="l" marL="342900" indent="-342900">
+              <a:spcAft>
+                <a:spcPts val="1600"/>
+              </a:spcAft>
+              <a:buSzPct val="100000"/>
+              <a:buChar char="▸"/>
+            </a:pPr>
+            <a:r>
+              <a:rPr lang="en-US" sz="1900" dirty="0">
+                <a:solidFill>
+                  <a:schemeClr val="bg1"/>
+                </a:solidFill>
+                <a:latin typeface="Calibri" pitchFamily="34" charset="0"/>
+                <a:ea typeface="Calibri" pitchFamily="34" charset="-122"/>
+                <a:cs typeface="Calibri" pitchFamily="34" charset="-120"/>
+              </a:rPr>
+              <a:t>Finish the interface build</a:t>
+            </a:r>
+            <a:endParaRPr lang="en-US" sz="1900" dirty="0"/>
+          </a:p>
+          <a:p>
+            <a:pPr algn="l" marL="342900" indent="-342900">
+              <a:spcAft>
+                <a:spcPts val="1600"/>
+              </a:spcAft>
+              <a:buSzPct val="100000"/>
+              <a:buChar char="▸"/>
+            </a:pPr>
+            <a:r>
+              <a:rPr lang="en-US" sz="1900" dirty="0">
+                <a:solidFill>
+                  <a:schemeClr val="bg1"/>
+                </a:solidFill>
+                <a:latin typeface="Calibri" pitchFamily="34" charset="0"/>
+                <a:ea typeface="Calibri" pitchFamily="34" charset="-122"/>
+                <a:cs typeface="Calibri" pitchFamily="34" charset="-120"/>
+              </a:rPr>
+              <a:t>Run the study with real participants</a:t>
+            </a:r>
+            <a:endParaRPr lang="en-US" sz="1900" dirty="0"/>
+          </a:p>
+          <a:p>
+            <a:pPr algn="l" marL="342900" indent="-342900">
+              <a:spcAft>
+                <a:spcPts val="1600"/>
+              </a:spcAft>
+              <a:buSzPct val="100000"/>
+              <a:buChar char="▸"/>
+            </a:pPr>
+            <a:r>
+              <a:rPr lang="en-US" sz="1900" dirty="0">
+                <a:solidFill>
+                  <a:schemeClr val="bg1"/>
+                </a:solidFill>
+                <a:latin typeface="Calibri" pitchFamily="34" charset="0"/>
+                <a:ea typeface="Calibri" pitchFamily="34" charset="-122"/>
+                <a:cs typeface="Calibri" pitchFamily="34" charset="-120"/>
+              </a:rPr>
+              <a:t>Return with results, not just a plan</a:t>
+            </a:r>
+            <a:endParaRPr lang="en-US" sz="1900" dirty="0"/>
+          </a:p>
+        </p:txBody>
+      </p:sp>
+      <p:sp>
+        <p:nvSpPr>
+          <p:cNvPr id="25" name="Slide Number Placeholder 0"/>
+          <p:cNvSpPr>
+            <a:spLocks noGrp="1"/>
+          </p:cNvSpPr>
+          <p:nvPr>
+            <p:ph type="sldNum" sz="quarter" idx="4294967295"/>
+          </p:nvPr>
+        </p:nvSpPr>
+        <p:spPr>
+          <a:xfrm>
+            <a:off x="11521440" y="6537960"/>
+            <a:ext cx="800000" cy="300000"/>
+          </a:xfrm>
+          <a:prstGeom prst="rect">
+            <a:avLst/>
+          </a:prstGeom>
+          <a:extLst>
+            <a:ext uri="{C572A759-6A51-4108-AA02-DFA0A04FC94B}">
+              <ma14:wrappingTextBoxFlag xmlns:ma14="http://schemas.microsoft.com/office/mac/drawingml/2011/main" val="0"/>
+            </a:ext>
+          </a:extLst>
+        </p:spPr>
+        <p:txBody>
+          <a:bodyPr/>
+          <a:lstStyle>
+            <a:lvl1pPr>
+              <a:defRPr sz="1000">
+                <a:solidFill>
+                  <a:schemeClr val="bg2"/>
+                </a:solidFill>
+                <a:latin typeface="Calibri"/>
+                <a:ea typeface="Calibri"/>
+                <a:cs typeface="Calibri"/>
+              </a:defRPr>
+            </a:lvl1pPr>
+          </a:lstStyle>
+          <a:p>
+            <a:pPr algn="l"/>
+            <a:fld id="{F7021451-1387-4CA6-816F-3879F97B5CBC}" type="slidenum">
+              <a:rPr b="0" lang="en-US"/>
+              <a:t>18</a:t>
+            </a:fld>
+            <a:endParaRPr lang="en-US"/>
+          </a:p>
+        </p:txBody>
+      </p:sp>
+    </p:spTree>
+  </p:cSld>
+  <p:clrMapOvr>
+    <a:masterClrMapping/>
+  </p:clrMapOvr>
+</p:sld>
+</file>
+
+<file path=ppt/slides/slide19.xml><?xml version="1.0" encoding="utf-8"?>
+<p:sld xmlns:a="http://schemas.openxmlformats.org/drawingml/2006/main" xmlns:r="http://schemas.openxmlformats.org/officeDocument/2006/relationships" xmlns:p="http://schemas.openxmlformats.org/presentationml/2006/main">
+  <p:cSld name="Slide 19">
+    <p:spTree>
+      <p:nvGrpSpPr>
+        <p:cNvPr id="1" name=""/>
+        <p:cNvGrpSpPr/>
+        <p:nvPr/>
+      </p:nvGrpSpPr>
+      <p:grpSpPr>
+        <a:xfrm>
+          <a:off x="0" y="0"/>
+          <a:ext cx="0" cy="0"/>
+          <a:chOff x="0" y="0"/>
+          <a:chExt cx="0" cy="0"/>
+        </a:xfrm>
+      </p:grpSpPr>
+      <p:sp>
+        <p:nvSpPr>
+          <p:cNvPr id="2" name="Text 0"/>
+          <p:cNvSpPr/>
+          <p:nvPr>
+            <p:ph idx="100" type="title" hasCustomPrompt="1"/>
+          </p:nvPr>
+        </p:nvSpPr>
+        <p:spPr>
+          <a:xfrm>
             <a:off x="822960" y="2194560"/>
             <a:ext cx="10515600" cy="1554480"/>
           </a:xfrm>
@@ -6451,7 +7084,7 @@
             </a:avLst>
           </a:prstGeom>
           <a:solidFill>
-            <a:srgbClr val="F3F4F6"/>
+            <a:srgbClr val="FFFFFF"/>
           </a:solidFill>
           <a:ln w="12700">
             <a:solidFill>
@@ -6769,7 +7402,7 @@
             </a:avLst>
           </a:prstGeom>
           <a:solidFill>
-            <a:srgbClr val="F3F4F6"/>
+            <a:srgbClr val="FFFFFF"/>
           </a:solidFill>
           <a:ln w="12700">
             <a:solidFill>
@@ -7002,7 +7635,7 @@
             </a:avLst>
           </a:prstGeom>
           <a:solidFill>
-            <a:srgbClr val="F3F4F6"/>
+            <a:srgbClr val="FFFFFF"/>
           </a:solidFill>
           <a:ln w="19050">
             <a:solidFill>
@@ -7143,7 +7776,7 @@
             </a:avLst>
           </a:prstGeom>
           <a:solidFill>
-            <a:srgbClr val="F3F4F6"/>
+            <a:srgbClr val="FFFFFF"/>
           </a:solidFill>
           <a:ln w="19050">
             <a:solidFill>
@@ -7284,7 +7917,7 @@
             </a:avLst>
           </a:prstGeom>
           <a:solidFill>
-            <a:srgbClr val="F3F4F6"/>
+            <a:srgbClr val="FFFFFF"/>
           </a:solidFill>
           <a:ln w="19050">
             <a:solidFill>
@@ -7425,7 +8058,7 @@
             </a:avLst>
           </a:prstGeom>
           <a:solidFill>
-            <a:srgbClr val="F3F4F6"/>
+            <a:srgbClr val="FFFFFF"/>
           </a:solidFill>
           <a:ln w="19050">
             <a:solidFill>
@@ -7858,7 +8491,7 @@
                 <a:ea typeface="Courier New" pitchFamily="34" charset="-122"/>
                 <a:cs typeface="Courier New" pitchFamily="34" charset="-120"/>
               </a:rPr>
-              <a:t>The Algorithm (RQ1) — The Problem</a:t>
+              <a:t>What The Algorithm Sees</a:t>
             </a:r>
             <a:endParaRPr lang="en-US" sz="3400" dirty="0"/>
           </a:p>
@@ -7866,16 +8499,14 @@
       </p:sp>
       <p:sp>
         <p:nvSpPr>
-          <p:cNvPr id="3" name="Text 0"/>
-          <p:cNvSpPr/>
-          <p:nvPr>
-            <p:ph idx="101" type="body" hasCustomPrompt="1"/>
-          </p:nvPr>
+          <p:cNvPr id="3" name="Text 1"/>
+          <p:cNvSpPr txBox="1"/>
+          <p:nvPr/>
         </p:nvSpPr>
         <p:spPr>
           <a:xfrm>
             <a:off x="548640" y="1463040"/>
-            <a:ext cx="11064240" cy="4983480"/>
+            <a:ext cx="11064240" cy="502920"/>
           </a:xfrm>
           <a:prstGeom prst="rect">
             <a:avLst/>
@@ -7884,60 +8515,91 @@
           <a:ln/>
         </p:spPr>
         <p:txBody>
-          <a:bodyPr wrap="square" rtlCol="0" anchor="t"/>
-          <a:lstStyle/>
-          <a:p>
-            <a:pPr algn="l" marL="342900" indent="-342900">
-              <a:spcAft>
-                <a:spcPts val="1600"/>
-              </a:spcAft>
-              <a:buSzPct val="100000"/>
-              <a:buChar char="▸"/>
-            </a:pPr>
-            <a:r>
-              <a:rPr lang="en-US" sz="1900" dirty="0">
-                <a:solidFill>
-                  <a:schemeClr val="bg1"/>
+          <a:bodyPr wrap="square" lIns="0" tIns="0" rIns="0" bIns="0" rtlCol="0" anchor="ctr"/>
+          <a:lstStyle/>
+          <a:p>
+            <a:pPr indent="0" marL="0">
+              <a:buNone/>
+            </a:pPr>
+            <a:r>
+              <a:rPr lang="en-US" sz="1800" dirty="0">
+                <a:solidFill>
+                  <a:schemeClr val="bg2"/>
                 </a:solidFill>
                 <a:latin typeface="Calibri" pitchFamily="34" charset="0"/>
                 <a:ea typeface="Calibri" pitchFamily="34" charset="-122"/>
                 <a:cs typeface="Calibri" pitchFamily="34" charset="-120"/>
               </a:rPr>
-              <a:t>Generated commands can destroy data silently</a:t>
-            </a:r>
-            <a:endParaRPr lang="en-US" sz="1900" dirty="0"/>
-          </a:p>
-          <a:p>
-            <a:pPr algn="l" marL="342900" indent="-342900">
-              <a:spcAft>
-                <a:spcPts val="1600"/>
-              </a:spcAft>
-              <a:buSzPct val="100000"/>
-              <a:buChar char="▸"/>
-            </a:pPr>
-            <a:r>
-              <a:rPr lang="en-US" sz="1900" dirty="0">
-                <a:solidFill>
-                  <a:schemeClr val="bg1"/>
+              <a:t>Not the chat interface — a tool we built for the algorithm itself, reasoning about a real command:</a:t>
+            </a:r>
+            <a:endParaRPr lang="en-US" sz="1800" dirty="0"/>
+          </a:p>
+        </p:txBody>
+      </p:sp>
+      <p:pic>
+        <p:nvPicPr>
+          <p:cNvPr id="4" name="Image 0" descr="media/algorithm-trace.png">    </p:cNvPr>
+          <p:cNvPicPr>
+            <a:picLocks noChangeAspect="1"/>
+          </p:cNvPicPr>
+          <p:nvPr/>
+        </p:nvPicPr>
+        <p:blipFill>
+          <a:blip r:embed="rId1"/>
+          <a:stretch>
+            <a:fillRect/>
+          </a:stretch>
+        </p:blipFill>
+        <p:spPr>
+          <a:xfrm>
+            <a:off x="1234440" y="2103120"/>
+            <a:ext cx="9692640" cy="1353312"/>
+          </a:xfrm>
+          <a:prstGeom prst="rect">
+            <a:avLst/>
+          </a:prstGeom>
+        </p:spPr>
+      </p:pic>
+      <p:sp>
+        <p:nvSpPr>
+          <p:cNvPr id="5" name="Text 2"/>
+          <p:cNvSpPr txBox="1"/>
+          <p:nvPr/>
+        </p:nvSpPr>
+        <p:spPr>
+          <a:xfrm>
+            <a:off x="548640" y="3749040"/>
+            <a:ext cx="11064240" cy="548640"/>
+          </a:xfrm>
+          <a:prstGeom prst="rect">
+            <a:avLst/>
+          </a:prstGeom>
+          <a:noFill/>
+          <a:ln/>
+        </p:spPr>
+        <p:txBody>
+          <a:bodyPr wrap="square" lIns="0" tIns="0" rIns="0" bIns="0" rtlCol="0" anchor="ctr"/>
+          <a:lstStyle/>
+          <a:p>
+            <a:pPr indent="0" marL="0">
+              <a:buNone/>
+            </a:pPr>
+            <a:r>
+              <a:rPr lang="en-US" sz="1600" b="1" dirty="0">
+                <a:solidFill>
+                  <a:schemeClr val="accent1"/>
                 </a:solidFill>
                 <a:latin typeface="Calibri" pitchFamily="34" charset="0"/>
                 <a:ea typeface="Calibri" pitchFamily="34" charset="-122"/>
                 <a:cs typeface="Calibri" pitchFamily="34" charset="-120"/>
               </a:rPr>
-              <a:t>Pattern lists judge a command by its name, not its effect</a:t>
-            </a:r>
-            <a:endParaRPr lang="en-US" sz="1900" dirty="0"/>
-          </a:p>
-          <a:p>
-            <a:pPr algn="l" marL="342900" indent="-342900">
-              <a:spcAft>
-                <a:spcPts val="1600"/>
-              </a:spcAft>
-              <a:buSzPct val="100000"/>
-              <a:buChar char="▸"/>
-            </a:pPr>
-            <a:r>
-              <a:rPr lang="en-US" sz="1900" dirty="0">
+              <a:t>Sees through find -exec </a:t>
+            </a:r>
+            <a:pPr indent="0" marL="0">
+              <a:buNone/>
+            </a:pPr>
+            <a:r>
+              <a:rPr lang="en-US" sz="1600" dirty="0">
                 <a:solidFill>
                   <a:schemeClr val="bg1"/>
                 </a:solidFill>
@@ -7945,43 +8607,24 @@
                 <a:ea typeface="Calibri" pitchFamily="34" charset="-122"/>
                 <a:cs typeface="Calibri" pitchFamily="34" charset="-120"/>
               </a:rPr>
-              <a:t>Binary choice today: unsafe (let it through) or useless (refuse everything)</a:t>
-            </a:r>
-            <a:endParaRPr lang="en-US" sz="1900" dirty="0"/>
-          </a:p>
-          <a:p>
-            <a:pPr algn="l" marL="342900" indent="-342900">
-              <a:spcAft>
-                <a:spcPts val="1600"/>
-              </a:spcAft>
-              <a:buSzPct val="100000"/>
-              <a:buChar char="▸"/>
-            </a:pPr>
-            <a:r>
-              <a:rPr lang="en-US" sz="1900" dirty="0">
-                <a:solidFill>
-                  <a:schemeClr val="bg1"/>
-                </a:solidFill>
-                <a:latin typeface="Calibri" pitchFamily="34" charset="0"/>
-                <a:ea typeface="Calibri" pitchFamily="34" charset="-122"/>
-                <a:cs typeface="Calibri" pitchFamily="34" charset="-120"/>
-              </a:rPr>
-              <a:t>Needed: know the command's actual effect before it runs</a:t>
-            </a:r>
-            <a:endParaRPr lang="en-US" sz="1900" dirty="0"/>
-          </a:p>
-        </p:txBody>
-      </p:sp>
-      <p:sp>
-        <p:nvSpPr>
-          <p:cNvPr id="4" name="Text 2"/>
-          <p:cNvSpPr txBox="1"/>
-          <p:nvPr/>
-        </p:nvSpPr>
-        <p:spPr>
-          <a:xfrm>
-            <a:off x="548640" y="5120640"/>
-            <a:ext cx="11064240" cy="548640"/>
+              <a:t>→ resolves the real files it would touch → labels it recoverable, with a capture plan.</a:t>
+            </a:r>
+            <a:endParaRPr lang="en-US" sz="1600" dirty="0"/>
+          </a:p>
+        </p:txBody>
+      </p:sp>
+      <p:sp>
+        <p:nvSpPr>
+          <p:cNvPr id="7" name="Text 0"/>
+          <p:cNvSpPr/>
+          <p:nvPr>
+            <p:ph idx="101" type="body" hasCustomPrompt="1"/>
+          </p:nvPr>
+        </p:nvSpPr>
+        <p:spPr>
+          <a:xfrm>
+            <a:off x="548640" y="1463040"/>
+            <a:ext cx="11064240" cy="4983480"/>
           </a:xfrm>
           <a:prstGeom prst="rect">
             <a:avLst/>
@@ -7990,24 +8633,13 @@
           <a:ln/>
         </p:spPr>
         <p:txBody>
-          <a:bodyPr wrap="square" lIns="0" tIns="0" rIns="0" bIns="0" rtlCol="0" anchor="ctr"/>
-          <a:lstStyle/>
-          <a:p>
-            <a:pPr indent="0" marL="0">
+          <a:bodyPr wrap="square" rtlCol="0" anchor="t"/>
+          <a:lstStyle/>
+          <a:p>
+            <a:pPr algn="l" indent="0" marL="0">
               <a:buNone/>
             </a:pPr>
-            <a:r>
-              <a:rPr lang="en-US" sz="1400" i="1" dirty="0">
-                <a:solidFill>
-                  <a:schemeClr val="bg2"/>
-                </a:solidFill>
-                <a:latin typeface="Calibri" pitchFamily="34" charset="0"/>
-                <a:ea typeface="Calibri" pitchFamily="34" charset="-122"/>
-                <a:cs typeface="Calibri" pitchFamily="34" charset="-120"/>
-              </a:rPr>
-              <a:t>The algorithm itself is real code in our repository, not a formula on paper — prototype/internal/effects.</a:t>
-            </a:r>
-            <a:endParaRPr lang="en-US" sz="1400" dirty="0"/>
+            <a:endParaRPr lang="en-US" sz="1900" dirty="0"/>
           </a:p>
         </p:txBody>
       </p:sp>
@@ -8119,7 +8751,7 @@
                 <a:ea typeface="Courier New" pitchFamily="34" charset="-122"/>
                 <a:cs typeface="Courier New" pitchFamily="34" charset="-120"/>
               </a:rPr>
-              <a:t>The Algorithm (RQ1) — What It Claims</a:t>
+              <a:t>The Algorithm (RQ1) — The Problem</a:t>
             </a:r>
             <a:endParaRPr lang="en-US" sz="3400" dirty="0"/>
           </a:p>
@@ -8127,30 +8759,111 @@
       </p:sp>
       <p:sp>
         <p:nvSpPr>
-          <p:cNvPr id="3" name="Shape 1"/>
+          <p:cNvPr id="3" name="Text 0"/>
           <p:cNvSpPr/>
-          <p:nvPr/>
-        </p:nvSpPr>
-        <p:spPr>
-          <a:xfrm>
-            <a:off x="548640" y="1371600"/>
-            <a:ext cx="5349240" cy="1691640"/>
-          </a:xfrm>
-          <a:prstGeom prst="roundRect">
-            <a:avLst>
-              <a:gd name="adj" fmla="val 4324"/>
-            </a:avLst>
-          </a:prstGeom>
-          <a:solidFill>
-            <a:srgbClr val="F3F4F6"/>
-          </a:solidFill>
-          <a:ln w="15240">
-            <a:solidFill>
-              <a:srgbClr val="1A7F37"/>
-            </a:solidFill>
-            <a:prstDash val="solid"/>
-          </a:ln>
-        </p:spPr>
+          <p:nvPr>
+            <p:ph idx="101" type="body" hasCustomPrompt="1"/>
+          </p:nvPr>
+        </p:nvSpPr>
+        <p:spPr>
+          <a:xfrm>
+            <a:off x="548640" y="1463040"/>
+            <a:ext cx="11064240" cy="4983480"/>
+          </a:xfrm>
+          <a:prstGeom prst="rect">
+            <a:avLst/>
+          </a:prstGeom>
+          <a:noFill/>
+          <a:ln/>
+        </p:spPr>
+        <p:txBody>
+          <a:bodyPr wrap="square" rtlCol="0" anchor="t"/>
+          <a:lstStyle/>
+          <a:p>
+            <a:pPr algn="l" marL="342900" indent="-342900">
+              <a:spcAft>
+                <a:spcPts val="1600"/>
+              </a:spcAft>
+              <a:buSzPct val="100000"/>
+              <a:buChar char="▸"/>
+            </a:pPr>
+            <a:r>
+              <a:rPr lang="en-US" sz="1900" dirty="0">
+                <a:solidFill>
+                  <a:schemeClr val="bg1"/>
+                </a:solidFill>
+                <a:latin typeface="Calibri" pitchFamily="34" charset="0"/>
+                <a:ea typeface="Calibri" pitchFamily="34" charset="-122"/>
+                <a:cs typeface="Calibri" pitchFamily="34" charset="-120"/>
+              </a:rPr>
+              <a:t>Generated commands can destroy data silently</a:t>
+            </a:r>
+            <a:endParaRPr lang="en-US" sz="1900" dirty="0"/>
+          </a:p>
+          <a:p>
+            <a:pPr algn="l" marL="342900" indent="-342900">
+              <a:spcAft>
+                <a:spcPts val="1600"/>
+              </a:spcAft>
+              <a:buSzPct val="100000"/>
+              <a:buChar char="▸"/>
+            </a:pPr>
+            <a:r>
+              <a:rPr lang="en-US" sz="1900" dirty="0">
+                <a:solidFill>
+                  <a:schemeClr val="bg1"/>
+                </a:solidFill>
+                <a:latin typeface="Calibri" pitchFamily="34" charset="0"/>
+                <a:ea typeface="Calibri" pitchFamily="34" charset="-122"/>
+                <a:cs typeface="Calibri" pitchFamily="34" charset="-120"/>
+              </a:rPr>
+              <a:t>Pattern lists judge a command by its name, not its effect</a:t>
+            </a:r>
+            <a:endParaRPr lang="en-US" sz="1900" dirty="0"/>
+          </a:p>
+          <a:p>
+            <a:pPr algn="l" marL="342900" indent="-342900">
+              <a:spcAft>
+                <a:spcPts val="1600"/>
+              </a:spcAft>
+              <a:buSzPct val="100000"/>
+              <a:buChar char="▸"/>
+            </a:pPr>
+            <a:r>
+              <a:rPr lang="en-US" sz="1900" dirty="0">
+                <a:solidFill>
+                  <a:schemeClr val="bg1"/>
+                </a:solidFill>
+                <a:latin typeface="Calibri" pitchFamily="34" charset="0"/>
+                <a:ea typeface="Calibri" pitchFamily="34" charset="-122"/>
+                <a:cs typeface="Calibri" pitchFamily="34" charset="-120"/>
+              </a:rPr>
+              <a:t>Binary choice today: unsafe (let it through) or useless (refuse everything)</a:t>
+            </a:r>
+            <a:endParaRPr lang="en-US" sz="1900" dirty="0"/>
+          </a:p>
+          <a:p>
+            <a:pPr algn="l" marL="342900" indent="-342900">
+              <a:spcAft>
+                <a:spcPts val="1600"/>
+              </a:spcAft>
+              <a:buSzPct val="100000"/>
+              <a:buChar char="▸"/>
+            </a:pPr>
+            <a:r>
+              <a:rPr lang="en-US" sz="1900" dirty="0">
+                <a:solidFill>
+                  <a:schemeClr val="bg1"/>
+                </a:solidFill>
+                <a:latin typeface="Calibri" pitchFamily="34" charset="0"/>
+                <a:ea typeface="Calibri" pitchFamily="34" charset="-122"/>
+                <a:cs typeface="Calibri" pitchFamily="34" charset="-120"/>
+              </a:rPr>
+              <a:t>Needed: know the command's actual effect before it runs</a:t>
+            </a:r>
+            <a:endParaRPr lang="en-US" sz="1900" dirty="0"/>
+          </a:p>
+        </p:txBody>
       </p:sp>
       <p:sp>
         <p:nvSpPr>
@@ -8160,8 +8873,8 @@
         </p:nvSpPr>
         <p:spPr>
           <a:xfrm>
-            <a:off x="777240" y="1508760"/>
-            <a:ext cx="4892040" cy="457200"/>
+            <a:off x="548640" y="5120640"/>
+            <a:ext cx="11064240" cy="548640"/>
           </a:xfrm>
           <a:prstGeom prst="rect">
             <a:avLst/>
@@ -8177,295 +8890,17 @@
               <a:buNone/>
             </a:pPr>
             <a:r>
-              <a:rPr lang="en-US" sz="1600" b="1" dirty="0">
-                <a:solidFill>
-                  <a:schemeClr val="accent1"/>
-                </a:solidFill>
-                <a:latin typeface="Courier New" pitchFamily="34" charset="0"/>
-                <a:ea typeface="Courier New" pitchFamily="34" charset="-122"/>
-                <a:cs typeface="Courier New" pitchFamily="34" charset="-120"/>
-              </a:rPr>
-              <a:t>Composition through wrappers</a:t>
-            </a:r>
-            <a:endParaRPr lang="en-US" sz="1600" dirty="0"/>
-          </a:p>
-        </p:txBody>
-      </p:sp>
-      <p:sp>
-        <p:nvSpPr>
-          <p:cNvPr id="5" name="Text 3"/>
-          <p:cNvSpPr txBox="1"/>
-          <p:nvPr/>
-        </p:nvSpPr>
-        <p:spPr>
-          <a:xfrm>
-            <a:off x="777240" y="2011680"/>
-            <a:ext cx="4892040" cy="1005840"/>
-          </a:xfrm>
-          <a:prstGeom prst="rect">
-            <a:avLst/>
-          </a:prstGeom>
-          <a:noFill/>
-          <a:ln/>
-        </p:spPr>
-        <p:txBody>
-          <a:bodyPr wrap="square" lIns="0" tIns="0" rIns="0" bIns="0" rtlCol="0" anchor="ctr"/>
-          <a:lstStyle/>
-          <a:p>
-            <a:pPr indent="0" marL="0">
-              <a:buNone/>
-            </a:pPr>
-            <a:r>
-              <a:rPr lang="en-US" sz="1500" dirty="0">
-                <a:solidFill>
-                  <a:schemeClr val="bg1"/>
+              <a:rPr lang="en-US" sz="1400" i="1" dirty="0">
+                <a:solidFill>
+                  <a:schemeClr val="bg2"/>
                 </a:solidFill>
                 <a:latin typeface="Calibri" pitchFamily="34" charset="0"/>
                 <a:ea typeface="Calibri" pitchFamily="34" charset="-122"/>
                 <a:cs typeface="Calibri" pitchFamily="34" charset="-120"/>
               </a:rPr>
-              <a:t>find -exec, xargs, loops, substitution, pipelines, sudo — earlier segments visible to later ones</a:t>
-            </a:r>
-            <a:endParaRPr lang="en-US" sz="1500" dirty="0"/>
-          </a:p>
-        </p:txBody>
-      </p:sp>
-      <p:sp>
-        <p:nvSpPr>
-          <p:cNvPr id="6" name="Shape 4"/>
-          <p:cNvSpPr/>
-          <p:nvPr/>
-        </p:nvSpPr>
-        <p:spPr>
-          <a:xfrm>
-            <a:off x="6172200" y="1371600"/>
-            <a:ext cx="5349240" cy="1691640"/>
-          </a:xfrm>
-          <a:prstGeom prst="roundRect">
-            <a:avLst>
-              <a:gd name="adj" fmla="val 4324"/>
-            </a:avLst>
-          </a:prstGeom>
-          <a:solidFill>
-            <a:srgbClr val="F3F4F6"/>
-          </a:solidFill>
-          <a:ln w="15240">
-            <a:solidFill>
-              <a:srgbClr val="1A7F37"/>
-            </a:solidFill>
-            <a:prstDash val="solid"/>
-          </a:ln>
-        </p:spPr>
-      </p:sp>
-      <p:sp>
-        <p:nvSpPr>
-          <p:cNvPr id="7" name="Text 5"/>
-          <p:cNvSpPr txBox="1"/>
-          <p:nvPr/>
-        </p:nvSpPr>
-        <p:spPr>
-          <a:xfrm>
-            <a:off x="6400800" y="1508760"/>
-            <a:ext cx="4892040" cy="457200"/>
-          </a:xfrm>
-          <a:prstGeom prst="rect">
-            <a:avLst/>
-          </a:prstGeom>
-          <a:noFill/>
-          <a:ln/>
-        </p:spPr>
-        <p:txBody>
-          <a:bodyPr wrap="square" lIns="0" tIns="0" rIns="0" bIns="0" rtlCol="0" anchor="ctr"/>
-          <a:lstStyle/>
-          <a:p>
-            <a:pPr indent="0" marL="0">
-              <a:buNone/>
-            </a:pPr>
-            <a:r>
-              <a:rPr lang="en-US" sz="1600" b="1" dirty="0">
-                <a:solidFill>
-                  <a:schemeClr val="accent1"/>
-                </a:solidFill>
-                <a:latin typeface="Courier New" pitchFamily="34" charset="0"/>
-                <a:ea typeface="Courier New" pitchFamily="34" charset="-122"/>
-                <a:cs typeface="Courier New" pitchFamily="34" charset="-120"/>
-              </a:rPr>
-              <a:t>Resolution of run-time targets</a:t>
-            </a:r>
-            <a:endParaRPr lang="en-US" sz="1600" dirty="0"/>
-          </a:p>
-        </p:txBody>
-      </p:sp>
-      <p:sp>
-        <p:nvSpPr>
-          <p:cNvPr id="8" name="Text 6"/>
-          <p:cNvSpPr txBox="1"/>
-          <p:nvPr/>
-        </p:nvSpPr>
-        <p:spPr>
-          <a:xfrm>
-            <a:off x="6400800" y="2011680"/>
-            <a:ext cx="4892040" cy="1005840"/>
-          </a:xfrm>
-          <a:prstGeom prst="rect">
-            <a:avLst/>
-          </a:prstGeom>
-          <a:noFill/>
-          <a:ln/>
-        </p:spPr>
-        <p:txBody>
-          <a:bodyPr wrap="square" lIns="0" tIns="0" rIns="0" bIns="0" rtlCol="0" anchor="ctr"/>
-          <a:lstStyle/>
-          <a:p>
-            <a:pPr indent="0" marL="0">
-              <a:buNone/>
-            </a:pPr>
-            <a:r>
-              <a:rPr lang="en-US" sz="1500" dirty="0">
-                <a:solidFill>
-                  <a:schemeClr val="bg1"/>
-                </a:solidFill>
-                <a:latin typeface="Calibri" pitchFamily="34" charset="0"/>
-                <a:ea typeface="Calibri" pitchFamily="34" charset="-122"/>
-                <a:cs typeface="Calibri" pitchFamily="34" charset="-120"/>
-              </a:rPr>
-              <a:t>Targets computed at run time (rm $(ls *.log), find -delete, xargs rm) resolved via a read-only dry run before execution</a:t>
-            </a:r>
-            <a:endParaRPr lang="en-US" sz="1500" dirty="0"/>
-          </a:p>
-        </p:txBody>
-      </p:sp>
-      <p:sp>
-        <p:nvSpPr>
-          <p:cNvPr id="9" name="Shape 7"/>
-          <p:cNvSpPr/>
-          <p:nvPr/>
-        </p:nvSpPr>
-        <p:spPr>
-          <a:xfrm>
-            <a:off x="548640" y="3246120"/>
-            <a:ext cx="10972800" cy="594360"/>
-          </a:xfrm>
-          <a:prstGeom prst="roundRect">
-            <a:avLst>
-              <a:gd name="adj" fmla="val 9231"/>
-            </a:avLst>
-          </a:prstGeom>
-          <a:solidFill>
-            <a:srgbClr val="F3F4F6"/>
-          </a:solidFill>
-          <a:ln w="12700">
-            <a:solidFill>
-              <a:srgbClr val="9A6700"/>
-            </a:solidFill>
-            <a:prstDash val="solid"/>
-          </a:ln>
-        </p:spPr>
-      </p:sp>
-      <p:sp>
-        <p:nvSpPr>
-          <p:cNvPr id="10" name="Text 8"/>
-          <p:cNvSpPr txBox="1"/>
-          <p:nvPr/>
-        </p:nvSpPr>
-        <p:spPr>
-          <a:xfrm>
-            <a:off x="822960" y="3246120"/>
-            <a:ext cx="10424160" cy="594360"/>
-          </a:xfrm>
-          <a:prstGeom prst="rect">
-            <a:avLst/>
-          </a:prstGeom>
-          <a:noFill/>
-          <a:ln/>
-        </p:spPr>
-        <p:txBody>
-          <a:bodyPr wrap="square" lIns="0" tIns="0" rIns="0" bIns="0" rtlCol="0" anchor="ctr"/>
-          <a:lstStyle/>
-          <a:p>
-            <a:pPr indent="0" marL="0">
-              <a:buNone/>
-            </a:pPr>
-            <a:r>
-              <a:rPr lang="en-US" sz="1500" b="1" dirty="0">
-                <a:solidFill>
-                  <a:schemeClr val="accent2"/>
-                </a:solidFill>
-                <a:latin typeface="Calibri" pitchFamily="34" charset="0"/>
-                <a:ea typeface="Calibri" pitchFamily="34" charset="-122"/>
-                <a:cs typeface="Calibri" pitchFamily="34" charset="-120"/>
-              </a:rPr>
-              <a:t>Deliberately narrow: </a:t>
-            </a:r>
-            <a:pPr indent="0" marL="0">
-              <a:buNone/>
-            </a:pPr>
-            <a:r>
-              <a:rPr lang="en-US" sz="1500" dirty="0">
-                <a:solidFill>
-                  <a:schemeClr val="bg1"/>
-                </a:solidFill>
-                <a:latin typeface="Calibri" pitchFamily="34" charset="0"/>
-                <a:ea typeface="Calibri" pitchFamily="34" charset="-122"/>
-                <a:cs typeface="Calibri" pitchFamily="34" charset="-120"/>
-              </a:rPr>
-              <a:t>unmodeled commands are unknown → fail closed, ask, capture nothing.</a:t>
-            </a:r>
-            <a:endParaRPr lang="en-US" sz="1500" dirty="0"/>
-          </a:p>
-        </p:txBody>
-      </p:sp>
-      <p:pic>
-        <p:nvPicPr>
-          <p:cNvPr id="11" name="Image 0" descr="media/safety-gate.png">    </p:cNvPr>
-          <p:cNvPicPr>
-            <a:picLocks noChangeAspect="1"/>
-          </p:cNvPicPr>
-          <p:nvPr/>
-        </p:nvPicPr>
-        <p:blipFill>
-          <a:blip r:embed="rId1"/>
-          <a:stretch>
-            <a:fillRect/>
-          </a:stretch>
-        </p:blipFill>
-        <p:spPr>
-          <a:xfrm>
-            <a:off x="2514600" y="3977640"/>
-            <a:ext cx="7132320" cy="2093976"/>
-          </a:xfrm>
-          <a:prstGeom prst="rect">
-            <a:avLst/>
-          </a:prstGeom>
-        </p:spPr>
-      </p:pic>
-      <p:sp>
-        <p:nvSpPr>
-          <p:cNvPr id="13" name="Text 0"/>
-          <p:cNvSpPr/>
-          <p:nvPr>
-            <p:ph idx="101" type="body" hasCustomPrompt="1"/>
-          </p:nvPr>
-        </p:nvSpPr>
-        <p:spPr>
-          <a:xfrm>
-            <a:off x="548640" y="1463040"/>
-            <a:ext cx="11064240" cy="4983480"/>
-          </a:xfrm>
-          <a:prstGeom prst="rect">
-            <a:avLst/>
-          </a:prstGeom>
-          <a:noFill/>
-          <a:ln/>
-        </p:spPr>
-        <p:txBody>
-          <a:bodyPr wrap="square" rtlCol="0" anchor="t"/>
-          <a:lstStyle/>
-          <a:p>
-            <a:pPr algn="l" indent="0" marL="0">
-              <a:buNone/>
-            </a:pPr>
-            <a:endParaRPr lang="en-US" sz="1900" dirty="0"/>
+              <a:t>The algorithm itself is real code in our repository, not a formula on paper — prototype/internal/effects.</a:t>
+            </a:r>
+            <a:endParaRPr lang="en-US" sz="1400" dirty="0"/>
           </a:p>
         </p:txBody>
       </p:sp>
@@ -8577,7 +9012,7 @@
                 <a:ea typeface="Courier New" pitchFamily="34" charset="-122"/>
                 <a:cs typeface="Courier New" pitchFamily="34" charset="-120"/>
               </a:rPr>
-              <a:t>Evaluation Design — Two Independent Studies</a:t>
+              <a:t>The Algorithm (RQ1) — What It Claims</a:t>
             </a:r>
             <a:endParaRPr lang="en-US" sz="3400" dirty="0"/>
           </a:p>
@@ -8591,16 +9026,16 @@
         </p:nvSpPr>
         <p:spPr>
           <a:xfrm>
-            <a:off x="548640" y="1554480"/>
-            <a:ext cx="5349240" cy="4297680"/>
+            <a:off x="548640" y="1371600"/>
+            <a:ext cx="5349240" cy="1691640"/>
           </a:xfrm>
           <a:prstGeom prst="roundRect">
             <a:avLst>
-              <a:gd name="adj" fmla="val 1702"/>
+              <a:gd name="adj" fmla="val 4324"/>
             </a:avLst>
           </a:prstGeom>
           <a:solidFill>
-            <a:srgbClr val="F3F4F6"/>
+            <a:srgbClr val="FFFFFF"/>
           </a:solidFill>
           <a:ln w="15240">
             <a:solidFill>
@@ -8618,8 +9053,8 @@
         </p:nvSpPr>
         <p:spPr>
           <a:xfrm>
-            <a:off x="822960" y="1783080"/>
-            <a:ext cx="4800600" cy="502920"/>
+            <a:off x="777240" y="1508760"/>
+            <a:ext cx="4892040" cy="457200"/>
           </a:xfrm>
           <a:prstGeom prst="rect">
             <a:avLst/>
@@ -8635,17 +9070,17 @@
               <a:buNone/>
             </a:pPr>
             <a:r>
-              <a:rPr lang="en-US" sz="1900" b="1" dirty="0">
-                <a:solidFill>
-                  <a:srgbClr val="1A7F37"/>
+              <a:rPr lang="en-US" sz="1600" b="1" dirty="0">
+                <a:solidFill>
+                  <a:schemeClr val="accent1"/>
                 </a:solidFill>
                 <a:latin typeface="Courier New" pitchFamily="34" charset="0"/>
                 <a:ea typeface="Courier New" pitchFamily="34" charset="-122"/>
                 <a:cs typeface="Courier New" pitchFamily="34" charset="-120"/>
               </a:rPr>
-              <a:t>Algorithm study (RQ1)</a:t>
-            </a:r>
-            <a:endParaRPr lang="en-US" sz="1900" dirty="0"/>
+              <a:t>Composition through wrappers</a:t>
+            </a:r>
+            <a:endParaRPr lang="en-US" sz="1600" dirty="0"/>
           </a:p>
         </p:txBody>
       </p:sp>
@@ -8657,8 +9092,8 @@
         </p:nvSpPr>
         <p:spPr>
           <a:xfrm>
-            <a:off x="822960" y="2377440"/>
-            <a:ext cx="4800600" cy="3383280"/>
+            <a:off x="777240" y="2011680"/>
+            <a:ext cx="4892040" cy="1005840"/>
           </a:xfrm>
           <a:prstGeom prst="rect">
             <a:avLst/>
@@ -8670,76 +9105,21 @@
           <a:bodyPr wrap="square" lIns="0" tIns="0" rIns="0" bIns="0" rtlCol="0" anchor="ctr"/>
           <a:lstStyle/>
           <a:p>
-            <a:pPr marL="342900" indent="-342900">
-              <a:spcAft>
-                <a:spcPts val="1200"/>
-              </a:spcAft>
-              <a:buSzPct val="100000"/>
-              <a:buChar char="▸"/>
-            </a:pPr>
-            <a:r>
-              <a:rPr lang="en-US" sz="1600" dirty="0">
+            <a:pPr indent="0" marL="0">
+              <a:buNone/>
+            </a:pPr>
+            <a:r>
+              <a:rPr lang="en-US" sz="1500" dirty="0">
                 <a:solidFill>
                   <a:schemeClr val="bg1"/>
                 </a:solidFill>
-              </a:rPr>
-              <a:t>Corpus-based — no participants</a:t>
-            </a:r>
-            <a:endParaRPr lang="en-US" sz="1600" dirty="0"/>
-          </a:p>
-          <a:p>
-            <a:pPr marL="342900" indent="-342900">
-              <a:spcAft>
-                <a:spcPts val="1200"/>
-              </a:spcAft>
-              <a:buSzPct val="100000"/>
-              <a:buChar char="▸"/>
-            </a:pPr>
-            <a:r>
-              <a:rPr lang="en-US" sz="1600" dirty="0">
-                <a:solidFill>
-                  <a:schemeClr val="bg1"/>
-                </a:solidFill>
-              </a:rPr>
-              <a:t>Held-out commands, sandboxed ground truth</a:t>
-            </a:r>
-            <a:endParaRPr lang="en-US" sz="1600" dirty="0"/>
-          </a:p>
-          <a:p>
-            <a:pPr marL="342900" indent="-342900">
-              <a:spcAft>
-                <a:spcPts val="1200"/>
-              </a:spcAft>
-              <a:buSzPct val="100000"/>
-              <a:buChar char="▸"/>
-            </a:pPr>
-            <a:r>
-              <a:rPr lang="en-US" sz="1600" dirty="0">
-                <a:solidFill>
-                  <a:schemeClr val="bg1"/>
-                </a:solidFill>
-              </a:rPr>
-              <a:t>Three baselines: pattern list, fail-closed list, algorithm</a:t>
-            </a:r>
-            <a:endParaRPr lang="en-US" sz="1600" dirty="0"/>
-          </a:p>
-          <a:p>
-            <a:pPr marL="342900" indent="-342900">
-              <a:spcAft>
-                <a:spcPts val="1200"/>
-              </a:spcAft>
-              <a:buSzPct val="100000"/>
-              <a:buChar char="▸"/>
-            </a:pPr>
-            <a:r>
-              <a:rPr lang="en-US" sz="1600" dirty="0">
-                <a:solidFill>
-                  <a:schemeClr val="bg1"/>
-                </a:solidFill>
-              </a:rPr>
-              <a:t>Answers RQ1 independently</a:t>
-            </a:r>
-            <a:endParaRPr lang="en-US" sz="1600" dirty="0"/>
+                <a:latin typeface="Calibri" pitchFamily="34" charset="0"/>
+                <a:ea typeface="Calibri" pitchFamily="34" charset="-122"/>
+                <a:cs typeface="Calibri" pitchFamily="34" charset="-120"/>
+              </a:rPr>
+              <a:t>find -exec, xargs, loops, substitution, pipelines, sudo — earlier segments visible to later ones</a:t>
+            </a:r>
+            <a:endParaRPr lang="en-US" sz="1500" dirty="0"/>
           </a:p>
         </p:txBody>
       </p:sp>
@@ -8751,20 +9131,20 @@
         </p:nvSpPr>
         <p:spPr>
           <a:xfrm>
-            <a:off x="6172200" y="1554480"/>
-            <a:ext cx="5349240" cy="4297680"/>
+            <a:off x="6172200" y="1371600"/>
+            <a:ext cx="5349240" cy="1691640"/>
           </a:xfrm>
           <a:prstGeom prst="roundRect">
             <a:avLst>
-              <a:gd name="adj" fmla="val 1702"/>
+              <a:gd name="adj" fmla="val 4324"/>
             </a:avLst>
           </a:prstGeom>
           <a:solidFill>
-            <a:srgbClr val="F3F4F6"/>
+            <a:srgbClr val="FFFFFF"/>
           </a:solidFill>
           <a:ln w="15240">
             <a:solidFill>
-              <a:srgbClr val="0969DA"/>
+              <a:srgbClr val="1A7F37"/>
             </a:solidFill>
             <a:prstDash val="solid"/>
           </a:ln>
@@ -8778,8 +9158,8 @@
         </p:nvSpPr>
         <p:spPr>
           <a:xfrm>
-            <a:off x="6446520" y="1783080"/>
-            <a:ext cx="4800600" cy="502920"/>
+            <a:off x="6400800" y="1508760"/>
+            <a:ext cx="4892040" cy="457200"/>
           </a:xfrm>
           <a:prstGeom prst="rect">
             <a:avLst/>
@@ -8795,17 +9175,17 @@
               <a:buNone/>
             </a:pPr>
             <a:r>
-              <a:rPr lang="en-US" sz="1900" b="1" dirty="0">
-                <a:solidFill>
-                  <a:srgbClr val="0969DA"/>
+              <a:rPr lang="en-US" sz="1600" b="1" dirty="0">
+                <a:solidFill>
+                  <a:schemeClr val="accent1"/>
                 </a:solidFill>
                 <a:latin typeface="Courier New" pitchFamily="34" charset="0"/>
                 <a:ea typeface="Courier New" pitchFamily="34" charset="-122"/>
                 <a:cs typeface="Courier New" pitchFamily="34" charset="-120"/>
               </a:rPr>
-              <a:t>User study (RQ2–4)</a:t>
-            </a:r>
-            <a:endParaRPr lang="en-US" sz="1900" dirty="0"/>
+              <a:t>Resolution of run-time targets</a:t>
+            </a:r>
+            <a:endParaRPr lang="en-US" sz="1600" dirty="0"/>
           </a:p>
         </p:txBody>
       </p:sp>
@@ -8817,8 +9197,8 @@
         </p:nvSpPr>
         <p:spPr>
           <a:xfrm>
-            <a:off x="6446520" y="2377440"/>
-            <a:ext cx="4800600" cy="3383280"/>
+            <a:off x="6400800" y="2011680"/>
+            <a:ext cx="4892040" cy="1005840"/>
           </a:xfrm>
           <a:prstGeom prst="rect">
             <a:avLst/>
@@ -8830,82 +9210,131 @@
           <a:bodyPr wrap="square" lIns="0" tIns="0" rIns="0" bIns="0" rtlCol="0" anchor="ctr"/>
           <a:lstStyle/>
           <a:p>
-            <a:pPr marL="342900" indent="-342900">
-              <a:spcAft>
-                <a:spcPts val="1200"/>
-              </a:spcAft>
-              <a:buSzPct val="100000"/>
-              <a:buChar char="▸"/>
-            </a:pPr>
-            <a:r>
-              <a:rPr lang="en-US" sz="1600" dirty="0">
+            <a:pPr indent="0" marL="0">
+              <a:buNone/>
+            </a:pPr>
+            <a:r>
+              <a:rPr lang="en-US" sz="1500" dirty="0">
                 <a:solidFill>
                   <a:schemeClr val="bg1"/>
                 </a:solidFill>
-              </a:rPr>
-              <a:t>40 participants, within-subjects</a:t>
-            </a:r>
-            <a:endParaRPr lang="en-US" sz="1600" dirty="0"/>
-          </a:p>
-          <a:p>
-            <a:pPr marL="342900" indent="-342900">
-              <a:spcAft>
-                <a:spcPts val="1200"/>
-              </a:spcAft>
-              <a:buSzPct val="100000"/>
-              <a:buChar char="▸"/>
-            </a:pPr>
-            <a:r>
-              <a:rPr lang="en-US" sz="1600" dirty="0">
+                <a:latin typeface="Calibri" pitchFamily="34" charset="0"/>
+                <a:ea typeface="Calibri" pitchFamily="34" charset="-122"/>
+                <a:cs typeface="Calibri" pitchFamily="34" charset="-120"/>
+              </a:rPr>
+              <a:t>Targets computed at run time (rm $(ls *.log), find -delete, xargs rm) resolved via a read-only dry run before execution</a:t>
+            </a:r>
+            <a:endParaRPr lang="en-US" sz="1500" dirty="0"/>
+          </a:p>
+        </p:txBody>
+      </p:sp>
+      <p:sp>
+        <p:nvSpPr>
+          <p:cNvPr id="9" name="Shape 7"/>
+          <p:cNvSpPr/>
+          <p:nvPr/>
+        </p:nvSpPr>
+        <p:spPr>
+          <a:xfrm>
+            <a:off x="548640" y="3246120"/>
+            <a:ext cx="10972800" cy="594360"/>
+          </a:xfrm>
+          <a:prstGeom prst="roundRect">
+            <a:avLst>
+              <a:gd name="adj" fmla="val 9231"/>
+            </a:avLst>
+          </a:prstGeom>
+          <a:solidFill>
+            <a:srgbClr val="FFFFFF"/>
+          </a:solidFill>
+          <a:ln w="12700">
+            <a:solidFill>
+              <a:srgbClr val="9A6700"/>
+            </a:solidFill>
+            <a:prstDash val="solid"/>
+          </a:ln>
+        </p:spPr>
+      </p:sp>
+      <p:sp>
+        <p:nvSpPr>
+          <p:cNvPr id="10" name="Text 8"/>
+          <p:cNvSpPr txBox="1"/>
+          <p:nvPr/>
+        </p:nvSpPr>
+        <p:spPr>
+          <a:xfrm>
+            <a:off x="822960" y="3246120"/>
+            <a:ext cx="10424160" cy="594360"/>
+          </a:xfrm>
+          <a:prstGeom prst="rect">
+            <a:avLst/>
+          </a:prstGeom>
+          <a:noFill/>
+          <a:ln/>
+        </p:spPr>
+        <p:txBody>
+          <a:bodyPr wrap="square" lIns="0" tIns="0" rIns="0" bIns="0" rtlCol="0" anchor="ctr"/>
+          <a:lstStyle/>
+          <a:p>
+            <a:pPr indent="0" marL="0">
+              <a:buNone/>
+            </a:pPr>
+            <a:r>
+              <a:rPr lang="en-US" sz="1500" b="1" dirty="0">
+                <a:solidFill>
+                  <a:schemeClr val="accent2"/>
+                </a:solidFill>
+                <a:latin typeface="Calibri" pitchFamily="34" charset="0"/>
+                <a:ea typeface="Calibri" pitchFamily="34" charset="-122"/>
+                <a:cs typeface="Calibri" pitchFamily="34" charset="-120"/>
+              </a:rPr>
+              <a:t>Deliberately narrow: </a:t>
+            </a:r>
+            <a:pPr indent="0" marL="0">
+              <a:buNone/>
+            </a:pPr>
+            <a:r>
+              <a:rPr lang="en-US" sz="1500" dirty="0">
                 <a:solidFill>
                   <a:schemeClr val="bg1"/>
                 </a:solidFill>
-              </a:rPr>
-              <a:t>Each person vs. their own daily OS</a:t>
-            </a:r>
-            <a:endParaRPr lang="en-US" sz="1600" dirty="0"/>
-          </a:p>
-          <a:p>
-            <a:pPr marL="342900" indent="-342900">
-              <a:spcAft>
-                <a:spcPts val="1200"/>
-              </a:spcAft>
-              <a:buSzPct val="100000"/>
-              <a:buChar char="▸"/>
-            </a:pPr>
-            <a:r>
-              <a:rPr lang="en-US" sz="1600" dirty="0">
-                <a:solidFill>
-                  <a:schemeClr val="bg1"/>
-                </a:solidFill>
-              </a:rPr>
-              <a:t>OSWorld + custom cross-platform task suite</a:t>
-            </a:r>
-            <a:endParaRPr lang="en-US" sz="1600" dirty="0"/>
-          </a:p>
-          <a:p>
-            <a:pPr marL="342900" indent="-342900">
-              <a:spcAft>
-                <a:spcPts val="1200"/>
-              </a:spcAft>
-              <a:buSzPct val="100000"/>
-              <a:buChar char="▸"/>
-            </a:pPr>
-            <a:r>
-              <a:rPr lang="en-US" sz="1600" dirty="0">
-                <a:solidFill>
-                  <a:schemeClr val="bg1"/>
-                </a:solidFill>
-              </a:rPr>
-              <a:t>Awaiting clearance to begin</a:t>
-            </a:r>
-            <a:endParaRPr lang="en-US" sz="1600" dirty="0"/>
-          </a:p>
-        </p:txBody>
-      </p:sp>
-      <p:sp>
-        <p:nvSpPr>
-          <p:cNvPr id="10" name="Text 0"/>
+                <a:latin typeface="Calibri" pitchFamily="34" charset="0"/>
+                <a:ea typeface="Calibri" pitchFamily="34" charset="-122"/>
+                <a:cs typeface="Calibri" pitchFamily="34" charset="-120"/>
+              </a:rPr>
+              <a:t>unmodeled commands are unknown → fail closed, ask, capture nothing.</a:t>
+            </a:r>
+            <a:endParaRPr lang="en-US" sz="1500" dirty="0"/>
+          </a:p>
+        </p:txBody>
+      </p:sp>
+      <p:pic>
+        <p:nvPicPr>
+          <p:cNvPr id="11" name="Image 0" descr="media/safety-gate.png">    </p:cNvPr>
+          <p:cNvPicPr>
+            <a:picLocks noChangeAspect="1"/>
+          </p:cNvPicPr>
+          <p:nvPr/>
+        </p:nvPicPr>
+        <p:blipFill>
+          <a:blip r:embed="rId1"/>
+          <a:stretch>
+            <a:fillRect/>
+          </a:stretch>
+        </p:blipFill>
+        <p:spPr>
+          <a:xfrm>
+            <a:off x="2514600" y="3977640"/>
+            <a:ext cx="7132320" cy="2093976"/>
+          </a:xfrm>
+          <a:prstGeom prst="rect">
+            <a:avLst/>
+          </a:prstGeom>
+        </p:spPr>
+      </p:pic>
+      <p:sp>
+        <p:nvSpPr>
+          <p:cNvPr id="13" name="Text 0"/>
           <p:cNvSpPr/>
           <p:nvPr>
             <p:ph idx="101" type="body" hasCustomPrompt="1"/>
@@ -8994,13 +9423,13 @@
   <a:themeElements>
     <a:clrScheme name="SynapseOS Light">
       <a:dk1>
-        <a:srgbClr val="FFFFFF"/>
+        <a:srgbClr val="F6F8FA"/>
       </a:dk1>
       <a:lt1>
         <a:srgbClr val="1A1F26"/>
       </a:lt1>
       <a:dk2>
-        <a:srgbClr val="F3F4F6"/>
+        <a:srgbClr val="FFFFFF"/>
       </a:dk2>
       <a:lt2>
         <a:srgbClr val="57606A"/>

</xml_diff>

<commit_message>
docs(defense): phrase slide 4's research questions as actual questions
Bullets were fragments ("Predict a command's effects...") on a slide
titled "Research Questions" - now each one is an actual question with
a question mark, matching the title.
</commit_message>
<xml_diff>
--- a/thesis 1/defense/SynapseOS_Proposal_Defense.pptx
+++ b/thesis 1/defense/SynapseOS_Proposal_Defense.pptx
@@ -7316,7 +7316,7 @@
                 <a:ea typeface="Calibri" pitchFamily="34" charset="-122"/>
                 <a:cs typeface="Calibri" pitchFamily="34" charset="-120"/>
               </a:rPr>
-              <a:t>RQ1 — Predict a command's effects before it runs; capture enough to undo it; beat a pattern list</a:t>
+              <a:t>RQ1 — Can we predict a command's effects before it runs — and undo it — better than a pattern list?</a:t>
             </a:r>
             <a:endParaRPr lang="en-US" sz="1900" dirty="0"/>
           </a:p>
@@ -7337,7 +7337,7 @@
                 <a:ea typeface="Calibri" pitchFamily="34" charset="-122"/>
                 <a:cs typeface="Calibri" pitchFamily="34" charset="-120"/>
               </a:rPr>
-              <a:t>RQ2 — Direct a full desktop in ordinary language</a:t>
+              <a:t>RQ2 — How do we let someone direct a whole desktop in ordinary language?</a:t>
             </a:r>
             <a:endParaRPr lang="en-US" sz="1900" dirty="0"/>
           </a:p>
@@ -7358,7 +7358,7 @@
                 <a:ea typeface="Calibri" pitchFamily="34" charset="-122"/>
                 <a:cs typeface="Calibri" pitchFamily="34" charset="-120"/>
               </a:rPr>
-              <a:t>RQ3 — Confirm and recover from mistakes, including ones the user approved</a:t>
+              <a:t>RQ3 — What confirmation and recovery design lets someone undo a mistake, even one they approved?</a:t>
             </a:r>
             <a:endParaRPr lang="en-US" sz="1900" dirty="0"/>
           </a:p>
@@ -7379,7 +7379,7 @@
                 <a:ea typeface="Calibri" pitchFamily="34" charset="-122"/>
                 <a:cs typeface="Calibri" pitchFamily="34" charset="-120"/>
               </a:rPr>
-              <a:t>RQ4 — Narrow the fluency gap between CLI and GUI non-experts</a:t>
+              <a:t>RQ4 — Does this close the fluency gap between people fluent in neither the command line nor a GUI?</a:t>
             </a:r>
             <a:endParaRPr lang="en-US" sz="1900" dirty="0"/>
           </a:p>

</xml_diff>